<commit_message>
docs(p20): ingest verified p18 evidence into working deck
</commit_message>
<xml_diff>
--- a/outputs/presentation/AegisInspect_P20_working_draft.pptx
+++ b/outputs/presentation/AegisInspect_P20_working_draft.pptx
@@ -521,7 +521,7 @@
               <a:rPr lang="en-US" dirty="0"/>
               <a:t>WORKING DRAFT
 Assembly source: docs/presentation/assembly/slide_content.md
-Assembly SHA-256: c316a7315525aa56970d24f118f4dda0dc2d84e39941643d73e7fd3241122ffe
+Assembly SHA-256: 76829ec39dff392479c4db9b50683b24143c96080f5eeef56148a6cf06412415
 Title and capability boundary derived from assembly source.</a:t>
             </a:r>
             <a:endParaRPr lang="en-US" dirty="0"/>
@@ -612,7 +612,7 @@
               <a:rPr lang="en-US" dirty="0"/>
               <a:t>WORKING DRAFT
 Assembly source: docs/presentation/assembly/slide_content.md
-Assembly SHA-256: c316a7315525aa56970d24f118f4dda0dc2d84e39941643d73e7fd3241122ffe
+Assembly SHA-256: 76829ec39dff392479c4db9b50683b24143c96080f5eeef56148a6cf06412415
 Verified inspection_2026091901.md and P17 report SHA-256.</a:t>
             </a:r>
             <a:endParaRPr lang="en-US" dirty="0"/>
@@ -703,8 +703,8 @@
               <a:rPr lang="en-US" dirty="0"/>
               <a:t>WORKING DRAFT
 Assembly source: docs/presentation/assembly/slide_content.md
-Assembly SHA-256: c316a7315525aa56970d24f118f4dda0dc2d84e39941643d73e7fd3241122ffe
-Assembly P18 statement only.</a:t>
+Assembly SHA-256: 76829ec39dff392479c4db9b50683b24143c96080f5eeef56148a6cf06412415
+Verified P18 dashboard-completion package; first retry limitation retained.</a:t>
             </a:r>
             <a:endParaRPr lang="en-US" dirty="0"/>
           </a:p>
@@ -794,8 +794,8 @@
               <a:rPr lang="en-US" dirty="0"/>
               <a:t>WORKING DRAFT
 Assembly source: docs/presentation/assembly/slide_content.md
-Assembly SHA-256: c316a7315525aa56970d24f118f4dda0dc2d84e39941643d73e7fd3241122ffe
-Assembly P18 statement only.</a:t>
+Assembly SHA-256: 76829ec39dff392479c4db9b50683b24143c96080f5eeef56148a6cf06412415
+Verified clean-repeatability package.</a:t>
             </a:r>
             <a:endParaRPr lang="en-US" dirty="0"/>
           </a:p>
@@ -885,7 +885,7 @@
               <a:rPr lang="en-US" dirty="0"/>
               <a:t>WORKING DRAFT
 Assembly source: docs/presentation/assembly/slide_content.md
-Assembly SHA-256: c316a7315525aa56970d24f118f4dda0dc2d84e39941643d73e7fd3241122ffe
+Assembly SHA-256: 76829ec39dff392479c4db9b50683b24143c96080f5eeef56148a6cf06412415
 Accepted P19 metrics represented in assembly source.</a:t>
             </a:r>
             <a:endParaRPr lang="en-US" dirty="0"/>
@@ -976,7 +976,7 @@
               <a:rPr lang="en-US" dirty="0"/>
               <a:t>WORKING DRAFT
 Assembly source: docs/presentation/assembly/slide_content.md
-Assembly SHA-256: c316a7315525aa56970d24f118f4dda0dc2d84e39941643d73e7fd3241122ffe
+Assembly SHA-256: 76829ec39dff392479c4db9b50683b24143c96080f5eeef56148a6cf06412415
 Assembly P19 3D pending boundary.</a:t>
             </a:r>
             <a:endParaRPr lang="en-US" dirty="0"/>
@@ -1067,7 +1067,7 @@
               <a:rPr lang="en-US" dirty="0"/>
               <a:t>WORKING DRAFT
 Assembly source: docs/presentation/assembly/slide_content.md
-Assembly SHA-256: c316a7315525aa56970d24f118f4dda0dc2d84e39941643d73e7fd3241122ffe
+Assembly SHA-256: 76829ec39dff392479c4db9b50683b24143c96080f5eeef56148a6cf06412415
 Assembly Workstream 04 pending statement.</a:t>
             </a:r>
             <a:endParaRPr lang="en-US" dirty="0"/>
@@ -1158,7 +1158,7 @@
               <a:rPr lang="en-US" dirty="0"/>
               <a:t>WORKING DRAFT
 Assembly source: docs/presentation/assembly/slide_content.md
-Assembly SHA-256: c316a7315525aa56970d24f118f4dda0dc2d84e39941643d73e7fd3241122ffe
+Assembly SHA-256: 76829ec39dff392479c4db9b50683b24143c96080f5eeef56148a6cf06412415
 Assembly section 18 and verified P16/P17 package.</a:t>
             </a:r>
             <a:endParaRPr lang="en-US" dirty="0"/>
@@ -1249,7 +1249,7 @@
               <a:rPr lang="en-US" dirty="0"/>
               <a:t>WORKING DRAFT
 Assembly source: docs/presentation/assembly/slide_content.md
-Assembly SHA-256: c316a7315525aa56970d24f118f4dda0dc2d84e39941643d73e7fd3241122ffe
+Assembly SHA-256: 76829ec39dff392479c4db9b50683b24143c96080f5eeef56148a6cf06412415
 Assembly section 15.</a:t>
             </a:r>
             <a:endParaRPr lang="en-US" dirty="0"/>
@@ -1340,7 +1340,7 @@
               <a:rPr lang="en-US" dirty="0"/>
               <a:t>WORKING DRAFT
 Assembly source: docs/presentation/assembly/slide_content.md
-Assembly SHA-256: c316a7315525aa56970d24f118f4dda0dc2d84e39941643d73e7fd3241122ffe
+Assembly SHA-256: 76829ec39dff392479c4db9b50683b24143c96080f5eeef56148a6cf06412415
 Assembly section 17.</a:t>
             </a:r>
             <a:endParaRPr lang="en-US" dirty="0"/>
@@ -1431,8 +1431,8 @@
               <a:rPr lang="en-US" dirty="0"/>
               <a:t>WORKING DRAFT
 Assembly source: docs/presentation/assembly/slide_content.md
-Assembly SHA-256: c316a7315525aa56970d24f118f4dda0dc2d84e39941643d73e7fd3241122ffe
-Assembly sections 1–2.</a:t>
+Assembly SHA-256: 76829ec39dff392479c4db9b50683b24143c96080f5eeef56148a6cf06412415
+Assembly sections 1-2.</a:t>
             </a:r>
             <a:endParaRPr lang="en-US" dirty="0"/>
           </a:p>
@@ -1522,7 +1522,7 @@
               <a:rPr lang="en-US" dirty="0"/>
               <a:t>WORKING DRAFT
 Assembly source: docs/presentation/assembly/slide_content.md
-Assembly SHA-256: c316a7315525aa56970d24f118f4dda0dc2d84e39941643d73e7fd3241122ffe
+Assembly SHA-256: 76829ec39dff392479c4db9b50683b24143c96080f5eeef56148a6cf06412415
 Assembly section 3.</a:t>
             </a:r>
             <a:endParaRPr lang="en-US" dirty="0"/>
@@ -1613,7 +1613,7 @@
               <a:rPr lang="en-US" dirty="0"/>
               <a:t>WORKING DRAFT
 Assembly source: docs/presentation/assembly/slide_content.md
-Assembly SHA-256: c316a7315525aa56970d24f118f4dda0dc2d84e39941643d73e7fd3241122ffe
+Assembly SHA-256: 76829ec39dff392479c4db9b50683b24143c96080f5eeef56148a6cf06412415
 Assembly section 4.</a:t>
             </a:r>
             <a:endParaRPr lang="en-US" dirty="0"/>
@@ -1704,8 +1704,8 @@
               <a:rPr lang="en-US" dirty="0"/>
               <a:t>WORKING DRAFT
 Assembly source: docs/presentation/assembly/slide_content.md
-Assembly SHA-256: c316a7315525aa56970d24f118f4dda0dc2d84e39941643d73e7fd3241122ffe
-Assembly sections 5–6.</a:t>
+Assembly SHA-256: 76829ec39dff392479c4db9b50683b24143c96080f5eeef56148a6cf06412415
+Assembly sections 5-6.</a:t>
             </a:r>
             <a:endParaRPr lang="en-US" dirty="0"/>
           </a:p>
@@ -1795,7 +1795,7 @@
               <a:rPr lang="en-US" dirty="0"/>
               <a:t>WORKING DRAFT
 Assembly source: docs/presentation/assembly/slide_content.md
-Assembly SHA-256: c316a7315525aa56970d24f118f4dda0dc2d84e39941643d73e7fd3241122ffe
+Assembly SHA-256: 76829ec39dff392479c4db9b50683b24143c96080f5eeef56148a6cf06412415
 Assembly sections 8 and insertable P19 status.</a:t>
             </a:r>
             <a:endParaRPr lang="en-US" dirty="0"/>
@@ -1886,8 +1886,8 @@
               <a:rPr lang="en-US" dirty="0"/>
               <a:t>WORKING DRAFT
 Assembly source: docs/presentation/assembly/slide_content.md
-Assembly SHA-256: c316a7315525aa56970d24f118f4dda0dc2d84e39941643d73e7fd3241122ffe
-Assembly sections 9–10.</a:t>
+Assembly SHA-256: 76829ec39dff392479c4db9b50683b24143c96080f5eeef56148a6cf06412415
+Assembly sections 9-10.</a:t>
             </a:r>
             <a:endParaRPr lang="en-US" dirty="0"/>
           </a:p>
@@ -1977,7 +1977,7 @@
               <a:rPr lang="en-US" dirty="0"/>
               <a:t>WORKING DRAFT
 Assembly source: docs/presentation/assembly/slide_content.md
-Assembly SHA-256: c316a7315525aa56970d24f118f4dda0dc2d84e39941643d73e7fd3241122ffe
+Assembly SHA-256: 76829ec39dff392479c4db9b50683b24143c96080f5eeef56148a6cf06412415
 Assembly section 11 and verified P16/P17 lineage.</a:t>
             </a:r>
             <a:endParaRPr lang="en-US" dirty="0"/>
@@ -2068,7 +2068,7 @@
               <a:rPr lang="en-US" dirty="0"/>
               <a:t>WORKING DRAFT
 Assembly source: docs/presentation/assembly/slide_content.md
-Assembly SHA-256: c316a7315525aa56970d24f118f4dda0dc2d84e39941643d73e7fd3241122ffe
+Assembly SHA-256: 76829ec39dff392479c4db9b50683b24143c96080f5eeef56148a6cf06412415
 Verified dashboard_overview.png; P16/P17 package hash inventory 29/29.</a:t>
             </a:r>
             <a:endParaRPr lang="en-US" dirty="0"/>
@@ -3667,7 +3667,7 @@
         <p:spPr>
           <a:xfrm>
             <a:off x="493776" y="1188720"/>
-            <a:ext cx="5093208" cy="274320"/>
+            <a:ext cx="5212080" cy="274320"/>
           </a:xfrm>
           <a:prstGeom prst="roundRect">
             <a:avLst>
@@ -3675,11 +3675,11 @@
             </a:avLst>
           </a:prstGeom>
           <a:solidFill>
-            <a:srgbClr val="D97706"/>
+            <a:srgbClr val="00796B"/>
           </a:solidFill>
           <a:ln w="12700">
             <a:solidFill>
-              <a:srgbClr val="D97706"/>
+              <a:srgbClr val="00796B"/>
             </a:solidFill>
             <a:prstDash val="solid"/>
           </a:ln>
@@ -3694,7 +3694,7 @@
         <p:spPr>
           <a:xfrm>
             <a:off x="603504" y="1261872"/>
-            <a:ext cx="4892040" cy="91440"/>
+            <a:ext cx="5010912" cy="91440"/>
           </a:xfrm>
           <a:prstGeom prst="rect">
             <a:avLst/>
@@ -3720,22 +3720,220 @@
                 <a:ea typeface="Aptos" pitchFamily="34" charset="-122"/>
                 <a:cs typeface="Aptos" pitchFamily="34" charset="-120"/>
               </a:rPr>
-              <a:t>PENDING / PRESENTATION ASSETS</a:t>
+              <a:t>DEMONSTRATED / VERIFIED PACKAGE</a:t>
             </a:r>
             <a:endParaRPr lang="en-US" sz="750" dirty="0"/>
           </a:p>
         </p:txBody>
       </p:sp>
-      <p:sp>
-        <p:nvSpPr>
-          <p:cNvPr id="7" name="Text 5"/>
-          <p:cNvSpPr/>
-          <p:nvPr/>
-        </p:nvSpPr>
-        <p:spPr>
-          <a:xfrm>
-            <a:off x="960120" y="1920240"/>
-            <a:ext cx="10149840" cy="640080"/>
+      <p:pic>
+        <p:nvPicPr>
+          <p:cNvPr id="7" name="Image 0" descr="C:\Users\Aritra\Documents\aegisinspect-p20-deck-draft\outputs\presentation\p18_evidence\dashboard\dashboard_completion_overview_final.png">    </p:cNvPr>
+          <p:cNvPicPr>
+            <a:picLocks noChangeAspect="1"/>
+          </p:cNvPicPr>
+          <p:nvPr/>
+        </p:nvPicPr>
+        <p:blipFill>
+          <a:blip r:embed="rId1"/>
+          <a:srcRect l="0" r="0" t="0" b="0"/>
+          <a:stretch/>
+        </p:blipFill>
+        <p:spPr>
+          <a:xfrm>
+            <a:off x="594360" y="1572768"/>
+            <a:ext cx="6675120" cy="4343400"/>
+          </a:xfrm>
+          <a:prstGeom prst="rect">
+            <a:avLst/>
+          </a:prstGeom>
+        </p:spPr>
+      </p:pic>
+      <p:sp>
+        <p:nvSpPr>
+          <p:cNvPr id="8" name="Shape 5"/>
+          <p:cNvSpPr/>
+          <p:nvPr/>
+        </p:nvSpPr>
+        <p:spPr>
+          <a:xfrm>
+            <a:off x="7635240" y="1755648"/>
+            <a:ext cx="3291840" cy="1024128"/>
+          </a:xfrm>
+          <a:prstGeom prst="roundRect">
+            <a:avLst>
+              <a:gd name="adj" fmla="val 4464"/>
+            </a:avLst>
+          </a:prstGeom>
+          <a:solidFill>
+            <a:srgbClr val="F3F7FA"/>
+          </a:solidFill>
+          <a:ln w="7620">
+            <a:solidFill>
+              <a:srgbClr val="DCE6ED"/>
+            </a:solidFill>
+            <a:prstDash val="solid"/>
+          </a:ln>
+        </p:spPr>
+      </p:sp>
+      <p:sp>
+        <p:nvSpPr>
+          <p:cNvPr id="9" name="Shape 6"/>
+          <p:cNvSpPr/>
+          <p:nvPr/>
+        </p:nvSpPr>
+        <p:spPr>
+          <a:xfrm>
+            <a:off x="7635240" y="1755648"/>
+            <a:ext cx="73152" cy="1024128"/>
+          </a:xfrm>
+          <a:prstGeom prst="rect">
+            <a:avLst/>
+          </a:prstGeom>
+          <a:solidFill>
+            <a:srgbClr val="00796B"/>
+          </a:solidFill>
+          <a:ln w="12700">
+            <a:solidFill>
+              <a:srgbClr val="00796B"/>
+            </a:solidFill>
+            <a:prstDash val="solid"/>
+          </a:ln>
+        </p:spPr>
+      </p:sp>
+      <p:sp>
+        <p:nvSpPr>
+          <p:cNvPr id="10" name="Text 7"/>
+          <p:cNvSpPr/>
+          <p:nvPr/>
+        </p:nvSpPr>
+        <p:spPr>
+          <a:xfrm>
+            <a:off x="7836408" y="1911096"/>
+            <a:ext cx="2980944" cy="146304"/>
+          </a:xfrm>
+          <a:prstGeom prst="rect">
+            <a:avLst/>
+          </a:prstGeom>
+          <a:noFill/>
+          <a:ln/>
+        </p:spPr>
+        <p:txBody>
+          <a:bodyPr wrap="square" lIns="0" tIns="0" rIns="0" bIns="0" rtlCol="0" anchor="ctr">
+            <a:normAutofit/>
+          </a:bodyPr>
+          <a:lstStyle/>
+          <a:p>
+            <a:pPr indent="0" marL="0">
+              <a:buNone/>
+            </a:pPr>
+            <a:r>
+              <a:rPr lang="en-US" sz="720" b="1" dirty="0">
+                <a:solidFill>
+                  <a:srgbClr val="52616B"/>
+                </a:solidFill>
+                <a:latin typeface="Aptos" pitchFamily="34" charset="0"/>
+                <a:ea typeface="Aptos" pitchFamily="34" charset="-122"/>
+                <a:cs typeface="Aptos" pitchFamily="34" charset="-120"/>
+              </a:rPr>
+              <a:t>DASHBOARD COMPLETION</a:t>
+            </a:r>
+            <a:endParaRPr lang="en-US" sz="720" dirty="0"/>
+          </a:p>
+        </p:txBody>
+      </p:sp>
+      <p:sp>
+        <p:nvSpPr>
+          <p:cNvPr id="11" name="Text 8"/>
+          <p:cNvSpPr/>
+          <p:nvPr/>
+        </p:nvSpPr>
+        <p:spPr>
+          <a:xfrm>
+            <a:off x="7836408" y="2148840"/>
+            <a:ext cx="2980944" cy="384048"/>
+          </a:xfrm>
+          <a:prstGeom prst="rect">
+            <a:avLst/>
+          </a:prstGeom>
+          <a:noFill/>
+          <a:ln/>
+        </p:spPr>
+        <p:txBody>
+          <a:bodyPr wrap="square" lIns="0" tIns="0" rIns="0" bIns="0" rtlCol="0" anchor="ctr">
+            <a:normAutofit/>
+          </a:bodyPr>
+          <a:lstStyle/>
+          <a:p>
+            <a:pPr indent="0" marL="0">
+              <a:buNone/>
+            </a:pPr>
+            <a:r>
+              <a:rPr lang="en-US" sz="2000" b="1" dirty="0">
+                <a:solidFill>
+                  <a:srgbClr val="0B1F33"/>
+                </a:solidFill>
+                <a:latin typeface="Aptos" pitchFamily="34" charset="0"/>
+                <a:ea typeface="Aptos" pitchFamily="34" charset="-122"/>
+                <a:cs typeface="Aptos" pitchFamily="34" charset="-120"/>
+              </a:rPr>
+              <a:t>PASS</a:t>
+            </a:r>
+            <a:endParaRPr lang="en-US" sz="2000" dirty="0"/>
+          </a:p>
+        </p:txBody>
+      </p:sp>
+      <p:sp>
+        <p:nvSpPr>
+          <p:cNvPr id="12" name="Text 9"/>
+          <p:cNvSpPr/>
+          <p:nvPr/>
+        </p:nvSpPr>
+        <p:spPr>
+          <a:xfrm>
+            <a:off x="7836408" y="2523744"/>
+            <a:ext cx="2980944" cy="137160"/>
+          </a:xfrm>
+          <a:prstGeom prst="rect">
+            <a:avLst/>
+          </a:prstGeom>
+          <a:noFill/>
+          <a:ln/>
+        </p:spPr>
+        <p:txBody>
+          <a:bodyPr wrap="square" lIns="0" tIns="0" rIns="0" bIns="0" rtlCol="0" anchor="ctr">
+            <a:normAutofit/>
+          </a:bodyPr>
+          <a:lstStyle/>
+          <a:p>
+            <a:pPr indent="0" marL="0">
+              <a:buNone/>
+            </a:pPr>
+            <a:r>
+              <a:rPr lang="en-US" sz="750" dirty="0">
+                <a:solidFill>
+                  <a:srgbClr val="52616B"/>
+                </a:solidFill>
+                <a:latin typeface="Aptos" pitchFamily="34" charset="0"/>
+                <a:ea typeface="Aptos" pitchFamily="34" charset="-122"/>
+                <a:cs typeface="Aptos" pitchFamily="34" charset="-120"/>
+              </a:rPr>
+              <a:t>real browser screenshot</a:t>
+            </a:r>
+            <a:endParaRPr lang="en-US" sz="750" dirty="0"/>
+          </a:p>
+        </p:txBody>
+      </p:sp>
+      <p:sp>
+        <p:nvSpPr>
+          <p:cNvPr id="13" name="Text 10"/>
+          <p:cNvSpPr/>
+          <p:nvPr/>
+        </p:nvSpPr>
+        <p:spPr>
+          <a:xfrm>
+            <a:off x="7589520" y="3182112"/>
+            <a:ext cx="3429000" cy="1508760"/>
           </a:xfrm>
           <a:prstGeom prst="rect">
             <a:avLst/>
@@ -3753,30 +3951,30 @@
               <a:buNone/>
             </a:pPr>
             <a:r>
-              <a:rPr lang="en-US" sz="2300" b="1" dirty="0">
-                <a:solidFill>
-                  <a:srgbClr val="0B1F33"/>
-                </a:solidFill>
-                <a:latin typeface="Aptos" pitchFamily="34" charset="0"/>
-                <a:ea typeface="Aptos" pitchFamily="34" charset="-122"/>
-                <a:cs typeface="Aptos" pitchFamily="34" charset="-120"/>
-              </a:rPr>
-              <a:t>P18 integrated-system evidence has been accepted by Control Center for the first integrated run and dashboard evidence.</a:t>
-            </a:r>
-            <a:endParaRPr lang="en-US" sz="2300" dirty="0"/>
-          </a:p>
-        </p:txBody>
-      </p:sp>
-      <p:sp>
-        <p:nvSpPr>
-          <p:cNvPr id="8" name="Text 6"/>
-          <p:cNvSpPr/>
-          <p:nvPr/>
-        </p:nvSpPr>
-        <p:spPr>
-          <a:xfrm>
-            <a:off x="1143000" y="3063240"/>
-            <a:ext cx="9784080" cy="1051560"/>
+              <a:rPr lang="en-US" sz="1450" dirty="0">
+                <a:solidFill>
+                  <a:srgbClr val="17212B"/>
+                </a:solidFill>
+                <a:latin typeface="Aptos" pitchFamily="34" charset="0"/>
+                <a:ea typeface="Aptos" pitchFamily="34" charset="-122"/>
+                <a:cs typeface="Aptos" pitchFamily="34" charset="-120"/>
+              </a:rPr>
+              <a:t>The first integrated retry validated the same-observation data chain, but its browser capture was absent. The separate dashboard-evidence completion package supplies the accepted real dashboard capture.</a:t>
+            </a:r>
+            <a:endParaRPr lang="en-US" sz="1450" dirty="0"/>
+          </a:p>
+        </p:txBody>
+      </p:sp>
+      <p:sp>
+        <p:nvSpPr>
+          <p:cNvPr id="14" name="Text 11"/>
+          <p:cNvSpPr/>
+          <p:nvPr/>
+        </p:nvSpPr>
+        <p:spPr>
+          <a:xfrm>
+            <a:off x="7607808" y="5138928"/>
+            <a:ext cx="3383280" cy="438912"/>
           </a:xfrm>
           <a:prstGeom prst="rect">
             <a:avLst/>
@@ -3794,7 +3992,7 @@
               <a:buNone/>
             </a:pPr>
             <a:r>
-              <a:rPr lang="en-US" sz="1900" dirty="0">
+              <a:rPr lang="en-US" sz="1150" b="1" dirty="0">
                 <a:solidFill>
                   <a:srgbClr val="B42318"/>
                 </a:solidFill>
@@ -3802,15 +4000,15 @@
                 <a:ea typeface="Aptos" pitchFamily="34" charset="-122"/>
                 <a:cs typeface="Aptos" pitchFamily="34" charset="-120"/>
               </a:rPr>
-              <a:t>Presentation artifacts are pending Laptop 1 evidence ingestion. This working draft intentionally contains no fabricated P18 screenshots, runtime plots, logs or measured values.</a:t>
-            </a:r>
-            <a:endParaRPr lang="en-US" sz="1900" dirty="0"/>
-          </a:p>
-        </p:txBody>
-      </p:sp>
-      <p:sp>
-        <p:nvSpPr>
-          <p:cNvPr id="9" name="Shape 7"/>
+              <a:t>This demonstrates integrated runtime and dashboard evidence; it does not establish full autonomy or production readiness.</a:t>
+            </a:r>
+            <a:endParaRPr lang="en-US" sz="1150" dirty="0"/>
+          </a:p>
+        </p:txBody>
+      </p:sp>
+      <p:sp>
+        <p:nvSpPr>
+          <p:cNvPr id="15" name="Shape 12"/>
           <p:cNvSpPr/>
           <p:nvPr/>
         </p:nvSpPr>
@@ -3833,7 +4031,7 @@
       </p:sp>
       <p:sp>
         <p:nvSpPr>
-          <p:cNvPr id="10" name="Text 8"/>
+          <p:cNvPr id="16" name="Text 13"/>
           <p:cNvSpPr/>
           <p:nvPr/>
         </p:nvSpPr>
@@ -3872,7 +4070,7 @@
       </p:sp>
       <p:sp>
         <p:nvSpPr>
-          <p:cNvPr id="11" name="Text 9"/>
+          <p:cNvPr id="17" name="Text 14"/>
           <p:cNvSpPr/>
           <p:nvPr/>
         </p:nvSpPr>
@@ -4015,7 +4213,7 @@
                 <a:ea typeface="Aptos" pitchFamily="34" charset="-122"/>
                 <a:cs typeface="Aptos" pitchFamily="34" charset="-120"/>
               </a:rPr>
-              <a:t>P18 Repeatability Status</a:t>
+              <a:t>P18 Clean Repeatability</a:t>
             </a:r>
             <a:endParaRPr lang="en-US" sz="2500" dirty="0"/>
           </a:p>
@@ -4053,7 +4251,7 @@
         <p:spPr>
           <a:xfrm>
             <a:off x="493776" y="1188720"/>
-            <a:ext cx="5093208" cy="274320"/>
+            <a:ext cx="5212080" cy="274320"/>
           </a:xfrm>
           <a:prstGeom prst="roundRect">
             <a:avLst>
@@ -4061,11 +4259,11 @@
             </a:avLst>
           </a:prstGeom>
           <a:solidFill>
-            <a:srgbClr val="D97706"/>
+            <a:srgbClr val="00796B"/>
           </a:solidFill>
           <a:ln w="12700">
             <a:solidFill>
-              <a:srgbClr val="D97706"/>
+              <a:srgbClr val="00796B"/>
             </a:solidFill>
             <a:prstDash val="solid"/>
           </a:ln>
@@ -4080,7 +4278,7 @@
         <p:spPr>
           <a:xfrm>
             <a:off x="603504" y="1261872"/>
-            <a:ext cx="4892040" cy="91440"/>
+            <a:ext cx="5010912" cy="91440"/>
           </a:xfrm>
           <a:prstGeom prst="rect">
             <a:avLst/>
@@ -4106,26 +4304,49 @@
                 <a:ea typeface="Aptos" pitchFamily="34" charset="-122"/>
                 <a:cs typeface="Aptos" pitchFamily="34" charset="-120"/>
               </a:rPr>
-              <a:t>PENDING / PRESENTATION ASSETS</a:t>
+              <a:t>DEMONSTRATED / VERIFIED PACKAGE</a:t>
             </a:r>
             <a:endParaRPr lang="en-US" sz="750" dirty="0"/>
           </a:p>
         </p:txBody>
       </p:sp>
-      <p:sp>
-        <p:nvSpPr>
-          <p:cNvPr id="7" name="Shape 5"/>
-          <p:cNvSpPr/>
-          <p:nvPr/>
-        </p:nvSpPr>
-        <p:spPr>
-          <a:xfrm>
-            <a:off x="914400" y="1920240"/>
-            <a:ext cx="2971800" cy="1143000"/>
+      <p:pic>
+        <p:nvPicPr>
+          <p:cNvPr id="7" name="Image 0" descr="C:\Users\Aritra\Documents\aegisinspect-p20-deck-draft\outputs\presentation\p18_evidence\dashboard\clean_repeatability_overview.png">    </p:cNvPr>
+          <p:cNvPicPr>
+            <a:picLocks noChangeAspect="1"/>
+          </p:cNvPicPr>
+          <p:nvPr/>
+        </p:nvPicPr>
+        <p:blipFill>
+          <a:blip r:embed="rId1"/>
+          <a:srcRect l="0" r="0" t="0" b="0"/>
+          <a:stretch/>
+        </p:blipFill>
+        <p:spPr>
+          <a:xfrm>
+            <a:off x="594360" y="1572768"/>
+            <a:ext cx="6675120" cy="4343400"/>
+          </a:xfrm>
+          <a:prstGeom prst="rect">
+            <a:avLst/>
+          </a:prstGeom>
+        </p:spPr>
+      </p:pic>
+      <p:sp>
+        <p:nvSpPr>
+          <p:cNvPr id="8" name="Shape 5"/>
+          <p:cNvSpPr/>
+          <p:nvPr/>
+        </p:nvSpPr>
+        <p:spPr>
+          <a:xfrm>
+            <a:off x="7635240" y="1755648"/>
+            <a:ext cx="3291840" cy="1024128"/>
           </a:xfrm>
           <a:prstGeom prst="roundRect">
             <a:avLst>
-              <a:gd name="adj" fmla="val 4000"/>
+              <a:gd name="adj" fmla="val 4464"/>
             </a:avLst>
           </a:prstGeom>
           <a:solidFill>
@@ -4141,14 +4362,14 @@
       </p:sp>
       <p:sp>
         <p:nvSpPr>
-          <p:cNvPr id="8" name="Shape 6"/>
-          <p:cNvSpPr/>
-          <p:nvPr/>
-        </p:nvSpPr>
-        <p:spPr>
-          <a:xfrm>
-            <a:off x="914400" y="1920240"/>
-            <a:ext cx="73152" cy="1143000"/>
+          <p:cNvPr id="9" name="Shape 6"/>
+          <p:cNvSpPr/>
+          <p:nvPr/>
+        </p:nvSpPr>
+        <p:spPr>
+          <a:xfrm>
+            <a:off x="7635240" y="1755648"/>
+            <a:ext cx="73152" cy="1024128"/>
           </a:xfrm>
           <a:prstGeom prst="rect">
             <a:avLst/>
@@ -4166,14 +4387,14 @@
       </p:sp>
       <p:sp>
         <p:nvSpPr>
-          <p:cNvPr id="9" name="Text 7"/>
-          <p:cNvSpPr/>
-          <p:nvPr/>
-        </p:nvSpPr>
-        <p:spPr>
-          <a:xfrm>
-            <a:off x="1115568" y="2075688"/>
-            <a:ext cx="2660904" cy="146304"/>
+          <p:cNvPr id="10" name="Text 7"/>
+          <p:cNvSpPr/>
+          <p:nvPr/>
+        </p:nvSpPr>
+        <p:spPr>
+          <a:xfrm>
+            <a:off x="7836408" y="1911096"/>
+            <a:ext cx="2980944" cy="146304"/>
           </a:xfrm>
           <a:prstGeom prst="rect">
             <a:avLst/>
@@ -4199,7 +4420,7 @@
                 <a:ea typeface="Aptos" pitchFamily="34" charset="-122"/>
                 <a:cs typeface="Aptos" pitchFamily="34" charset="-120"/>
               </a:rPr>
-              <a:t>CONTROL CENTER STATE</a:t>
+              <a:t>CLEAN REPEATABILITY</a:t>
             </a:r>
             <a:endParaRPr lang="en-US" sz="720" dirty="0"/>
           </a:p>
@@ -4207,14 +4428,14 @@
       </p:sp>
       <p:sp>
         <p:nvSpPr>
-          <p:cNvPr id="10" name="Text 8"/>
-          <p:cNvSpPr/>
-          <p:nvPr/>
-        </p:nvSpPr>
-        <p:spPr>
-          <a:xfrm>
-            <a:off x="1115568" y="2313432"/>
-            <a:ext cx="2660904" cy="502920"/>
+          <p:cNvPr id="11" name="Text 8"/>
+          <p:cNvSpPr/>
+          <p:nvPr/>
+        </p:nvSpPr>
+        <p:spPr>
+          <a:xfrm>
+            <a:off x="7836408" y="2148840"/>
+            <a:ext cx="2980944" cy="384048"/>
           </a:xfrm>
           <a:prstGeom prst="rect">
             <a:avLst/>
@@ -4240,7 +4461,7 @@
                 <a:ea typeface="Aptos" pitchFamily="34" charset="-122"/>
                 <a:cs typeface="Aptos" pitchFamily="34" charset="-120"/>
               </a:rPr>
-              <a:t>ACCEPTED</a:t>
+              <a:t>PASS</a:t>
             </a:r>
             <a:endParaRPr lang="en-US" sz="2000" dirty="0"/>
           </a:p>
@@ -4248,14 +4469,14 @@
       </p:sp>
       <p:sp>
         <p:nvSpPr>
-          <p:cNvPr id="11" name="Text 9"/>
-          <p:cNvSpPr/>
-          <p:nvPr/>
-        </p:nvSpPr>
-        <p:spPr>
-          <a:xfrm>
-            <a:off x="1115568" y="2807208"/>
-            <a:ext cx="2660904" cy="137160"/>
+          <p:cNvPr id="12" name="Text 9"/>
+          <p:cNvSpPr/>
+          <p:nvPr/>
+        </p:nvSpPr>
+        <p:spPr>
+          <a:xfrm>
+            <a:off x="7836408" y="2523744"/>
+            <a:ext cx="2980944" cy="137160"/>
           </a:xfrm>
           <a:prstGeom prst="rect">
             <a:avLst/>
@@ -4281,7 +4502,7 @@
                 <a:ea typeface="Aptos" pitchFamily="34" charset="-122"/>
                 <a:cs typeface="Aptos" pitchFamily="34" charset="-120"/>
               </a:rPr>
-              <a:t>clean repeatability accepted</a:t>
+              <a:t>accepted execution identity</a:t>
             </a:r>
             <a:endParaRPr lang="en-US" sz="750" dirty="0"/>
           </a:p>
@@ -4289,364 +4510,14 @@
       </p:sp>
       <p:sp>
         <p:nvSpPr>
-          <p:cNvPr id="12" name="Shape 10"/>
-          <p:cNvSpPr/>
-          <p:nvPr/>
-        </p:nvSpPr>
-        <p:spPr>
-          <a:xfrm>
-            <a:off x="4617720" y="1920240"/>
-            <a:ext cx="2971800" cy="1143000"/>
-          </a:xfrm>
-          <a:prstGeom prst="roundRect">
-            <a:avLst>
-              <a:gd name="adj" fmla="val 4000"/>
-            </a:avLst>
-          </a:prstGeom>
-          <a:solidFill>
-            <a:srgbClr val="F3F7FA"/>
-          </a:solidFill>
-          <a:ln w="7620">
-            <a:solidFill>
-              <a:srgbClr val="DCE6ED"/>
-            </a:solidFill>
-            <a:prstDash val="solid"/>
-          </a:ln>
-        </p:spPr>
-      </p:sp>
-      <p:sp>
-        <p:nvSpPr>
-          <p:cNvPr id="13" name="Shape 11"/>
-          <p:cNvSpPr/>
-          <p:nvPr/>
-        </p:nvSpPr>
-        <p:spPr>
-          <a:xfrm>
-            <a:off x="4617720" y="1920240"/>
-            <a:ext cx="73152" cy="1143000"/>
-          </a:xfrm>
-          <a:prstGeom prst="rect">
-            <a:avLst/>
-          </a:prstGeom>
-          <a:solidFill>
-            <a:srgbClr val="D97706"/>
-          </a:solidFill>
-          <a:ln w="12700">
-            <a:solidFill>
-              <a:srgbClr val="D97706"/>
-            </a:solidFill>
-            <a:prstDash val="solid"/>
-          </a:ln>
-        </p:spPr>
-      </p:sp>
-      <p:sp>
-        <p:nvSpPr>
-          <p:cNvPr id="14" name="Text 12"/>
-          <p:cNvSpPr/>
-          <p:nvPr/>
-        </p:nvSpPr>
-        <p:spPr>
-          <a:xfrm>
-            <a:off x="4818888" y="2075688"/>
-            <a:ext cx="2660904" cy="146304"/>
-          </a:xfrm>
-          <a:prstGeom prst="rect">
-            <a:avLst/>
-          </a:prstGeom>
-          <a:noFill/>
-          <a:ln/>
-        </p:spPr>
-        <p:txBody>
-          <a:bodyPr wrap="square" lIns="0" tIns="0" rIns="0" bIns="0" rtlCol="0" anchor="ctr">
-            <a:normAutofit/>
-          </a:bodyPr>
-          <a:lstStyle/>
-          <a:p>
-            <a:pPr indent="0" marL="0">
-              <a:buNone/>
-            </a:pPr>
-            <a:r>
-              <a:rPr lang="en-US" sz="720" b="1" dirty="0">
-                <a:solidFill>
-                  <a:srgbClr val="52616B"/>
-                </a:solidFill>
-                <a:latin typeface="Aptos" pitchFamily="34" charset="0"/>
-                <a:ea typeface="Aptos" pitchFamily="34" charset="-122"/>
-                <a:cs typeface="Aptos" pitchFamily="34" charset="-120"/>
-              </a:rPr>
-              <a:t>P20 EVIDENCE INGESTION</a:t>
-            </a:r>
-            <a:endParaRPr lang="en-US" sz="720" dirty="0"/>
-          </a:p>
-        </p:txBody>
-      </p:sp>
-      <p:sp>
-        <p:nvSpPr>
-          <p:cNvPr id="15" name="Text 13"/>
-          <p:cNvSpPr/>
-          <p:nvPr/>
-        </p:nvSpPr>
-        <p:spPr>
-          <a:xfrm>
-            <a:off x="4818888" y="2313432"/>
-            <a:ext cx="2660904" cy="502920"/>
-          </a:xfrm>
-          <a:prstGeom prst="rect">
-            <a:avLst/>
-          </a:prstGeom>
-          <a:noFill/>
-          <a:ln/>
-        </p:spPr>
-        <p:txBody>
-          <a:bodyPr wrap="square" lIns="0" tIns="0" rIns="0" bIns="0" rtlCol="0" anchor="ctr">
-            <a:normAutofit/>
-          </a:bodyPr>
-          <a:lstStyle/>
-          <a:p>
-            <a:pPr indent="0" marL="0">
-              <a:buNone/>
-            </a:pPr>
-            <a:r>
-              <a:rPr lang="en-US" sz="2000" b="1" dirty="0">
-                <a:solidFill>
-                  <a:srgbClr val="0B1F33"/>
-                </a:solidFill>
-                <a:latin typeface="Aptos" pitchFamily="34" charset="0"/>
-                <a:ea typeface="Aptos" pitchFamily="34" charset="-122"/>
-                <a:cs typeface="Aptos" pitchFamily="34" charset="-120"/>
-              </a:rPr>
-              <a:t>PENDING</a:t>
-            </a:r>
-            <a:endParaRPr lang="en-US" sz="2000" dirty="0"/>
-          </a:p>
-        </p:txBody>
-      </p:sp>
-      <p:sp>
-        <p:nvSpPr>
-          <p:cNvPr id="16" name="Text 14"/>
-          <p:cNvSpPr/>
-          <p:nvPr/>
-        </p:nvSpPr>
-        <p:spPr>
-          <a:xfrm>
-            <a:off x="4818888" y="2807208"/>
-            <a:ext cx="2660904" cy="137160"/>
-          </a:xfrm>
-          <a:prstGeom prst="rect">
-            <a:avLst/>
-          </a:prstGeom>
-          <a:noFill/>
-          <a:ln/>
-        </p:spPr>
-        <p:txBody>
-          <a:bodyPr wrap="square" lIns="0" tIns="0" rIns="0" bIns="0" rtlCol="0" anchor="ctr">
-            <a:normAutofit/>
-          </a:bodyPr>
-          <a:lstStyle/>
-          <a:p>
-            <a:pPr indent="0" marL="0">
-              <a:buNone/>
-            </a:pPr>
-            <a:r>
-              <a:rPr lang="en-US" sz="750" dirty="0">
-                <a:solidFill>
-                  <a:srgbClr val="52616B"/>
-                </a:solidFill>
-                <a:latin typeface="Aptos" pitchFamily="34" charset="0"/>
-                <a:ea typeface="Aptos" pitchFamily="34" charset="-122"/>
-                <a:cs typeface="Aptos" pitchFamily="34" charset="-120"/>
-              </a:rPr>
-              <a:t>no transferred assets yet</a:t>
-            </a:r>
-            <a:endParaRPr lang="en-US" sz="750" dirty="0"/>
-          </a:p>
-        </p:txBody>
-      </p:sp>
-      <p:sp>
-        <p:nvSpPr>
-          <p:cNvPr id="17" name="Shape 15"/>
-          <p:cNvSpPr/>
-          <p:nvPr/>
-        </p:nvSpPr>
-        <p:spPr>
-          <a:xfrm>
-            <a:off x="8321040" y="1920240"/>
-            <a:ext cx="2971800" cy="1143000"/>
-          </a:xfrm>
-          <a:prstGeom prst="roundRect">
-            <a:avLst>
-              <a:gd name="adj" fmla="val 4000"/>
-            </a:avLst>
-          </a:prstGeom>
-          <a:solidFill>
-            <a:srgbClr val="F3F7FA"/>
-          </a:solidFill>
-          <a:ln w="7620">
-            <a:solidFill>
-              <a:srgbClr val="DCE6ED"/>
-            </a:solidFill>
-            <a:prstDash val="solid"/>
-          </a:ln>
-        </p:spPr>
-      </p:sp>
-      <p:sp>
-        <p:nvSpPr>
-          <p:cNvPr id="18" name="Shape 16"/>
-          <p:cNvSpPr/>
-          <p:nvPr/>
-        </p:nvSpPr>
-        <p:spPr>
-          <a:xfrm>
-            <a:off x="8321040" y="1920240"/>
-            <a:ext cx="73152" cy="1143000"/>
-          </a:xfrm>
-          <a:prstGeom prst="rect">
-            <a:avLst/>
-          </a:prstGeom>
-          <a:solidFill>
-            <a:srgbClr val="B42318"/>
-          </a:solidFill>
-          <a:ln w="12700">
-            <a:solidFill>
-              <a:srgbClr val="B42318"/>
-            </a:solidFill>
-            <a:prstDash val="solid"/>
-          </a:ln>
-        </p:spPr>
-      </p:sp>
-      <p:sp>
-        <p:nvSpPr>
-          <p:cNvPr id="19" name="Text 17"/>
-          <p:cNvSpPr/>
-          <p:nvPr/>
-        </p:nvSpPr>
-        <p:spPr>
-          <a:xfrm>
-            <a:off x="8522208" y="2075688"/>
-            <a:ext cx="2660904" cy="146304"/>
-          </a:xfrm>
-          <a:prstGeom prst="rect">
-            <a:avLst/>
-          </a:prstGeom>
-          <a:noFill/>
-          <a:ln/>
-        </p:spPr>
-        <p:txBody>
-          <a:bodyPr wrap="square" lIns="0" tIns="0" rIns="0" bIns="0" rtlCol="0" anchor="ctr">
-            <a:normAutofit/>
-          </a:bodyPr>
-          <a:lstStyle/>
-          <a:p>
-            <a:pPr indent="0" marL="0">
-              <a:buNone/>
-            </a:pPr>
-            <a:r>
-              <a:rPr lang="en-US" sz="720" b="1" dirty="0">
-                <a:solidFill>
-                  <a:srgbClr val="52616B"/>
-                </a:solidFill>
-                <a:latin typeface="Aptos" pitchFamily="34" charset="0"/>
-                <a:ea typeface="Aptos" pitchFamily="34" charset="-122"/>
-                <a:cs typeface="Aptos" pitchFamily="34" charset="-120"/>
-              </a:rPr>
-              <a:t>AUDIENCE ASSETS</a:t>
-            </a:r>
-            <a:endParaRPr lang="en-US" sz="720" dirty="0"/>
-          </a:p>
-        </p:txBody>
-      </p:sp>
-      <p:sp>
-        <p:nvSpPr>
-          <p:cNvPr id="20" name="Text 18"/>
-          <p:cNvSpPr/>
-          <p:nvPr/>
-        </p:nvSpPr>
-        <p:spPr>
-          <a:xfrm>
-            <a:off x="8522208" y="2313432"/>
-            <a:ext cx="2660904" cy="502920"/>
-          </a:xfrm>
-          <a:prstGeom prst="rect">
-            <a:avLst/>
-          </a:prstGeom>
-          <a:noFill/>
-          <a:ln/>
-        </p:spPr>
-        <p:txBody>
-          <a:bodyPr wrap="square" lIns="0" tIns="0" rIns="0" bIns="0" rtlCol="0" anchor="ctr">
-            <a:normAutofit/>
-          </a:bodyPr>
-          <a:lstStyle/>
-          <a:p>
-            <a:pPr indent="0" marL="0">
-              <a:buNone/>
-            </a:pPr>
-            <a:r>
-              <a:rPr lang="en-US" sz="2000" b="1" dirty="0">
-                <a:solidFill>
-                  <a:srgbClr val="0B1F33"/>
-                </a:solidFill>
-                <a:latin typeface="Aptos" pitchFamily="34" charset="0"/>
-                <a:ea typeface="Aptos" pitchFamily="34" charset="-122"/>
-                <a:cs typeface="Aptos" pitchFamily="34" charset="-120"/>
-              </a:rPr>
-              <a:t>NOT SHOWN</a:t>
-            </a:r>
-            <a:endParaRPr lang="en-US" sz="2000" dirty="0"/>
-          </a:p>
-        </p:txBody>
-      </p:sp>
-      <p:sp>
-        <p:nvSpPr>
-          <p:cNvPr id="21" name="Text 19"/>
-          <p:cNvSpPr/>
-          <p:nvPr/>
-        </p:nvSpPr>
-        <p:spPr>
-          <a:xfrm>
-            <a:off x="8522208" y="2807208"/>
-            <a:ext cx="2660904" cy="137160"/>
-          </a:xfrm>
-          <a:prstGeom prst="rect">
-            <a:avLst/>
-          </a:prstGeom>
-          <a:noFill/>
-          <a:ln/>
-        </p:spPr>
-        <p:txBody>
-          <a:bodyPr wrap="square" lIns="0" tIns="0" rIns="0" bIns="0" rtlCol="0" anchor="ctr">
-            <a:normAutofit/>
-          </a:bodyPr>
-          <a:lstStyle/>
-          <a:p>
-            <a:pPr indent="0" marL="0">
-              <a:buNone/>
-            </a:pPr>
-            <a:r>
-              <a:rPr lang="en-US" sz="750" dirty="0">
-                <a:solidFill>
-                  <a:srgbClr val="52616B"/>
-                </a:solidFill>
-                <a:latin typeface="Aptos" pitchFamily="34" charset="0"/>
-                <a:ea typeface="Aptos" pitchFamily="34" charset="-122"/>
-                <a:cs typeface="Aptos" pitchFamily="34" charset="-120"/>
-              </a:rPr>
-              <a:t>avoid fabricated visual evidence</a:t>
-            </a:r>
-            <a:endParaRPr lang="en-US" sz="750" dirty="0"/>
-          </a:p>
-        </p:txBody>
-      </p:sp>
-      <p:sp>
-        <p:nvSpPr>
-          <p:cNvPr id="22" name="Text 20"/>
-          <p:cNvSpPr/>
-          <p:nvPr/>
-        </p:nvSpPr>
-        <p:spPr>
-          <a:xfrm>
-            <a:off x="1143000" y="3886200"/>
-            <a:ext cx="9784080" cy="548640"/>
+          <p:cNvPr id="13" name="Text 10"/>
+          <p:cNvSpPr/>
+          <p:nvPr/>
+        </p:nvSpPr>
+        <p:spPr>
+          <a:xfrm>
+            <a:off x="7589520" y="3182112"/>
+            <a:ext cx="3429000" cy="1508760"/>
           </a:xfrm>
           <a:prstGeom prst="rect">
             <a:avLst/>
@@ -4664,23 +4535,64 @@
               <a:buNone/>
             </a:pPr>
             <a:r>
-              <a:rPr lang="en-US" sz="1900" dirty="0">
-                <a:solidFill>
-                  <a:srgbClr val="0B1F33"/>
-                </a:solidFill>
-                <a:latin typeface="Aptos" pitchFamily="34" charset="0"/>
-                <a:ea typeface="Aptos" pitchFamily="34" charset="-122"/>
-                <a:cs typeface="Aptos" pitchFamily="34" charset="-120"/>
-              </a:rPr>
-              <a:t>This slide preserves the accepted program state while waiting for the corresponding presentation-safe evidence package.</a:t>
-            </a:r>
-            <a:endParaRPr lang="en-US" sz="1900" dirty="0"/>
-          </a:p>
-        </p:txBody>
-      </p:sp>
-      <p:sp>
-        <p:nvSpPr>
-          <p:cNvPr id="23" name="Shape 21"/>
+              <a:rPr lang="en-US" sz="1450" dirty="0">
+                <a:solidFill>
+                  <a:srgbClr val="17212B"/>
+                </a:solidFill>
+                <a:latin typeface="Aptos" pitchFamily="34" charset="0"/>
+                <a:ea typeface="Aptos" pitchFamily="34" charset="-122"/>
+                <a:cs typeface="Aptos" pitchFamily="34" charset="-120"/>
+              </a:rPr>
+              <a:t>The clean repeatability package records a new detection and mapped-defect identity, P16 PASS, browser screenshots PASS and P17 PASS under unchanged source and configuration.</a:t>
+            </a:r>
+            <a:endParaRPr lang="en-US" sz="1450" dirty="0"/>
+          </a:p>
+        </p:txBody>
+      </p:sp>
+      <p:sp>
+        <p:nvSpPr>
+          <p:cNvPr id="14" name="Text 11"/>
+          <p:cNvSpPr/>
+          <p:nvPr/>
+        </p:nvSpPr>
+        <p:spPr>
+          <a:xfrm>
+            <a:off x="7607808" y="5138928"/>
+            <a:ext cx="3383280" cy="438912"/>
+          </a:xfrm>
+          <a:prstGeom prst="rect">
+            <a:avLst/>
+          </a:prstGeom>
+          <a:noFill/>
+          <a:ln/>
+        </p:spPr>
+        <p:txBody>
+          <a:bodyPr wrap="square" lIns="508" tIns="508" rIns="508" bIns="508" rtlCol="0" anchor="t">
+            <a:normAutofit/>
+          </a:bodyPr>
+          <a:lstStyle/>
+          <a:p>
+            <a:pPr algn="ctr" indent="0" marL="0">
+              <a:buNone/>
+            </a:pPr>
+            <a:r>
+              <a:rPr lang="en-US" sz="1150" b="1" dirty="0">
+                <a:solidFill>
+                  <a:srgbClr val="B42318"/>
+                </a:solidFill>
+                <a:latin typeface="Aptos" pitchFamily="34" charset="0"/>
+                <a:ea typeface="Aptos" pitchFamily="34" charset="-122"/>
+                <a:cs typeface="Aptos" pitchFamily="34" charset="-120"/>
+              </a:rPr>
+              <a:t>P19 3D correspondence and Workstream 04 evidence remain pending.</a:t>
+            </a:r>
+            <a:endParaRPr lang="en-US" sz="1150" dirty="0"/>
+          </a:p>
+        </p:txBody>
+      </p:sp>
+      <p:sp>
+        <p:nvSpPr>
+          <p:cNvPr id="15" name="Shape 12"/>
           <p:cNvSpPr/>
           <p:nvPr/>
         </p:nvSpPr>
@@ -4703,7 +4615,7 @@
       </p:sp>
       <p:sp>
         <p:nvSpPr>
-          <p:cNvPr id="24" name="Text 22"/>
+          <p:cNvPr id="16" name="Text 13"/>
           <p:cNvSpPr/>
           <p:nvPr/>
         </p:nvSpPr>
@@ -4742,7 +4654,7 @@
       </p:sp>
       <p:sp>
         <p:nvSpPr>
-          <p:cNvPr id="25" name="Text 23"/>
+          <p:cNvPr id="17" name="Text 14"/>
           <p:cNvSpPr/>
           <p:nvPr/>
         </p:nvSpPr>
@@ -5151,7 +5063,7 @@
                 <a:ea typeface="Aptos" pitchFamily="34" charset="-122"/>
                 <a:cs typeface="Aptos" pitchFamily="34" charset="-120"/>
               </a:rPr>
-              <a:t>76 matched samples; interval 3–18 s</a:t>
+              <a:t>76 matched samples; interval 3-18 s</a:t>
             </a:r>
             <a:endParaRPr lang="en-US" sz="750" dirty="0"/>
           </a:p>
@@ -5326,7 +5238,7 @@
                 <a:ea typeface="Aptos" pitchFamily="34" charset="-122"/>
                 <a:cs typeface="Aptos" pitchFamily="34" charset="-120"/>
               </a:rPr>
-              <a:t>delta 1 s ± 50 ms</a:t>
+              <a:t>delta 1 s +/- 50 ms</a:t>
             </a:r>
             <a:endParaRPr lang="en-US" sz="750" dirty="0"/>
           </a:p>
@@ -5928,7 +5840,7 @@
                 <a:ea typeface="Aptos" pitchFamily="34" charset="-122"/>
                 <a:cs typeface="Aptos" pitchFamily="34" charset="-120"/>
               </a:rPr>
-              <a:t>P19 3D evaluation — pending controlled correspondence experiment</a:t>
+              <a:t>P19 3D evaluation - pending controlled correspondence experiment</a:t>
             </a:r>
             <a:endParaRPr lang="en-US" sz="2500" dirty="0"/>
           </a:p>
@@ -6314,7 +6226,7 @@
                 <a:ea typeface="Aptos" pitchFamily="34" charset="-122"/>
                 <a:cs typeface="Aptos" pitchFamily="34" charset="-120"/>
               </a:rPr>
-              <a:t>Low-light robustness — results pending Workstream 04 completion</a:t>
+              <a:t>Low-light robustness - results pending Workstream 04 completion</a:t>
             </a:r>
             <a:endParaRPr lang="en-US" sz="2500" dirty="0"/>
           </a:p>
@@ -6700,7 +6612,7 @@
                 <a:ea typeface="Aptos" pitchFamily="34" charset="-122"/>
                 <a:cs typeface="Aptos" pitchFamily="34" charset="-120"/>
               </a:rPr>
-              <a:t>• Git preservation provenance: canonical P17 preservation state</a:t>
+              <a:t>- Git preservation provenance: canonical P17 preservation state</a:t>
             </a:r>
             <a:endParaRPr lang="en-US" sz="1600" dirty="0"/>
           </a:p>
@@ -6717,7 +6629,7 @@
                 <a:ea typeface="Aptos" pitchFamily="34" charset="-122"/>
                 <a:cs typeface="Aptos" pitchFamily="34" charset="-120"/>
               </a:rPr>
-              <a:t>• Runtime evidence provenance: recovered P16/P17 ZIP, DB and report</a:t>
+              <a:t>- Runtime evidence provenance: recovered P16/P17 ZIP, DB and report</a:t>
             </a:r>
             <a:endParaRPr lang="en-US" sz="1600" dirty="0"/>
           </a:p>
@@ -6734,7 +6646,7 @@
                 <a:ea typeface="Aptos" pitchFamily="34" charset="-122"/>
                 <a:cs typeface="Aptos" pitchFamily="34" charset="-120"/>
               </a:rPr>
-              <a:t>• P19 localization evidence preservation commit</a:t>
+              <a:t>- P19 localization evidence preservation commit</a:t>
             </a:r>
             <a:endParaRPr lang="en-US" sz="1600" dirty="0"/>
           </a:p>
@@ -6751,7 +6663,7 @@
                 <a:ea typeface="Aptos" pitchFamily="34" charset="-122"/>
                 <a:cs typeface="Aptos" pitchFamily="34" charset="-120"/>
               </a:rPr>
-              <a:t>• Full hashes retained in the verified P20 evidence package</a:t>
+              <a:t>- Full hashes retained in the verified P20 evidence package</a:t>
             </a:r>
             <a:endParaRPr lang="en-US" sz="1600" dirty="0"/>
           </a:p>
@@ -6984,7 +6896,7 @@
                 <a:ea typeface="Aptos" pitchFamily="34" charset="-122"/>
                 <a:cs typeface="Aptos" pitchFamily="34" charset="-120"/>
               </a:rPr>
-              <a:t>P17 Git: eb4013fa…bbfe488f</a:t>
+              <a:t>P17 Git: eb4013fa...bbfe488f</a:t>
             </a:r>
             <a:endParaRPr lang="en-US" sz="1500" dirty="0"/>
           </a:p>
@@ -7001,7 +6913,7 @@
                 <a:ea typeface="Aptos" pitchFamily="34" charset="-122"/>
                 <a:cs typeface="Aptos" pitchFamily="34" charset="-120"/>
               </a:rPr>
-              <a:t>P16/P17 ZIP: df3f87f0…9f313ec2</a:t>
+              <a:t>P16/P17 ZIP: df3f87f0...9f313ec2</a:t>
             </a:r>
             <a:endParaRPr lang="en-US" sz="1500" dirty="0"/>
           </a:p>
@@ -7018,7 +6930,7 @@
                 <a:ea typeface="Aptos" pitchFamily="34" charset="-122"/>
                 <a:cs typeface="Aptos" pitchFamily="34" charset="-120"/>
               </a:rPr>
-              <a:t>P19 evidence: 4c7bd79a…9a4d78a</a:t>
+              <a:t>P19 evidence: 4c7bd79a...9a4d78a</a:t>
             </a:r>
             <a:endParaRPr lang="en-US" sz="1500" dirty="0"/>
           </a:p>
@@ -7363,7 +7275,7 @@
                 <a:ea typeface="Aptos" pitchFamily="34" charset="-122"/>
                 <a:cs typeface="Aptos" pitchFamily="34" charset="-120"/>
               </a:rPr>
-              <a:t>• Held-out detector mAP remains modest; metrics are not generic accuracy</a:t>
+              <a:t>- Held-out detector mAP remains modest; metrics are not generic accuracy</a:t>
             </a:r>
             <a:endParaRPr lang="en-US" sz="1700" dirty="0"/>
           </a:p>
@@ -7380,7 +7292,7 @@
                 <a:ea typeface="Aptos" pitchFamily="34" charset="-122"/>
                 <a:cs typeface="Aptos" pitchFamily="34" charset="-120"/>
               </a:rPr>
-              <a:t>• Accepted P16/P17 example is extremely-low-confidence, unreviewed machine output</a:t>
+              <a:t>- Accepted P16/P17 example is extremely-low-confidence, unreviewed machine output</a:t>
             </a:r>
             <a:endParaRPr lang="en-US" sz="1700" dirty="0"/>
           </a:p>
@@ -7397,7 +7309,7 @@
                 <a:ea typeface="Aptos" pitchFamily="34" charset="-122"/>
                 <a:cs typeface="Aptos" pitchFamily="34" charset="-120"/>
               </a:rPr>
-              <a:t>• P19 localization is measured, not threshold-classified as accurate</a:t>
+              <a:t>- P19 localization is measured, not threshold-classified as accurate</a:t>
             </a:r>
             <a:endParaRPr lang="en-US" sz="1700" dirty="0"/>
           </a:p>
@@ -7414,7 +7326,7 @@
                 <a:ea typeface="Aptos" pitchFamily="34" charset="-122"/>
                 <a:cs typeface="Aptos" pitchFamily="34" charset="-120"/>
               </a:rPr>
-              <a:t>• P19 3D requires explicit correspondence</a:t>
+              <a:t>- P19 3D requires explicit correspondence</a:t>
             </a:r>
             <a:endParaRPr lang="en-US" sz="1700" dirty="0"/>
           </a:p>
@@ -7431,7 +7343,7 @@
                 <a:ea typeface="Aptos" pitchFamily="34" charset="-122"/>
                 <a:cs typeface="Aptos" pitchFamily="34" charset="-120"/>
               </a:rPr>
-              <a:t>• P18 presentation-evidence ingestion and Workstream 04 results are pending</a:t>
+              <a:t>- P18 demonstrates runtime, dashboard-completion and repeatability evidence; Workstream 04 results are pending</a:t>
             </a:r>
             <a:endParaRPr lang="en-US" sz="1700" dirty="0"/>
           </a:p>
@@ -7448,7 +7360,7 @@
                 <a:ea typeface="Aptos" pitchFamily="34" charset="-122"/>
                 <a:cs typeface="Aptos" pitchFamily="34" charset="-120"/>
               </a:rPr>
-              <a:t>• Stop C / full autonomy is not demonstrated</a:t>
+              <a:t>- Stop C / full autonomy is not demonstrated</a:t>
             </a:r>
             <a:endParaRPr lang="en-US" sz="1700" dirty="0"/>
           </a:p>
@@ -7834,7 +7746,7 @@
                 <a:ea typeface="Aptos" pitchFamily="34" charset="-122"/>
                 <a:cs typeface="Aptos" pitchFamily="34" charset="-120"/>
               </a:rPr>
-              <a:t>Next accepted inputs: P18 presentation artifacts; explicit P19 3D correspondence; Workstream 04 low-light results.</a:t>
+              <a:t>Next accepted inputs: explicit P19 3D correspondence; Workstream 04 low-light results.</a:t>
             </a:r>
             <a:endParaRPr lang="en-US" sz="1800" dirty="0"/>
           </a:p>
@@ -8261,7 +8173,7 @@
                 <a:ea typeface="Aptos" pitchFamily="34" charset="-122"/>
                 <a:cs typeface="Aptos" pitchFamily="34" charset="-120"/>
               </a:rPr>
-              <a:t>• Acquire RGB, depth, IMU and LiDAR observations</a:t>
+              <a:t>- Acquire RGB, depth, IMU and LiDAR observations</a:t>
             </a:r>
             <a:endParaRPr lang="en-US" sz="1600" dirty="0"/>
           </a:p>
@@ -8278,7 +8190,7 @@
                 <a:ea typeface="Aptos" pitchFamily="34" charset="-122"/>
                 <a:cs typeface="Aptos" pitchFamily="34" charset="-120"/>
               </a:rPr>
-              <a:t>• Detect structural defects and project observations into 3D</a:t>
+              <a:t>- Detect structural defects and project observations into 3D</a:t>
             </a:r>
             <a:endParaRPr lang="en-US" sz="1600" dirty="0"/>
           </a:p>
@@ -8295,7 +8207,7 @@
                 <a:ea typeface="Aptos" pitchFamily="34" charset="-122"/>
                 <a:cs typeface="Aptos" pitchFamily="34" charset="-120"/>
               </a:rPr>
-              <a:t>• Persist records for human review and deterministic reporting</a:t>
+              <a:t>- Persist records for human review and deterministic reporting</a:t>
             </a:r>
             <a:endParaRPr lang="en-US" sz="1600" dirty="0"/>
           </a:p>
@@ -8312,7 +8224,7 @@
                 <a:ea typeface="Aptos" pitchFamily="34" charset="-122"/>
                 <a:cs typeface="Aptos" pitchFamily="34" charset="-120"/>
               </a:rPr>
-              <a:t>• Evaluate detector, localization and spatial outputs reproducibly</a:t>
+              <a:t>- Evaluate detector, localization and spatial outputs reproducibly</a:t>
             </a:r>
             <a:endParaRPr lang="en-US" sz="1600" dirty="0"/>
           </a:p>
@@ -8773,7 +8685,7 @@
               <a:buNone/>
             </a:pPr>
             <a:r>
-              <a:rPr lang="en-US" sz="2400" dirty="0">
+              <a:rPr lang="en-US" sz="1800" dirty="0">
                 <a:solidFill>
                   <a:srgbClr val="00A6A6"/>
                 </a:solidFill>
@@ -8781,9 +8693,9 @@
                 <a:ea typeface="Aptos" pitchFamily="34" charset="-122"/>
                 <a:cs typeface="Aptos" pitchFamily="34" charset="-120"/>
               </a:rPr>
-              <a:t>›</a:t>
-            </a:r>
-            <a:endParaRPr lang="en-US" sz="2400" dirty="0"/>
+              <a:t>&gt;</a:t>
+            </a:r>
+            <a:endParaRPr lang="en-US" sz="1800" dirty="0"/>
           </a:p>
         </p:txBody>
       </p:sp>
@@ -8880,7 +8792,7 @@
               <a:buNone/>
             </a:pPr>
             <a:r>
-              <a:rPr lang="en-US" sz="2400" dirty="0">
+              <a:rPr lang="en-US" sz="1800" dirty="0">
                 <a:solidFill>
                   <a:srgbClr val="00A6A6"/>
                 </a:solidFill>
@@ -8888,9 +8800,9 @@
                 <a:ea typeface="Aptos" pitchFamily="34" charset="-122"/>
                 <a:cs typeface="Aptos" pitchFamily="34" charset="-120"/>
               </a:rPr>
-              <a:t>›</a:t>
-            </a:r>
-            <a:endParaRPr lang="en-US" sz="2400" dirty="0"/>
+              <a:t>&gt;</a:t>
+            </a:r>
+            <a:endParaRPr lang="en-US" sz="1800" dirty="0"/>
           </a:p>
         </p:txBody>
       </p:sp>
@@ -9004,7 +8916,7 @@
               <a:buNone/>
             </a:pPr>
             <a:r>
-              <a:rPr lang="en-US" sz="2400" dirty="0">
+              <a:rPr lang="en-US" sz="1800" dirty="0">
                 <a:solidFill>
                   <a:srgbClr val="00A6A6"/>
                 </a:solidFill>
@@ -9012,9 +8924,9 @@
                 <a:ea typeface="Aptos" pitchFamily="34" charset="-122"/>
                 <a:cs typeface="Aptos" pitchFamily="34" charset="-120"/>
               </a:rPr>
-              <a:t>›</a:t>
-            </a:r>
-            <a:endParaRPr lang="en-US" sz="2400" dirty="0"/>
+              <a:t>&gt;</a:t>
+            </a:r>
+            <a:endParaRPr lang="en-US" sz="1800" dirty="0"/>
           </a:p>
         </p:txBody>
       </p:sp>
@@ -9128,7 +9040,7 @@
               <a:buNone/>
             </a:pPr>
             <a:r>
-              <a:rPr lang="en-US" sz="2400" dirty="0">
+              <a:rPr lang="en-US" sz="1800" dirty="0">
                 <a:solidFill>
                   <a:srgbClr val="00A6A6"/>
                 </a:solidFill>
@@ -9136,9 +9048,9 @@
                 <a:ea typeface="Aptos" pitchFamily="34" charset="-122"/>
                 <a:cs typeface="Aptos" pitchFamily="34" charset="-120"/>
               </a:rPr>
-              <a:t>›</a:t>
-            </a:r>
-            <a:endParaRPr lang="en-US" sz="2400" dirty="0"/>
+              <a:t>&gt;</a:t>
+            </a:r>
+            <a:endParaRPr lang="en-US" sz="1800" dirty="0"/>
           </a:p>
         </p:txBody>
       </p:sp>
@@ -9252,7 +9164,7 @@
               <a:buNone/>
             </a:pPr>
             <a:r>
-              <a:rPr lang="en-US" sz="2400" dirty="0">
+              <a:rPr lang="en-US" sz="1800" dirty="0">
                 <a:solidFill>
                   <a:srgbClr val="00A6A6"/>
                 </a:solidFill>
@@ -9260,9 +9172,9 @@
                 <a:ea typeface="Aptos" pitchFamily="34" charset="-122"/>
                 <a:cs typeface="Aptos" pitchFamily="34" charset="-120"/>
               </a:rPr>
-              <a:t>›</a:t>
-            </a:r>
-            <a:endParaRPr lang="en-US" sz="2400" dirty="0"/>
+              <a:t>&gt;</a:t>
+            </a:r>
+            <a:endParaRPr lang="en-US" sz="1800" dirty="0"/>
           </a:p>
         </p:txBody>
       </p:sp>
@@ -9376,7 +9288,7 @@
               <a:buNone/>
             </a:pPr>
             <a:r>
-              <a:rPr lang="en-US" sz="2400" dirty="0">
+              <a:rPr lang="en-US" sz="1800" dirty="0">
                 <a:solidFill>
                   <a:srgbClr val="00A6A6"/>
                 </a:solidFill>
@@ -9384,9 +9296,9 @@
                 <a:ea typeface="Aptos" pitchFamily="34" charset="-122"/>
                 <a:cs typeface="Aptos" pitchFamily="34" charset="-120"/>
               </a:rPr>
-              <a:t>›</a:t>
-            </a:r>
-            <a:endParaRPr lang="en-US" sz="2400" dirty="0"/>
+              <a:t>&gt;</a:t>
+            </a:r>
+            <a:endParaRPr lang="en-US" sz="1800" dirty="0"/>
           </a:p>
         </p:txBody>
       </p:sp>
@@ -11039,7 +10951,7 @@
                 <a:ea typeface="Aptos" pitchFamily="34" charset="-122"/>
                 <a:cs typeface="Aptos" pitchFamily="34" charset="-120"/>
               </a:rPr>
-              <a:t>• Crack</a:t>
+              <a:t>- Crack</a:t>
             </a:r>
             <a:endParaRPr lang="en-US" sz="1700" dirty="0"/>
           </a:p>
@@ -11056,7 +10968,7 @@
                 <a:ea typeface="Aptos" pitchFamily="34" charset="-122"/>
                 <a:cs typeface="Aptos" pitchFamily="34" charset="-120"/>
               </a:rPr>
-              <a:t>• Breakage</a:t>
+              <a:t>- Breakage</a:t>
             </a:r>
             <a:endParaRPr lang="en-US" sz="1700" dirty="0"/>
           </a:p>
@@ -11073,7 +10985,7 @@
                 <a:ea typeface="Aptos" pitchFamily="34" charset="-122"/>
                 <a:cs typeface="Aptos" pitchFamily="34" charset="-120"/>
               </a:rPr>
-              <a:t>• Honeycombing</a:t>
+              <a:t>- Honeycombing</a:t>
             </a:r>
             <a:endParaRPr lang="en-US" sz="1700" dirty="0"/>
           </a:p>
@@ -11090,7 +11002,7 @@
                 <a:ea typeface="Aptos" pitchFamily="34" charset="-122"/>
                 <a:cs typeface="Aptos" pitchFamily="34" charset="-120"/>
               </a:rPr>
-              <a:t>• Hole</a:t>
+              <a:t>- Hole</a:t>
             </a:r>
             <a:endParaRPr lang="en-US" sz="1700" dirty="0"/>
           </a:p>
@@ -11107,7 +11019,7 @@
                 <a:ea typeface="Aptos" pitchFamily="34" charset="-122"/>
                 <a:cs typeface="Aptos" pitchFamily="34" charset="-120"/>
               </a:rPr>
-              <a:t>• Exposed Reinforcement</a:t>
+              <a:t>- Exposed Reinforcement</a:t>
             </a:r>
             <a:endParaRPr lang="en-US" sz="1700" dirty="0"/>
           </a:p>
@@ -11124,7 +11036,7 @@
                 <a:ea typeface="Aptos" pitchFamily="34" charset="-122"/>
                 <a:cs typeface="Aptos" pitchFamily="34" charset="-120"/>
               </a:rPr>
-              <a:t>• Seepage</a:t>
+              <a:t>- Seepage</a:t>
             </a:r>
             <a:endParaRPr lang="en-US" sz="1700" dirty="0"/>
           </a:p>
@@ -12076,7 +11988,7 @@
                 <a:ea typeface="Aptos" pitchFamily="34" charset="-122"/>
                 <a:cs typeface="Aptos" pitchFamily="34" charset="-120"/>
               </a:rPr>
-              <a:t>• 1,053 test images; 5,886 instances</a:t>
+              <a:t>- 1,053 test images; 5,886 instances</a:t>
             </a:r>
             <a:endParaRPr lang="en-US" sz="1450" dirty="0"/>
           </a:p>
@@ -12093,7 +12005,7 @@
                 <a:ea typeface="Aptos" pitchFamily="34" charset="-122"/>
                 <a:cs typeface="Aptos" pitchFamily="34" charset="-120"/>
               </a:rPr>
-              <a:t>• Validation-selected operating threshold: 0.18618618618618618</a:t>
+              <a:t>- Validation-selected operating threshold: 0.18618618618618618</a:t>
             </a:r>
             <a:endParaRPr lang="en-US" sz="1450" dirty="0"/>
           </a:p>
@@ -12110,7 +12022,7 @@
                 <a:ea typeface="Aptos" pitchFamily="34" charset="-122"/>
                 <a:cs typeface="Aptos" pitchFamily="34" charset="-120"/>
               </a:rPr>
-              <a:t>• Macro precision: 0.37674095487474335</a:t>
+              <a:t>- Macro precision: 0.37674095487474335</a:t>
             </a:r>
             <a:endParaRPr lang="en-US" sz="1450" dirty="0"/>
           </a:p>
@@ -12127,7 +12039,7 @@
                 <a:ea typeface="Aptos" pitchFamily="34" charset="-122"/>
                 <a:cs typeface="Aptos" pitchFamily="34" charset="-120"/>
               </a:rPr>
-              <a:t>• Macro recall: 0.37432339044543</a:t>
+              <a:t>- Macro recall: 0.37432339044543</a:t>
             </a:r>
             <a:endParaRPr lang="en-US" sz="1450" dirty="0"/>
           </a:p>
@@ -12168,7 +12080,7 @@
                 <a:ea typeface="Aptos" pitchFamily="34" charset="-122"/>
                 <a:cs typeface="Aptos" pitchFamily="34" charset="-120"/>
               </a:rPr>
-              <a:t>mAP is a detection metric, not generic or “drone” accuracy. The operating threshold was selected using validation data, not the test set.</a:t>
+              <a:t>mAP is a detection metric, not generic or drone accuracy. The operating threshold was selected using validation data, not the test set.</a:t>
             </a:r>
             <a:endParaRPr lang="en-US" sz="1450" dirty="0"/>
           </a:p>
@@ -12513,7 +12425,7 @@
                 <a:ea typeface="Aptos" pitchFamily="34" charset="-122"/>
                 <a:cs typeface="Aptos" pitchFamily="34" charset="-120"/>
               </a:rPr>
-              <a:t>• ROS 2 Lyrical and Gazebo Sim 10.5.0</a:t>
+              <a:t>- ROS 2 Lyrical and Gazebo Sim 10.5.0</a:t>
             </a:r>
             <a:endParaRPr lang="en-US" sz="1700" dirty="0"/>
           </a:p>
@@ -12530,7 +12442,7 @@
                 <a:ea typeface="Aptos" pitchFamily="34" charset="-122"/>
                 <a:cs typeface="Aptos" pitchFamily="34" charset="-120"/>
               </a:rPr>
-              <a:t>• RGB, CameraInfo, IMU, 3D LiDAR, depth, simulation clock and TF</a:t>
+              <a:t>- RGB, CameraInfo, IMU, 3D LiDAR, depth, simulation clock and TF</a:t>
             </a:r>
             <a:endParaRPr lang="en-US" sz="1700" dirty="0"/>
           </a:p>
@@ -12547,7 +12459,7 @@
                 <a:ea typeface="Aptos" pitchFamily="34" charset="-122"/>
                 <a:cs typeface="Aptos" pitchFamily="34" charset="-120"/>
               </a:rPr>
-              <a:t>• Accepted LiDAR ICP runtime acceptance: PASS</a:t>
+              <a:t>- Accepted LiDAR ICP runtime acceptance: PASS</a:t>
             </a:r>
             <a:endParaRPr lang="en-US" sz="1700" dirty="0"/>
           </a:p>
@@ -12564,7 +12476,7 @@
                 <a:ea typeface="Aptos" pitchFamily="34" charset="-122"/>
                 <a:cs typeface="Aptos" pitchFamily="34" charset="-120"/>
               </a:rPr>
-              <a:t>• Localization accuracy is MEASURED against simulation ground truth</a:t>
+              <a:t>- Localization accuracy is MEASURED against simulation ground truth</a:t>
             </a:r>
             <a:endParaRPr lang="en-US" sz="1700" dirty="0"/>
           </a:p>
@@ -14345,7 +14257,7 @@
                 <a:ea typeface="Aptos" pitchFamily="34" charset="-122"/>
                 <a:cs typeface="Aptos" pitchFamily="34" charset="-120"/>
               </a:rPr>
-              <a:t>• Detection / track</a:t>
+              <a:t>- Detection / track</a:t>
             </a:r>
             <a:endParaRPr lang="en-US" sz="1600" dirty="0"/>
           </a:p>
@@ -14362,7 +14274,7 @@
                 <a:ea typeface="Aptos" pitchFamily="34" charset="-122"/>
                 <a:cs typeface="Aptos" pitchFamily="34" charset="-120"/>
               </a:rPr>
-              <a:t>• Robust depth</a:t>
+              <a:t>- Robust depth</a:t>
             </a:r>
             <a:endParaRPr lang="en-US" sz="1600" dirty="0"/>
           </a:p>
@@ -14379,7 +14291,7 @@
                 <a:ea typeface="Aptos" pitchFamily="34" charset="-122"/>
                 <a:cs typeface="Aptos" pitchFamily="34" charset="-120"/>
               </a:rPr>
-              <a:t>• Camera XYZ</a:t>
+              <a:t>- Camera XYZ</a:t>
             </a:r>
             <a:endParaRPr lang="en-US" sz="1600" dirty="0"/>
           </a:p>
@@ -14396,7 +14308,7 @@
                 <a:ea typeface="Aptos" pitchFamily="34" charset="-122"/>
                 <a:cs typeface="Aptos" pitchFamily="34" charset="-120"/>
               </a:rPr>
-              <a:t>• Pose transform</a:t>
+              <a:t>- Pose transform</a:t>
             </a:r>
             <a:endParaRPr lang="en-US" sz="1600" dirty="0"/>
           </a:p>
@@ -14413,7 +14325,7 @@
                 <a:ea typeface="Aptos" pitchFamily="34" charset="-122"/>
                 <a:cs typeface="Aptos" pitchFamily="34" charset="-120"/>
               </a:rPr>
-              <a:t>• Map XYZ</a:t>
+              <a:t>- Map XYZ</a:t>
             </a:r>
             <a:endParaRPr lang="en-US" sz="1600" dirty="0"/>
           </a:p>
@@ -14430,7 +14342,7 @@
                 <a:ea typeface="Aptos" pitchFamily="34" charset="-122"/>
                 <a:cs typeface="Aptos" pitchFamily="34" charset="-120"/>
               </a:rPr>
-              <a:t>• Temporal aggregation</a:t>
+              <a:t>- Temporal aggregation</a:t>
             </a:r>
             <a:endParaRPr lang="en-US" sz="1600" dirty="0"/>
           </a:p>
@@ -14447,7 +14359,7 @@
                 <a:ea typeface="Aptos" pitchFamily="34" charset="-122"/>
                 <a:cs typeface="Aptos" pitchFamily="34" charset="-120"/>
               </a:rPr>
-              <a:t>• Persistent defect record</a:t>
+              <a:t>- Persistent defect record</a:t>
             </a:r>
             <a:endParaRPr lang="en-US" sz="1600" dirty="0"/>
           </a:p>

</xml_diff>

<commit_message>
docs(p20): harden working deck for final evidence
</commit_message>
<xml_diff>
--- a/outputs/presentation/AegisInspect_P20_working_draft.pptx
+++ b/outputs/presentation/AegisInspect_P20_working_draft.pptx
@@ -977,7 +977,7 @@
               <a:t>WORKING DRAFT
 Assembly source: docs/presentation/assembly/slide_content.md
 Assembly SHA-256: 76829ec39dff392479c4db9b50683b24143c96080f5eeef56148a6cf06412415
-Assembly P19 3D pending boundary.</a:t>
+Assembly P19 3D pending boundary and late-evidence slot.</a:t>
             </a:r>
             <a:endParaRPr lang="en-US" dirty="0"/>
           </a:p>
@@ -1068,7 +1068,7 @@
               <a:t>WORKING DRAFT
 Assembly source: docs/presentation/assembly/slide_content.md
 Assembly SHA-256: 76829ec39dff392479c4db9b50683b24143c96080f5eeef56148a6cf06412415
-Assembly Workstream 04 pending statement.</a:t>
+Assembly Workstream 04 pending statement and late-evidence slot.</a:t>
             </a:r>
             <a:endParaRPr lang="en-US" dirty="0"/>
           </a:p>
@@ -3736,13 +3736,13 @@
         </p:nvPicPr>
         <p:blipFill>
           <a:blip r:embed="rId1"/>
-          <a:srcRect l="0" r="0" t="0" b="0"/>
+          <a:srcRect l="5680" r="-5680" t="29358" b="-29358"/>
           <a:stretch/>
         </p:blipFill>
         <p:spPr>
           <a:xfrm>
-            <a:off x="594360" y="1572768"/>
-            <a:ext cx="6675120" cy="4343400"/>
+            <a:off x="438912" y="1463040"/>
+            <a:ext cx="7726680" cy="4983480"/>
           </a:xfrm>
           <a:prstGeom prst="rect">
             <a:avLst/>
@@ -3757,12 +3757,12 @@
         </p:nvSpPr>
         <p:spPr>
           <a:xfrm>
-            <a:off x="7635240" y="1755648"/>
-            <a:ext cx="3291840" cy="1024128"/>
+            <a:off x="8458200" y="1691640"/>
+            <a:ext cx="2926080" cy="1005840"/>
           </a:xfrm>
           <a:prstGeom prst="roundRect">
             <a:avLst>
-              <a:gd name="adj" fmla="val 4464"/>
+              <a:gd name="adj" fmla="val 4545"/>
             </a:avLst>
           </a:prstGeom>
           <a:solidFill>
@@ -3784,8 +3784,8 @@
         </p:nvSpPr>
         <p:spPr>
           <a:xfrm>
-            <a:off x="7635240" y="1755648"/>
-            <a:ext cx="73152" cy="1024128"/>
+            <a:off x="8458200" y="1691640"/>
+            <a:ext cx="73152" cy="1005840"/>
           </a:xfrm>
           <a:prstGeom prst="rect">
             <a:avLst/>
@@ -3809,8 +3809,8 @@
         </p:nvSpPr>
         <p:spPr>
           <a:xfrm>
-            <a:off x="7836408" y="1911096"/>
-            <a:ext cx="2980944" cy="146304"/>
+            <a:off x="8659368" y="1847088"/>
+            <a:ext cx="2615184" cy="146304"/>
           </a:xfrm>
           <a:prstGeom prst="rect">
             <a:avLst/>
@@ -3850,8 +3850,8 @@
         </p:nvSpPr>
         <p:spPr>
           <a:xfrm>
-            <a:off x="7836408" y="2148840"/>
-            <a:ext cx="2980944" cy="384048"/>
+            <a:off x="8659368" y="2084832"/>
+            <a:ext cx="2615184" cy="365760"/>
           </a:xfrm>
           <a:prstGeom prst="rect">
             <a:avLst/>
@@ -3891,8 +3891,8 @@
         </p:nvSpPr>
         <p:spPr>
           <a:xfrm>
-            <a:off x="7836408" y="2523744"/>
-            <a:ext cx="2980944" cy="137160"/>
+            <a:off x="8659368" y="2441448"/>
+            <a:ext cx="2615184" cy="137160"/>
           </a:xfrm>
           <a:prstGeom prst="rect">
             <a:avLst/>
@@ -3932,8 +3932,8 @@
         </p:nvSpPr>
         <p:spPr>
           <a:xfrm>
-            <a:off x="7589520" y="3182112"/>
-            <a:ext cx="3429000" cy="1508760"/>
+            <a:off x="8430768" y="2999232"/>
+            <a:ext cx="2907792" cy="1783080"/>
           </a:xfrm>
           <a:prstGeom prst="rect">
             <a:avLst/>
@@ -3951,7 +3951,7 @@
               <a:buNone/>
             </a:pPr>
             <a:r>
-              <a:rPr lang="en-US" sz="1450" dirty="0">
+              <a:rPr lang="en-US" sz="1230" dirty="0">
                 <a:solidFill>
                   <a:srgbClr val="17212B"/>
                 </a:solidFill>
@@ -3961,7 +3961,7 @@
               </a:rPr>
               <a:t>The first integrated retry validated the same-observation data chain, but its browser capture was absent. The separate dashboard-evidence completion package supplies the accepted real dashboard capture.</a:t>
             </a:r>
-            <a:endParaRPr lang="en-US" sz="1450" dirty="0"/>
+            <a:endParaRPr lang="en-US" sz="1230" dirty="0"/>
           </a:p>
         </p:txBody>
       </p:sp>
@@ -3973,8 +3973,8 @@
         </p:nvSpPr>
         <p:spPr>
           <a:xfrm>
-            <a:off x="7607808" y="5138928"/>
-            <a:ext cx="3383280" cy="438912"/>
+            <a:off x="8430768" y="5230368"/>
+            <a:ext cx="2907792" cy="502920"/>
           </a:xfrm>
           <a:prstGeom prst="rect">
             <a:avLst/>
@@ -3992,7 +3992,7 @@
               <a:buNone/>
             </a:pPr>
             <a:r>
-              <a:rPr lang="en-US" sz="1150" b="1" dirty="0">
+              <a:rPr lang="en-US" sz="1070" b="1" dirty="0">
                 <a:solidFill>
                   <a:srgbClr val="B42318"/>
                 </a:solidFill>
@@ -4002,7 +4002,7 @@
               </a:rPr>
               <a:t>This demonstrates integrated runtime and dashboard evidence; it does not establish full autonomy or production readiness.</a:t>
             </a:r>
-            <a:endParaRPr lang="en-US" sz="1150" dirty="0"/>
+            <a:endParaRPr lang="en-US" sz="1070" dirty="0"/>
           </a:p>
         </p:txBody>
       </p:sp>
@@ -4320,13 +4320,13 @@
         </p:nvPicPr>
         <p:blipFill>
           <a:blip r:embed="rId1"/>
-          <a:srcRect l="0" r="0" t="0" b="0"/>
+          <a:srcRect l="5680" r="-5680" t="29358" b="-29358"/>
           <a:stretch/>
         </p:blipFill>
         <p:spPr>
           <a:xfrm>
-            <a:off x="594360" y="1572768"/>
-            <a:ext cx="6675120" cy="4343400"/>
+            <a:off x="438912" y="1463040"/>
+            <a:ext cx="7726680" cy="4983480"/>
           </a:xfrm>
           <a:prstGeom prst="rect">
             <a:avLst/>
@@ -4341,12 +4341,12 @@
         </p:nvSpPr>
         <p:spPr>
           <a:xfrm>
-            <a:off x="7635240" y="1755648"/>
-            <a:ext cx="3291840" cy="1024128"/>
+            <a:off x="8458200" y="1691640"/>
+            <a:ext cx="2926080" cy="1005840"/>
           </a:xfrm>
           <a:prstGeom prst="roundRect">
             <a:avLst>
-              <a:gd name="adj" fmla="val 4464"/>
+              <a:gd name="adj" fmla="val 4545"/>
             </a:avLst>
           </a:prstGeom>
           <a:solidFill>
@@ -4368,8 +4368,8 @@
         </p:nvSpPr>
         <p:spPr>
           <a:xfrm>
-            <a:off x="7635240" y="1755648"/>
-            <a:ext cx="73152" cy="1024128"/>
+            <a:off x="8458200" y="1691640"/>
+            <a:ext cx="73152" cy="1005840"/>
           </a:xfrm>
           <a:prstGeom prst="rect">
             <a:avLst/>
@@ -4393,8 +4393,8 @@
         </p:nvSpPr>
         <p:spPr>
           <a:xfrm>
-            <a:off x="7836408" y="1911096"/>
-            <a:ext cx="2980944" cy="146304"/>
+            <a:off x="8659368" y="1847088"/>
+            <a:ext cx="2615184" cy="146304"/>
           </a:xfrm>
           <a:prstGeom prst="rect">
             <a:avLst/>
@@ -4434,8 +4434,8 @@
         </p:nvSpPr>
         <p:spPr>
           <a:xfrm>
-            <a:off x="7836408" y="2148840"/>
-            <a:ext cx="2980944" cy="384048"/>
+            <a:off x="8659368" y="2084832"/>
+            <a:ext cx="2615184" cy="365760"/>
           </a:xfrm>
           <a:prstGeom prst="rect">
             <a:avLst/>
@@ -4475,8 +4475,8 @@
         </p:nvSpPr>
         <p:spPr>
           <a:xfrm>
-            <a:off x="7836408" y="2523744"/>
-            <a:ext cx="2980944" cy="137160"/>
+            <a:off x="8659368" y="2441448"/>
+            <a:ext cx="2615184" cy="137160"/>
           </a:xfrm>
           <a:prstGeom prst="rect">
             <a:avLst/>
@@ -4516,8 +4516,8 @@
         </p:nvSpPr>
         <p:spPr>
           <a:xfrm>
-            <a:off x="7589520" y="3182112"/>
-            <a:ext cx="3429000" cy="1508760"/>
+            <a:off x="8430768" y="2999232"/>
+            <a:ext cx="2907792" cy="1783080"/>
           </a:xfrm>
           <a:prstGeom prst="rect">
             <a:avLst/>
@@ -4535,7 +4535,7 @@
               <a:buNone/>
             </a:pPr>
             <a:r>
-              <a:rPr lang="en-US" sz="1450" dirty="0">
+              <a:rPr lang="en-US" sz="1230" dirty="0">
                 <a:solidFill>
                   <a:srgbClr val="17212B"/>
                 </a:solidFill>
@@ -4545,7 +4545,7 @@
               </a:rPr>
               <a:t>The clean repeatability package records a new detection and mapped-defect identity, P16 PASS, browser screenshots PASS and P17 PASS under unchanged source and configuration.</a:t>
             </a:r>
-            <a:endParaRPr lang="en-US" sz="1450" dirty="0"/>
+            <a:endParaRPr lang="en-US" sz="1230" dirty="0"/>
           </a:p>
         </p:txBody>
       </p:sp>
@@ -4557,8 +4557,8 @@
         </p:nvSpPr>
         <p:spPr>
           <a:xfrm>
-            <a:off x="7607808" y="5138928"/>
-            <a:ext cx="3383280" cy="438912"/>
+            <a:off x="8430768" y="5230368"/>
+            <a:ext cx="2907792" cy="502920"/>
           </a:xfrm>
           <a:prstGeom prst="rect">
             <a:avLst/>
@@ -4576,7 +4576,7 @@
               <a:buNone/>
             </a:pPr>
             <a:r>
-              <a:rPr lang="en-US" sz="1150" b="1" dirty="0">
+              <a:rPr lang="en-US" sz="1070" b="1" dirty="0">
                 <a:solidFill>
                   <a:srgbClr val="B42318"/>
                 </a:solidFill>
@@ -4586,7 +4586,7 @@
               </a:rPr>
               <a:t>P19 3D correspondence and Workstream 04 evidence remain pending.</a:t>
             </a:r>
-            <a:endParaRPr lang="en-US" sz="1150" dirty="0"/>
+            <a:endParaRPr lang="en-US" sz="1070" dirty="0"/>
           </a:p>
         </p:txBody>
       </p:sp>
@@ -5813,8 +5813,8 @@
         </p:nvSpPr>
         <p:spPr>
           <a:xfrm>
-            <a:off x="914400" y="2057400"/>
-            <a:ext cx="10241280" cy="502920"/>
+            <a:off x="731520" y="1508760"/>
+            <a:ext cx="10698480" cy="365760"/>
           </a:xfrm>
           <a:prstGeom prst="rect">
             <a:avLst/>
@@ -5832,7 +5832,7 @@
               <a:buNone/>
             </a:pPr>
             <a:r>
-              <a:rPr lang="en-US" sz="2500" b="1" dirty="0">
+              <a:rPr lang="en-US" sz="2200" b="1" dirty="0">
                 <a:solidFill>
                   <a:srgbClr val="0B1F33"/>
                 </a:solidFill>
@@ -5840,22 +5840,457 @@
                 <a:ea typeface="Aptos" pitchFamily="34" charset="-122"/>
                 <a:cs typeface="Aptos" pitchFamily="34" charset="-120"/>
               </a:rPr>
-              <a:t>P19 3D evaluation - pending controlled correspondence experiment</a:t>
-            </a:r>
-            <a:endParaRPr lang="en-US" sz="2500" dirty="0"/>
-          </a:p>
-        </p:txBody>
-      </p:sp>
-      <p:sp>
-        <p:nvSpPr>
-          <p:cNvPr id="8" name="Text 6"/>
-          <p:cNvSpPr/>
-          <p:nvPr/>
-        </p:nvSpPr>
-        <p:spPr>
-          <a:xfrm>
-            <a:off x="1143000" y="3246120"/>
-            <a:ext cx="9784080" cy="868680"/>
+              <a:t>P19 3D correspondence - pending controlled experiment</a:t>
+            </a:r>
+            <a:endParaRPr lang="en-US" sz="2200" dirty="0"/>
+          </a:p>
+        </p:txBody>
+      </p:sp>
+      <p:sp>
+        <p:nvSpPr>
+          <p:cNvPr id="8" name="Shape 6"/>
+          <p:cNvSpPr/>
+          <p:nvPr/>
+        </p:nvSpPr>
+        <p:spPr>
+          <a:xfrm>
+            <a:off x="731520" y="2240280"/>
+            <a:ext cx="3154680" cy="530352"/>
+          </a:xfrm>
+          <a:prstGeom prst="roundRect">
+            <a:avLst>
+              <a:gd name="adj" fmla="val 6897"/>
+            </a:avLst>
+          </a:prstGeom>
+          <a:solidFill>
+            <a:srgbClr val="FFF9EC"/>
+          </a:solidFill>
+          <a:ln w="7620">
+            <a:solidFill>
+              <a:srgbClr val="E8C878"/>
+            </a:solidFill>
+            <a:prstDash val="solid"/>
+          </a:ln>
+        </p:spPr>
+      </p:sp>
+      <p:sp>
+        <p:nvSpPr>
+          <p:cNvPr id="9" name="Text 7"/>
+          <p:cNvSpPr/>
+          <p:nvPr/>
+        </p:nvSpPr>
+        <p:spPr>
+          <a:xfrm>
+            <a:off x="896112" y="2423160"/>
+            <a:ext cx="2788920" cy="128016"/>
+          </a:xfrm>
+          <a:prstGeom prst="rect">
+            <a:avLst/>
+          </a:prstGeom>
+          <a:noFill/>
+          <a:ln/>
+        </p:spPr>
+        <p:txBody>
+          <a:bodyPr wrap="square" lIns="0" tIns="0" rIns="0" bIns="0" rtlCol="0" anchor="ctr">
+            <a:normAutofit/>
+          </a:bodyPr>
+          <a:lstStyle/>
+          <a:p>
+            <a:pPr indent="0" marL="0">
+              <a:buNone/>
+            </a:pPr>
+            <a:r>
+              <a:rPr lang="en-US" sz="1000" dirty="0">
+                <a:solidFill>
+                  <a:srgbClr val="52616B"/>
+                </a:solidFill>
+                <a:latin typeface="Aptos" pitchFamily="34" charset="0"/>
+                <a:ea typeface="Aptos" pitchFamily="34" charset="-122"/>
+                <a:cs typeface="Aptos" pitchFamily="34" charset="-120"/>
+              </a:rPr>
+              <a:t>GT defect ID: pending</a:t>
+            </a:r>
+            <a:endParaRPr lang="en-US" sz="1000" dirty="0"/>
+          </a:p>
+        </p:txBody>
+      </p:sp>
+      <p:sp>
+        <p:nvSpPr>
+          <p:cNvPr id="10" name="Shape 8"/>
+          <p:cNvSpPr/>
+          <p:nvPr/>
+        </p:nvSpPr>
+        <p:spPr>
+          <a:xfrm>
+            <a:off x="4206240" y="2240280"/>
+            <a:ext cx="3154680" cy="530352"/>
+          </a:xfrm>
+          <a:prstGeom prst="roundRect">
+            <a:avLst>
+              <a:gd name="adj" fmla="val 6897"/>
+            </a:avLst>
+          </a:prstGeom>
+          <a:solidFill>
+            <a:srgbClr val="FFF9EC"/>
+          </a:solidFill>
+          <a:ln w="7620">
+            <a:solidFill>
+              <a:srgbClr val="E8C878"/>
+            </a:solidFill>
+            <a:prstDash val="solid"/>
+          </a:ln>
+        </p:spPr>
+      </p:sp>
+      <p:sp>
+        <p:nvSpPr>
+          <p:cNvPr id="11" name="Text 9"/>
+          <p:cNvSpPr/>
+          <p:nvPr/>
+        </p:nvSpPr>
+        <p:spPr>
+          <a:xfrm>
+            <a:off x="4370832" y="2423160"/>
+            <a:ext cx="2788920" cy="128016"/>
+          </a:xfrm>
+          <a:prstGeom prst="rect">
+            <a:avLst/>
+          </a:prstGeom>
+          <a:noFill/>
+          <a:ln/>
+        </p:spPr>
+        <p:txBody>
+          <a:bodyPr wrap="square" lIns="0" tIns="0" rIns="0" bIns="0" rtlCol="0" anchor="ctr">
+            <a:normAutofit/>
+          </a:bodyPr>
+          <a:lstStyle/>
+          <a:p>
+            <a:pPr indent="0" marL="0">
+              <a:buNone/>
+            </a:pPr>
+            <a:r>
+              <a:rPr lang="en-US" sz="1000" dirty="0">
+                <a:solidFill>
+                  <a:srgbClr val="52616B"/>
+                </a:solidFill>
+                <a:latin typeface="Aptos" pitchFamily="34" charset="0"/>
+                <a:ea typeface="Aptos" pitchFamily="34" charset="-122"/>
+                <a:cs typeface="Aptos" pitchFamily="34" charset="-120"/>
+              </a:rPr>
+              <a:t>Mapped defect ID: pending</a:t>
+            </a:r>
+            <a:endParaRPr lang="en-US" sz="1000" dirty="0"/>
+          </a:p>
+        </p:txBody>
+      </p:sp>
+      <p:sp>
+        <p:nvSpPr>
+          <p:cNvPr id="12" name="Shape 10"/>
+          <p:cNvSpPr/>
+          <p:nvPr/>
+        </p:nvSpPr>
+        <p:spPr>
+          <a:xfrm>
+            <a:off x="731520" y="3026664"/>
+            <a:ext cx="3154680" cy="530352"/>
+          </a:xfrm>
+          <a:prstGeom prst="roundRect">
+            <a:avLst>
+              <a:gd name="adj" fmla="val 6897"/>
+            </a:avLst>
+          </a:prstGeom>
+          <a:solidFill>
+            <a:srgbClr val="FFF9EC"/>
+          </a:solidFill>
+          <a:ln w="7620">
+            <a:solidFill>
+              <a:srgbClr val="E8C878"/>
+            </a:solidFill>
+            <a:prstDash val="solid"/>
+          </a:ln>
+        </p:spPr>
+      </p:sp>
+      <p:sp>
+        <p:nvSpPr>
+          <p:cNvPr id="13" name="Text 11"/>
+          <p:cNvSpPr/>
+          <p:nvPr/>
+        </p:nvSpPr>
+        <p:spPr>
+          <a:xfrm>
+            <a:off x="896112" y="3209544"/>
+            <a:ext cx="2788920" cy="128016"/>
+          </a:xfrm>
+          <a:prstGeom prst="rect">
+            <a:avLst/>
+          </a:prstGeom>
+          <a:noFill/>
+          <a:ln/>
+        </p:spPr>
+        <p:txBody>
+          <a:bodyPr wrap="square" lIns="0" tIns="0" rIns="0" bIns="0" rtlCol="0" anchor="ctr">
+            <a:normAutofit/>
+          </a:bodyPr>
+          <a:lstStyle/>
+          <a:p>
+            <a:pPr indent="0" marL="0">
+              <a:buNone/>
+            </a:pPr>
+            <a:r>
+              <a:rPr lang="en-US" sz="1000" dirty="0">
+                <a:solidFill>
+                  <a:srgbClr val="52616B"/>
+                </a:solidFill>
+                <a:latin typeface="Aptos" pitchFamily="34" charset="0"/>
+                <a:ea typeface="Aptos" pitchFamily="34" charset="-122"/>
+                <a:cs typeface="Aptos" pitchFamily="34" charset="-120"/>
+              </a:rPr>
+              <a:t>Estimated XYZ: pending</a:t>
+            </a:r>
+            <a:endParaRPr lang="en-US" sz="1000" dirty="0"/>
+          </a:p>
+        </p:txBody>
+      </p:sp>
+      <p:sp>
+        <p:nvSpPr>
+          <p:cNvPr id="14" name="Shape 12"/>
+          <p:cNvSpPr/>
+          <p:nvPr/>
+        </p:nvSpPr>
+        <p:spPr>
+          <a:xfrm>
+            <a:off x="4206240" y="3026664"/>
+            <a:ext cx="3154680" cy="530352"/>
+          </a:xfrm>
+          <a:prstGeom prst="roundRect">
+            <a:avLst>
+              <a:gd name="adj" fmla="val 6897"/>
+            </a:avLst>
+          </a:prstGeom>
+          <a:solidFill>
+            <a:srgbClr val="FFF9EC"/>
+          </a:solidFill>
+          <a:ln w="7620">
+            <a:solidFill>
+              <a:srgbClr val="E8C878"/>
+            </a:solidFill>
+            <a:prstDash val="solid"/>
+          </a:ln>
+        </p:spPr>
+      </p:sp>
+      <p:sp>
+        <p:nvSpPr>
+          <p:cNvPr id="15" name="Text 13"/>
+          <p:cNvSpPr/>
+          <p:nvPr/>
+        </p:nvSpPr>
+        <p:spPr>
+          <a:xfrm>
+            <a:off x="4370832" y="3209544"/>
+            <a:ext cx="2788920" cy="128016"/>
+          </a:xfrm>
+          <a:prstGeom prst="rect">
+            <a:avLst/>
+          </a:prstGeom>
+          <a:noFill/>
+          <a:ln/>
+        </p:spPr>
+        <p:txBody>
+          <a:bodyPr wrap="square" lIns="0" tIns="0" rIns="0" bIns="0" rtlCol="0" anchor="ctr">
+            <a:normAutofit/>
+          </a:bodyPr>
+          <a:lstStyle/>
+          <a:p>
+            <a:pPr indent="0" marL="0">
+              <a:buNone/>
+            </a:pPr>
+            <a:r>
+              <a:rPr lang="en-US" sz="1000" dirty="0">
+                <a:solidFill>
+                  <a:srgbClr val="52616B"/>
+                </a:solidFill>
+                <a:latin typeface="Aptos" pitchFamily="34" charset="0"/>
+                <a:ea typeface="Aptos" pitchFamily="34" charset="-122"/>
+                <a:cs typeface="Aptos" pitchFamily="34" charset="-120"/>
+              </a:rPr>
+              <a:t>Ground-truth XYZ: pending</a:t>
+            </a:r>
+            <a:endParaRPr lang="en-US" sz="1000" dirty="0"/>
+          </a:p>
+        </p:txBody>
+      </p:sp>
+      <p:sp>
+        <p:nvSpPr>
+          <p:cNvPr id="16" name="Shape 14"/>
+          <p:cNvSpPr/>
+          <p:nvPr/>
+        </p:nvSpPr>
+        <p:spPr>
+          <a:xfrm>
+            <a:off x="731520" y="3813048"/>
+            <a:ext cx="3154680" cy="530352"/>
+          </a:xfrm>
+          <a:prstGeom prst="roundRect">
+            <a:avLst>
+              <a:gd name="adj" fmla="val 6897"/>
+            </a:avLst>
+          </a:prstGeom>
+          <a:solidFill>
+            <a:srgbClr val="FFF9EC"/>
+          </a:solidFill>
+          <a:ln w="7620">
+            <a:solidFill>
+              <a:srgbClr val="E8C878"/>
+            </a:solidFill>
+            <a:prstDash val="solid"/>
+          </a:ln>
+        </p:spPr>
+      </p:sp>
+      <p:sp>
+        <p:nvSpPr>
+          <p:cNvPr id="17" name="Text 15"/>
+          <p:cNvSpPr/>
+          <p:nvPr/>
+        </p:nvSpPr>
+        <p:spPr>
+          <a:xfrm>
+            <a:off x="896112" y="3995928"/>
+            <a:ext cx="2788920" cy="128016"/>
+          </a:xfrm>
+          <a:prstGeom prst="rect">
+            <a:avLst/>
+          </a:prstGeom>
+          <a:noFill/>
+          <a:ln/>
+        </p:spPr>
+        <p:txBody>
+          <a:bodyPr wrap="square" lIns="0" tIns="0" rIns="0" bIns="0" rtlCol="0" anchor="ctr">
+            <a:normAutofit/>
+          </a:bodyPr>
+          <a:lstStyle/>
+          <a:p>
+            <a:pPr indent="0" marL="0">
+              <a:buNone/>
+            </a:pPr>
+            <a:r>
+              <a:rPr lang="en-US" sz="1000" dirty="0">
+                <a:solidFill>
+                  <a:srgbClr val="52616B"/>
+                </a:solidFill>
+                <a:latin typeface="Aptos" pitchFamily="34" charset="0"/>
+                <a:ea typeface="Aptos" pitchFamily="34" charset="-122"/>
+                <a:cs typeface="Aptos" pitchFamily="34" charset="-120"/>
+              </a:rPr>
+              <a:t>Euclidean 3D error: pending</a:t>
+            </a:r>
+            <a:endParaRPr lang="en-US" sz="1000" dirty="0"/>
+          </a:p>
+        </p:txBody>
+      </p:sp>
+      <p:sp>
+        <p:nvSpPr>
+          <p:cNvPr id="18" name="Shape 16"/>
+          <p:cNvSpPr/>
+          <p:nvPr/>
+        </p:nvSpPr>
+        <p:spPr>
+          <a:xfrm>
+            <a:off x="4206240" y="3813048"/>
+            <a:ext cx="3154680" cy="530352"/>
+          </a:xfrm>
+          <a:prstGeom prst="roundRect">
+            <a:avLst>
+              <a:gd name="adj" fmla="val 6897"/>
+            </a:avLst>
+          </a:prstGeom>
+          <a:solidFill>
+            <a:srgbClr val="FFF9EC"/>
+          </a:solidFill>
+          <a:ln w="7620">
+            <a:solidFill>
+              <a:srgbClr val="E8C878"/>
+            </a:solidFill>
+            <a:prstDash val="solid"/>
+          </a:ln>
+        </p:spPr>
+      </p:sp>
+      <p:sp>
+        <p:nvSpPr>
+          <p:cNvPr id="19" name="Text 17"/>
+          <p:cNvSpPr/>
+          <p:nvPr/>
+        </p:nvSpPr>
+        <p:spPr>
+          <a:xfrm>
+            <a:off x="4370832" y="3995928"/>
+            <a:ext cx="2788920" cy="128016"/>
+          </a:xfrm>
+          <a:prstGeom prst="rect">
+            <a:avLst/>
+          </a:prstGeom>
+          <a:noFill/>
+          <a:ln/>
+        </p:spPr>
+        <p:txBody>
+          <a:bodyPr wrap="square" lIns="0" tIns="0" rIns="0" bIns="0" rtlCol="0" anchor="ctr">
+            <a:normAutofit/>
+          </a:bodyPr>
+          <a:lstStyle/>
+          <a:p>
+            <a:pPr indent="0" marL="0">
+              <a:buNone/>
+            </a:pPr>
+            <a:r>
+              <a:rPr lang="en-US" sz="1000" dirty="0">
+                <a:solidFill>
+                  <a:srgbClr val="52616B"/>
+                </a:solidFill>
+                <a:latin typeface="Aptos" pitchFamily="34" charset="0"/>
+                <a:ea typeface="Aptos" pitchFamily="34" charset="-122"/>
+                <a:cs typeface="Aptos" pitchFamily="34" charset="-120"/>
+              </a:rPr>
+              <a:t>Correspondence provenance: pending</a:t>
+            </a:r>
+            <a:endParaRPr lang="en-US" sz="1000" dirty="0"/>
+          </a:p>
+        </p:txBody>
+      </p:sp>
+      <p:sp>
+        <p:nvSpPr>
+          <p:cNvPr id="20" name="Shape 18"/>
+          <p:cNvSpPr/>
+          <p:nvPr/>
+        </p:nvSpPr>
+        <p:spPr>
+          <a:xfrm>
+            <a:off x="7909560" y="2240280"/>
+            <a:ext cx="3520440" cy="2103120"/>
+          </a:xfrm>
+          <a:prstGeom prst="roundRect">
+            <a:avLst>
+              <a:gd name="adj" fmla="val 1739"/>
+            </a:avLst>
+          </a:prstGeom>
+          <a:solidFill>
+            <a:srgbClr val="FFFDF7"/>
+          </a:solidFill>
+          <a:ln w="10160">
+            <a:solidFill>
+              <a:srgbClr val="E8C878"/>
+            </a:solidFill>
+            <a:prstDash val="solid"/>
+          </a:ln>
+        </p:spPr>
+      </p:sp>
+      <p:sp>
+        <p:nvSpPr>
+          <p:cNvPr id="21" name="Text 19"/>
+          <p:cNvSpPr/>
+          <p:nvPr/>
+        </p:nvSpPr>
+        <p:spPr>
+          <a:xfrm>
+            <a:off x="8229600" y="2880360"/>
+            <a:ext cx="2880360" cy="548640"/>
           </a:xfrm>
           <a:prstGeom prst="rect">
             <a:avLst/>
@@ -5873,7 +6308,65 @@
               <a:buNone/>
             </a:pPr>
             <a:r>
-              <a:rPr lang="en-US" sz="1900" dirty="0">
+              <a:rPr lang="en-US" sz="1300" dirty="0">
+                <a:solidFill>
+                  <a:srgbClr val="52616B"/>
+                </a:solidFill>
+                <a:latin typeface="Aptos" pitchFamily="34" charset="0"/>
+                <a:ea typeface="Aptos" pitchFamily="34" charset="-122"/>
+                <a:cs typeface="Aptos" pitchFamily="34" charset="-120"/>
+              </a:rPr>
+              <a:t>Reserved evidence visual</a:t>
+            </a:r>
+            <a:endParaRPr lang="en-US" sz="1300" dirty="0"/>
+          </a:p>
+          <a:p>
+            <a:pPr algn="ctr" indent="0" marL="0">
+              <a:buNone/>
+            </a:pPr>
+            <a:r>
+              <a:rPr lang="en-US" sz="1300" dirty="0">
+                <a:solidFill>
+                  <a:srgbClr val="52616B"/>
+                </a:solidFill>
+                <a:latin typeface="Aptos" pitchFamily="34" charset="0"/>
+                <a:ea typeface="Aptos" pitchFamily="34" charset="-122"/>
+                <a:cs typeface="Aptos" pitchFamily="34" charset="-120"/>
+              </a:rPr>
+              <a:t>Insert only after accepted correspondence evidence arrives.</a:t>
+            </a:r>
+            <a:endParaRPr lang="en-US" sz="1300" dirty="0"/>
+          </a:p>
+        </p:txBody>
+      </p:sp>
+      <p:sp>
+        <p:nvSpPr>
+          <p:cNvPr id="22" name="Text 20"/>
+          <p:cNvSpPr/>
+          <p:nvPr/>
+        </p:nvSpPr>
+        <p:spPr>
+          <a:xfrm>
+            <a:off x="1143000" y="5074920"/>
+            <a:ext cx="9784080" cy="365760"/>
+          </a:xfrm>
+          <a:prstGeom prst="rect">
+            <a:avLst/>
+          </a:prstGeom>
+          <a:noFill/>
+          <a:ln/>
+        </p:spPr>
+        <p:txBody>
+          <a:bodyPr wrap="square" lIns="508" tIns="508" rIns="508" bIns="508" rtlCol="0" anchor="t">
+            <a:normAutofit/>
+          </a:bodyPr>
+          <a:lstStyle/>
+          <a:p>
+            <a:pPr algn="ctr" indent="0" marL="0">
+              <a:buNone/>
+            </a:pPr>
+            <a:r>
+              <a:rPr lang="en-US" sz="1450" b="1" dirty="0">
                 <a:solidFill>
                   <a:srgbClr val="B42318"/>
                 </a:solidFill>
@@ -5881,15 +6374,15 @@
                 <a:ea typeface="Aptos" pitchFamily="34" charset="-122"/>
                 <a:cs typeface="Aptos" pitchFamily="34" charset="-120"/>
               </a:rPr>
-              <a:t>Accepted explicit GT-to-mapped-defect correspondence is required before reporting XYZ error, mean, median, RMSE, P95 or correspondence counts.</a:t>
-            </a:r>
-            <a:endParaRPr lang="en-US" sz="1900" dirty="0"/>
-          </a:p>
-        </p:txBody>
-      </p:sp>
-      <p:sp>
-        <p:nvSpPr>
-          <p:cNvPr id="9" name="Shape 7"/>
+              <a:t>No 3D metric or result classification is populated before accepted explicit correspondence.</a:t>
+            </a:r>
+            <a:endParaRPr lang="en-US" sz="1450" dirty="0"/>
+          </a:p>
+        </p:txBody>
+      </p:sp>
+      <p:sp>
+        <p:nvSpPr>
+          <p:cNvPr id="23" name="Shape 21"/>
           <p:cNvSpPr/>
           <p:nvPr/>
         </p:nvSpPr>
@@ -5912,7 +6405,7 @@
       </p:sp>
       <p:sp>
         <p:nvSpPr>
-          <p:cNvPr id="10" name="Text 8"/>
+          <p:cNvPr id="24" name="Text 22"/>
           <p:cNvSpPr/>
           <p:nvPr/>
         </p:nvSpPr>
@@ -5951,7 +6444,7 @@
       </p:sp>
       <p:sp>
         <p:nvSpPr>
-          <p:cNvPr id="11" name="Text 9"/>
+          <p:cNvPr id="25" name="Text 23"/>
           <p:cNvSpPr/>
           <p:nvPr/>
         </p:nvSpPr>
@@ -6199,8 +6692,8 @@
         </p:nvSpPr>
         <p:spPr>
           <a:xfrm>
-            <a:off x="914400" y="2148840"/>
-            <a:ext cx="10241280" cy="502920"/>
+            <a:off x="777240" y="1508760"/>
+            <a:ext cx="10607040" cy="365760"/>
           </a:xfrm>
           <a:prstGeom prst="rect">
             <a:avLst/>
@@ -6218,7 +6711,7 @@
               <a:buNone/>
             </a:pPr>
             <a:r>
-              <a:rPr lang="en-US" sz="2500" b="1" dirty="0">
+              <a:rPr lang="en-US" sz="2200" b="1" dirty="0">
                 <a:solidFill>
                   <a:srgbClr val="0B1F33"/>
                 </a:solidFill>
@@ -6226,22 +6719,378 @@
                 <a:ea typeface="Aptos" pitchFamily="34" charset="-122"/>
                 <a:cs typeface="Aptos" pitchFamily="34" charset="-120"/>
               </a:rPr>
-              <a:t>Low-light robustness - results pending Workstream 04 completion</a:t>
-            </a:r>
-            <a:endParaRPr lang="en-US" sz="2500" dirty="0"/>
-          </a:p>
-        </p:txBody>
-      </p:sp>
-      <p:sp>
-        <p:nvSpPr>
-          <p:cNvPr id="8" name="Text 6"/>
-          <p:cNvSpPr/>
-          <p:nvPr/>
-        </p:nvSpPr>
-        <p:spPr>
-          <a:xfrm>
-            <a:off x="1325880" y="3383280"/>
-            <a:ext cx="9509760" cy="457200"/>
+              <a:t>AWAITING ACCEPTED WORKSTREAM 04 RESULTS</a:t>
+            </a:r>
+            <a:endParaRPr lang="en-US" sz="2200" dirty="0"/>
+          </a:p>
+        </p:txBody>
+      </p:sp>
+      <p:sp>
+        <p:nvSpPr>
+          <p:cNvPr id="8" name="Shape 6"/>
+          <p:cNvSpPr/>
+          <p:nvPr/>
+        </p:nvSpPr>
+        <p:spPr>
+          <a:xfrm>
+            <a:off x="1234440" y="2240280"/>
+            <a:ext cx="0" cy="2971800"/>
+          </a:xfrm>
+          <a:prstGeom prst="line">
+            <a:avLst/>
+          </a:prstGeom>
+          <a:noFill/>
+          <a:ln w="15240">
+            <a:solidFill>
+              <a:srgbClr val="0B1F33"/>
+            </a:solidFill>
+            <a:prstDash val="solid"/>
+          </a:ln>
+        </p:spPr>
+      </p:sp>
+      <p:sp>
+        <p:nvSpPr>
+          <p:cNvPr id="9" name="Shape 7"/>
+          <p:cNvSpPr/>
+          <p:nvPr/>
+        </p:nvSpPr>
+        <p:spPr>
+          <a:xfrm>
+            <a:off x="1234440" y="5212080"/>
+            <a:ext cx="6537960" cy="0"/>
+          </a:xfrm>
+          <a:prstGeom prst="line">
+            <a:avLst/>
+          </a:prstGeom>
+          <a:noFill/>
+          <a:ln w="15240">
+            <a:solidFill>
+              <a:srgbClr val="0B1F33"/>
+            </a:solidFill>
+            <a:prstDash val="solid"/>
+          </a:ln>
+        </p:spPr>
+      </p:sp>
+      <p:sp>
+        <p:nvSpPr>
+          <p:cNvPr id="10" name="Shape 8"/>
+          <p:cNvSpPr/>
+          <p:nvPr/>
+        </p:nvSpPr>
+        <p:spPr>
+          <a:xfrm>
+            <a:off x="1737360" y="5212080"/>
+            <a:ext cx="0" cy="100584"/>
+          </a:xfrm>
+          <a:prstGeom prst="line">
+            <a:avLst/>
+          </a:prstGeom>
+          <a:noFill/>
+          <a:ln w="10160">
+            <a:solidFill>
+              <a:srgbClr val="0B1F33"/>
+            </a:solidFill>
+            <a:prstDash val="solid"/>
+          </a:ln>
+        </p:spPr>
+      </p:sp>
+      <p:sp>
+        <p:nvSpPr>
+          <p:cNvPr id="11" name="Text 9"/>
+          <p:cNvSpPr/>
+          <p:nvPr/>
+        </p:nvSpPr>
+        <p:spPr>
+          <a:xfrm>
+            <a:off x="1591056" y="5394960"/>
+            <a:ext cx="310896" cy="137160"/>
+          </a:xfrm>
+          <a:prstGeom prst="rect">
+            <a:avLst/>
+          </a:prstGeom>
+          <a:noFill/>
+          <a:ln/>
+        </p:spPr>
+        <p:txBody>
+          <a:bodyPr wrap="square" lIns="0" tIns="0" rIns="0" bIns="0" rtlCol="0" anchor="ctr"/>
+          <a:lstStyle/>
+          <a:p>
+            <a:pPr algn="ctr" indent="0" marL="0">
+              <a:buNone/>
+            </a:pPr>
+            <a:r>
+              <a:rPr lang="en-US" sz="1050" dirty="0">
+                <a:solidFill>
+                  <a:srgbClr val="17212B"/>
+                </a:solidFill>
+                <a:latin typeface="Aptos" pitchFamily="34" charset="0"/>
+                <a:ea typeface="Aptos" pitchFamily="34" charset="-122"/>
+                <a:cs typeface="Aptos" pitchFamily="34" charset="-120"/>
+              </a:rPr>
+              <a:t>L0</a:t>
+            </a:r>
+            <a:endParaRPr lang="en-US" sz="1050" dirty="0"/>
+          </a:p>
+        </p:txBody>
+      </p:sp>
+      <p:sp>
+        <p:nvSpPr>
+          <p:cNvPr id="12" name="Shape 10"/>
+          <p:cNvSpPr/>
+          <p:nvPr/>
+        </p:nvSpPr>
+        <p:spPr>
+          <a:xfrm>
+            <a:off x="3108960" y="5212080"/>
+            <a:ext cx="0" cy="100584"/>
+          </a:xfrm>
+          <a:prstGeom prst="line">
+            <a:avLst/>
+          </a:prstGeom>
+          <a:noFill/>
+          <a:ln w="10160">
+            <a:solidFill>
+              <a:srgbClr val="0B1F33"/>
+            </a:solidFill>
+            <a:prstDash val="solid"/>
+          </a:ln>
+        </p:spPr>
+      </p:sp>
+      <p:sp>
+        <p:nvSpPr>
+          <p:cNvPr id="13" name="Text 11"/>
+          <p:cNvSpPr/>
+          <p:nvPr/>
+        </p:nvSpPr>
+        <p:spPr>
+          <a:xfrm>
+            <a:off x="2962656" y="5394960"/>
+            <a:ext cx="310896" cy="137160"/>
+          </a:xfrm>
+          <a:prstGeom prst="rect">
+            <a:avLst/>
+          </a:prstGeom>
+          <a:noFill/>
+          <a:ln/>
+        </p:spPr>
+        <p:txBody>
+          <a:bodyPr wrap="square" lIns="0" tIns="0" rIns="0" bIns="0" rtlCol="0" anchor="ctr"/>
+          <a:lstStyle/>
+          <a:p>
+            <a:pPr algn="ctr" indent="0" marL="0">
+              <a:buNone/>
+            </a:pPr>
+            <a:r>
+              <a:rPr lang="en-US" sz="1050" dirty="0">
+                <a:solidFill>
+                  <a:srgbClr val="17212B"/>
+                </a:solidFill>
+                <a:latin typeface="Aptos" pitchFamily="34" charset="0"/>
+                <a:ea typeface="Aptos" pitchFamily="34" charset="-122"/>
+                <a:cs typeface="Aptos" pitchFamily="34" charset="-120"/>
+              </a:rPr>
+              <a:t>L1</a:t>
+            </a:r>
+            <a:endParaRPr lang="en-US" sz="1050" dirty="0"/>
+          </a:p>
+        </p:txBody>
+      </p:sp>
+      <p:sp>
+        <p:nvSpPr>
+          <p:cNvPr id="14" name="Shape 12"/>
+          <p:cNvSpPr/>
+          <p:nvPr/>
+        </p:nvSpPr>
+        <p:spPr>
+          <a:xfrm>
+            <a:off x="4480560" y="5212080"/>
+            <a:ext cx="0" cy="100584"/>
+          </a:xfrm>
+          <a:prstGeom prst="line">
+            <a:avLst/>
+          </a:prstGeom>
+          <a:noFill/>
+          <a:ln w="10160">
+            <a:solidFill>
+              <a:srgbClr val="0B1F33"/>
+            </a:solidFill>
+            <a:prstDash val="solid"/>
+          </a:ln>
+        </p:spPr>
+      </p:sp>
+      <p:sp>
+        <p:nvSpPr>
+          <p:cNvPr id="15" name="Text 13"/>
+          <p:cNvSpPr/>
+          <p:nvPr/>
+        </p:nvSpPr>
+        <p:spPr>
+          <a:xfrm>
+            <a:off x="4334256" y="5394960"/>
+            <a:ext cx="310896" cy="137160"/>
+          </a:xfrm>
+          <a:prstGeom prst="rect">
+            <a:avLst/>
+          </a:prstGeom>
+          <a:noFill/>
+          <a:ln/>
+        </p:spPr>
+        <p:txBody>
+          <a:bodyPr wrap="square" lIns="0" tIns="0" rIns="0" bIns="0" rtlCol="0" anchor="ctr"/>
+          <a:lstStyle/>
+          <a:p>
+            <a:pPr algn="ctr" indent="0" marL="0">
+              <a:buNone/>
+            </a:pPr>
+            <a:r>
+              <a:rPr lang="en-US" sz="1050" dirty="0">
+                <a:solidFill>
+                  <a:srgbClr val="17212B"/>
+                </a:solidFill>
+                <a:latin typeface="Aptos" pitchFamily="34" charset="0"/>
+                <a:ea typeface="Aptos" pitchFamily="34" charset="-122"/>
+                <a:cs typeface="Aptos" pitchFamily="34" charset="-120"/>
+              </a:rPr>
+              <a:t>L2</a:t>
+            </a:r>
+            <a:endParaRPr lang="en-US" sz="1050" dirty="0"/>
+          </a:p>
+        </p:txBody>
+      </p:sp>
+      <p:sp>
+        <p:nvSpPr>
+          <p:cNvPr id="16" name="Shape 14"/>
+          <p:cNvSpPr/>
+          <p:nvPr/>
+        </p:nvSpPr>
+        <p:spPr>
+          <a:xfrm>
+            <a:off x="5852160" y="5212080"/>
+            <a:ext cx="0" cy="100584"/>
+          </a:xfrm>
+          <a:prstGeom prst="line">
+            <a:avLst/>
+          </a:prstGeom>
+          <a:noFill/>
+          <a:ln w="10160">
+            <a:solidFill>
+              <a:srgbClr val="0B1F33"/>
+            </a:solidFill>
+            <a:prstDash val="solid"/>
+          </a:ln>
+        </p:spPr>
+      </p:sp>
+      <p:sp>
+        <p:nvSpPr>
+          <p:cNvPr id="17" name="Text 15"/>
+          <p:cNvSpPr/>
+          <p:nvPr/>
+        </p:nvSpPr>
+        <p:spPr>
+          <a:xfrm>
+            <a:off x="5705856" y="5394960"/>
+            <a:ext cx="310896" cy="137160"/>
+          </a:xfrm>
+          <a:prstGeom prst="rect">
+            <a:avLst/>
+          </a:prstGeom>
+          <a:noFill/>
+          <a:ln/>
+        </p:spPr>
+        <p:txBody>
+          <a:bodyPr wrap="square" lIns="0" tIns="0" rIns="0" bIns="0" rtlCol="0" anchor="ctr"/>
+          <a:lstStyle/>
+          <a:p>
+            <a:pPr algn="ctr" indent="0" marL="0">
+              <a:buNone/>
+            </a:pPr>
+            <a:r>
+              <a:rPr lang="en-US" sz="1050" dirty="0">
+                <a:solidFill>
+                  <a:srgbClr val="17212B"/>
+                </a:solidFill>
+                <a:latin typeface="Aptos" pitchFamily="34" charset="0"/>
+                <a:ea typeface="Aptos" pitchFamily="34" charset="-122"/>
+                <a:cs typeface="Aptos" pitchFamily="34" charset="-120"/>
+              </a:rPr>
+              <a:t>L3</a:t>
+            </a:r>
+            <a:endParaRPr lang="en-US" sz="1050" dirty="0"/>
+          </a:p>
+        </p:txBody>
+      </p:sp>
+      <p:sp>
+        <p:nvSpPr>
+          <p:cNvPr id="18" name="Shape 16"/>
+          <p:cNvSpPr/>
+          <p:nvPr/>
+        </p:nvSpPr>
+        <p:spPr>
+          <a:xfrm>
+            <a:off x="7223760" y="5212080"/>
+            <a:ext cx="0" cy="100584"/>
+          </a:xfrm>
+          <a:prstGeom prst="line">
+            <a:avLst/>
+          </a:prstGeom>
+          <a:noFill/>
+          <a:ln w="10160">
+            <a:solidFill>
+              <a:srgbClr val="0B1F33"/>
+            </a:solidFill>
+            <a:prstDash val="solid"/>
+          </a:ln>
+        </p:spPr>
+      </p:sp>
+      <p:sp>
+        <p:nvSpPr>
+          <p:cNvPr id="19" name="Text 17"/>
+          <p:cNvSpPr/>
+          <p:nvPr/>
+        </p:nvSpPr>
+        <p:spPr>
+          <a:xfrm>
+            <a:off x="7077456" y="5394960"/>
+            <a:ext cx="310896" cy="137160"/>
+          </a:xfrm>
+          <a:prstGeom prst="rect">
+            <a:avLst/>
+          </a:prstGeom>
+          <a:noFill/>
+          <a:ln/>
+        </p:spPr>
+        <p:txBody>
+          <a:bodyPr wrap="square" lIns="0" tIns="0" rIns="0" bIns="0" rtlCol="0" anchor="ctr"/>
+          <a:lstStyle/>
+          <a:p>
+            <a:pPr algn="ctr" indent="0" marL="0">
+              <a:buNone/>
+            </a:pPr>
+            <a:r>
+              <a:rPr lang="en-US" sz="1050" dirty="0">
+                <a:solidFill>
+                  <a:srgbClr val="17212B"/>
+                </a:solidFill>
+                <a:latin typeface="Aptos" pitchFamily="34" charset="0"/>
+                <a:ea typeface="Aptos" pitchFamily="34" charset="-122"/>
+                <a:cs typeface="Aptos" pitchFamily="34" charset="-120"/>
+              </a:rPr>
+              <a:t>L4</a:t>
+            </a:r>
+            <a:endParaRPr lang="en-US" sz="1050" dirty="0"/>
+          </a:p>
+        </p:txBody>
+      </p:sp>
+      <p:sp>
+        <p:nvSpPr>
+          <p:cNvPr id="20" name="Text 18"/>
+          <p:cNvSpPr/>
+          <p:nvPr/>
+        </p:nvSpPr>
+        <p:spPr>
+          <a:xfrm>
+            <a:off x="182880" y="3200400"/>
+            <a:ext cx="868680" cy="502920"/>
           </a:xfrm>
           <a:prstGeom prst="rect">
             <a:avLst/>
@@ -6259,7 +7108,255 @@
               <a:buNone/>
             </a:pPr>
             <a:r>
-              <a:rPr lang="en-US" sz="1900" dirty="0">
+              <a:rPr lang="en-US" sz="1050" dirty="0">
+                <a:solidFill>
+                  <a:srgbClr val="52616B"/>
+                </a:solidFill>
+                <a:latin typeface="Aptos" pitchFamily="34" charset="0"/>
+                <a:ea typeface="Aptos" pitchFamily="34" charset="-122"/>
+                <a:cs typeface="Aptos" pitchFamily="34" charset="-120"/>
+              </a:rPr>
+              <a:t>Accepted detector metric</a:t>
+            </a:r>
+            <a:endParaRPr lang="en-US" sz="1050" dirty="0"/>
+          </a:p>
+          <a:p>
+            <a:pPr algn="ctr" indent="0" marL="0">
+              <a:buNone/>
+            </a:pPr>
+            <a:r>
+              <a:rPr lang="en-US" sz="1050" dirty="0">
+                <a:solidFill>
+                  <a:srgbClr val="52616B"/>
+                </a:solidFill>
+                <a:latin typeface="Aptos" pitchFamily="34" charset="0"/>
+                <a:ea typeface="Aptos" pitchFamily="34" charset="-122"/>
+                <a:cs typeface="Aptos" pitchFamily="34" charset="-120"/>
+              </a:rPr>
+              <a:t>(mAP50-95 if accepted)</a:t>
+            </a:r>
+            <a:endParaRPr lang="en-US" sz="1050" dirty="0"/>
+          </a:p>
+        </p:txBody>
+      </p:sp>
+      <p:sp>
+        <p:nvSpPr>
+          <p:cNvPr id="21" name="Text 19"/>
+          <p:cNvSpPr/>
+          <p:nvPr/>
+        </p:nvSpPr>
+        <p:spPr>
+          <a:xfrm>
+            <a:off x="3520440" y="5532120"/>
+            <a:ext cx="2011680" cy="164592"/>
+          </a:xfrm>
+          <a:prstGeom prst="rect">
+            <a:avLst/>
+          </a:prstGeom>
+          <a:noFill/>
+          <a:ln/>
+        </p:spPr>
+        <p:txBody>
+          <a:bodyPr wrap="square" lIns="508" tIns="508" rIns="508" bIns="508" rtlCol="0" anchor="t">
+            <a:normAutofit/>
+          </a:bodyPr>
+          <a:lstStyle/>
+          <a:p>
+            <a:pPr algn="ctr" indent="0" marL="0">
+              <a:buNone/>
+            </a:pPr>
+            <a:r>
+              <a:rPr lang="en-US" sz="1050" dirty="0">
+                <a:solidFill>
+                  <a:srgbClr val="52616B"/>
+                </a:solidFill>
+                <a:latin typeface="Aptos" pitchFamily="34" charset="0"/>
+                <a:ea typeface="Aptos" pitchFamily="34" charset="-122"/>
+                <a:cs typeface="Aptos" pitchFamily="34" charset="-120"/>
+              </a:rPr>
+              <a:t>Illumination level</a:t>
+            </a:r>
+            <a:endParaRPr lang="en-US" sz="1050" dirty="0"/>
+          </a:p>
+        </p:txBody>
+      </p:sp>
+      <p:sp>
+        <p:nvSpPr>
+          <p:cNvPr id="22" name="Shape 20"/>
+          <p:cNvSpPr/>
+          <p:nvPr/>
+        </p:nvSpPr>
+        <p:spPr>
+          <a:xfrm>
+            <a:off x="8458200" y="2423160"/>
+            <a:ext cx="2651760" cy="640080"/>
+          </a:xfrm>
+          <a:prstGeom prst="roundRect">
+            <a:avLst>
+              <a:gd name="adj" fmla="val 5714"/>
+            </a:avLst>
+          </a:prstGeom>
+          <a:solidFill>
+            <a:srgbClr val="FFF9EC"/>
+          </a:solidFill>
+          <a:ln w="7620">
+            <a:solidFill>
+              <a:srgbClr val="E8C878"/>
+            </a:solidFill>
+            <a:prstDash val="solid"/>
+          </a:ln>
+        </p:spPr>
+      </p:sp>
+      <p:sp>
+        <p:nvSpPr>
+          <p:cNvPr id="23" name="Text 21"/>
+          <p:cNvSpPr/>
+          <p:nvPr/>
+        </p:nvSpPr>
+        <p:spPr>
+          <a:xfrm>
+            <a:off x="8668512" y="2679192"/>
+            <a:ext cx="2240280" cy="137160"/>
+          </a:xfrm>
+          <a:prstGeom prst="rect">
+            <a:avLst/>
+          </a:prstGeom>
+          <a:noFill/>
+          <a:ln/>
+        </p:spPr>
+        <p:txBody>
+          <a:bodyPr wrap="square" lIns="0" tIns="0" rIns="0" bIns="0" rtlCol="0" anchor="ctr"/>
+          <a:lstStyle/>
+          <a:p>
+            <a:pPr algn="ctr" indent="0" marL="0">
+              <a:buNone/>
+            </a:pPr>
+            <a:r>
+              <a:rPr lang="en-US" sz="1200" dirty="0">
+                <a:solidFill>
+                  <a:srgbClr val="52616B"/>
+                </a:solidFill>
+                <a:latin typeface="Aptos" pitchFamily="34" charset="0"/>
+                <a:ea typeface="Aptos" pitchFamily="34" charset="-122"/>
+                <a:cs typeface="Aptos" pitchFamily="34" charset="-120"/>
+              </a:rPr>
+              <a:t>RAW series reserved</a:t>
+            </a:r>
+            <a:endParaRPr lang="en-US" sz="1200" dirty="0"/>
+          </a:p>
+        </p:txBody>
+      </p:sp>
+      <p:sp>
+        <p:nvSpPr>
+          <p:cNvPr id="24" name="Shape 22"/>
+          <p:cNvSpPr/>
+          <p:nvPr/>
+        </p:nvSpPr>
+        <p:spPr>
+          <a:xfrm>
+            <a:off x="8458200" y="3383280"/>
+            <a:ext cx="2651760" cy="640080"/>
+          </a:xfrm>
+          <a:prstGeom prst="roundRect">
+            <a:avLst>
+              <a:gd name="adj" fmla="val 5714"/>
+            </a:avLst>
+          </a:prstGeom>
+          <a:solidFill>
+            <a:srgbClr val="FFFDF7"/>
+          </a:solidFill>
+          <a:ln w="7620">
+            <a:solidFill>
+              <a:srgbClr val="E8C878"/>
+            </a:solidFill>
+            <a:prstDash val="solid"/>
+          </a:ln>
+        </p:spPr>
+      </p:sp>
+      <p:sp>
+        <p:nvSpPr>
+          <p:cNvPr id="25" name="Text 23"/>
+          <p:cNvSpPr/>
+          <p:nvPr/>
+        </p:nvSpPr>
+        <p:spPr>
+          <a:xfrm>
+            <a:off x="8668512" y="3566160"/>
+            <a:ext cx="2240280" cy="274320"/>
+          </a:xfrm>
+          <a:prstGeom prst="rect">
+            <a:avLst/>
+          </a:prstGeom>
+          <a:noFill/>
+          <a:ln/>
+        </p:spPr>
+        <p:txBody>
+          <a:bodyPr wrap="square" lIns="0" tIns="0" rIns="0" bIns="0" rtlCol="0" anchor="ctr"/>
+          <a:lstStyle/>
+          <a:p>
+            <a:pPr algn="ctr" indent="0" marL="0">
+              <a:buNone/>
+            </a:pPr>
+            <a:r>
+              <a:rPr lang="en-US" sz="1100" dirty="0">
+                <a:solidFill>
+                  <a:srgbClr val="52616B"/>
+                </a:solidFill>
+                <a:latin typeface="Aptos" pitchFamily="34" charset="0"/>
+                <a:ea typeface="Aptos" pitchFamily="34" charset="-122"/>
+                <a:cs typeface="Aptos" pitchFamily="34" charset="-120"/>
+              </a:rPr>
+              <a:t>Additional series</a:t>
+            </a:r>
+            <a:endParaRPr lang="en-US" sz="1100" dirty="0"/>
+          </a:p>
+          <a:p>
+            <a:pPr algn="ctr" indent="0" marL="0">
+              <a:buNone/>
+            </a:pPr>
+            <a:r>
+              <a:rPr lang="en-US" sz="1100" dirty="0">
+                <a:solidFill>
+                  <a:srgbClr val="52616B"/>
+                </a:solidFill>
+                <a:latin typeface="Aptos" pitchFamily="34" charset="0"/>
+                <a:ea typeface="Aptos" pitchFamily="34" charset="-122"/>
+                <a:cs typeface="Aptos" pitchFamily="34" charset="-120"/>
+              </a:rPr>
+              <a:t>only if accepted</a:t>
+            </a:r>
+            <a:endParaRPr lang="en-US" sz="1100" dirty="0"/>
+          </a:p>
+        </p:txBody>
+      </p:sp>
+      <p:sp>
+        <p:nvSpPr>
+          <p:cNvPr id="26" name="Text 24"/>
+          <p:cNvSpPr/>
+          <p:nvPr/>
+        </p:nvSpPr>
+        <p:spPr>
+          <a:xfrm>
+            <a:off x="8138160" y="4709160"/>
+            <a:ext cx="3246120" cy="502920"/>
+          </a:xfrm>
+          <a:prstGeom prst="rect">
+            <a:avLst/>
+          </a:prstGeom>
+          <a:noFill/>
+          <a:ln/>
+        </p:spPr>
+        <p:txBody>
+          <a:bodyPr wrap="square" lIns="508" tIns="508" rIns="508" bIns="508" rtlCol="0" anchor="t">
+            <a:normAutofit/>
+          </a:bodyPr>
+          <a:lstStyle/>
+          <a:p>
+            <a:pPr algn="ctr" indent="0" marL="0">
+              <a:buNone/>
+            </a:pPr>
+            <a:r>
+              <a:rPr lang="en-US" sz="1250" b="1" dirty="0">
                 <a:solidFill>
                   <a:srgbClr val="B42318"/>
                 </a:solidFill>
@@ -6267,15 +7364,15 @@
                 <a:ea typeface="Aptos" pitchFamily="34" charset="-122"/>
                 <a:cs typeface="Aptos" pitchFamily="34" charset="-120"/>
               </a:rPr>
-              <a:t>No performance figures are presented until the final accepted Workstream 04 evidence is available.</a:t>
-            </a:r>
-            <a:endParaRPr lang="en-US" sz="1900" dirty="0"/>
-          </a:p>
-        </p:txBody>
-      </p:sp>
-      <p:sp>
-        <p:nvSpPr>
-          <p:cNvPr id="9" name="Shape 7"/>
+              <a:t>No points, bars, curves, or performance values are shown before accepted results.</a:t>
+            </a:r>
+            <a:endParaRPr lang="en-US" sz="1250" dirty="0"/>
+          </a:p>
+        </p:txBody>
+      </p:sp>
+      <p:sp>
+        <p:nvSpPr>
+          <p:cNvPr id="27" name="Shape 25"/>
           <p:cNvSpPr/>
           <p:nvPr/>
         </p:nvSpPr>
@@ -6298,7 +7395,7 @@
       </p:sp>
       <p:sp>
         <p:nvSpPr>
-          <p:cNvPr id="10" name="Text 8"/>
+          <p:cNvPr id="28" name="Text 26"/>
           <p:cNvSpPr/>
           <p:nvPr/>
         </p:nvSpPr>
@@ -6337,7 +7434,7 @@
       </p:sp>
       <p:sp>
         <p:nvSpPr>
-          <p:cNvPr id="11" name="Text 9"/>
+          <p:cNvPr id="29" name="Text 27"/>
           <p:cNvSpPr/>
           <p:nvPr/>
         </p:nvSpPr>
@@ -9857,7 +10954,7 @@
               <a:buNone/>
             </a:pPr>
             <a:r>
-              <a:rPr lang="en-US" sz="2000" b="1" dirty="0">
+              <a:rPr lang="en-US" sz="1600" b="1" dirty="0">
                 <a:solidFill>
                   <a:srgbClr val="0B1F33"/>
                 </a:solidFill>
@@ -9865,9 +10962,9 @@
                 <a:ea typeface="Aptos" pitchFamily="34" charset="-122"/>
                 <a:cs typeface="Aptos" pitchFamily="34" charset="-120"/>
               </a:rPr>
-              <a:t>P19 3D + P18 assets</a:t>
-            </a:r>
-            <a:endParaRPr lang="en-US" sz="2000" dirty="0"/>
+              <a:t>P19 3D + Workstream 04</a:t>
+            </a:r>
+            <a:endParaRPr lang="en-US" sz="1600" dirty="0"/>
           </a:p>
         </p:txBody>
       </p:sp>
@@ -9906,7 +11003,7 @@
                 <a:ea typeface="Aptos" pitchFamily="34" charset="-122"/>
                 <a:cs typeface="Aptos" pitchFamily="34" charset="-120"/>
               </a:rPr>
-              <a:t>controlled correspondence / ingestion</a:t>
+              <a:t>controlled correspondence / low-light evaluation</a:t>
             </a:r>
             <a:endParaRPr lang="en-US" sz="750" dirty="0"/>
           </a:p>
@@ -14859,13 +15956,13 @@
         </p:nvPicPr>
         <p:blipFill>
           <a:blip r:embed="rId1"/>
-          <a:srcRect l="0" r="0" t="0" b="0"/>
+          <a:srcRect l="5680" r="-5680" t="29358" b="-29358"/>
           <a:stretch/>
         </p:blipFill>
         <p:spPr>
           <a:xfrm>
-            <a:off x="621792" y="1627632"/>
-            <a:ext cx="6629400" cy="4279392"/>
+            <a:off x="438912" y="1463040"/>
+            <a:ext cx="7726680" cy="4983480"/>
           </a:xfrm>
           <a:prstGeom prst="rect">
             <a:avLst/>
@@ -14880,8 +15977,8 @@
         </p:nvSpPr>
         <p:spPr>
           <a:xfrm>
-            <a:off x="7635240" y="1783080"/>
-            <a:ext cx="3291840" cy="1005840"/>
+            <a:off x="8458200" y="1691640"/>
+            <a:ext cx="2926080" cy="1005840"/>
           </a:xfrm>
           <a:prstGeom prst="roundRect">
             <a:avLst>
@@ -14907,7 +16004,7 @@
         </p:nvSpPr>
         <p:spPr>
           <a:xfrm>
-            <a:off x="7635240" y="1783080"/>
+            <a:off x="8458200" y="1691640"/>
             <a:ext cx="73152" cy="1005840"/>
           </a:xfrm>
           <a:prstGeom prst="rect">
@@ -14932,8 +16029,8 @@
         </p:nvSpPr>
         <p:spPr>
           <a:xfrm>
-            <a:off x="7836408" y="1938528"/>
-            <a:ext cx="2980944" cy="146304"/>
+            <a:off x="8659368" y="1847088"/>
+            <a:ext cx="2615184" cy="146304"/>
           </a:xfrm>
           <a:prstGeom prst="rect">
             <a:avLst/>
@@ -14973,8 +16070,8 @@
         </p:nvSpPr>
         <p:spPr>
           <a:xfrm>
-            <a:off x="7836408" y="2176272"/>
-            <a:ext cx="2980944" cy="365760"/>
+            <a:off x="8659368" y="2084832"/>
+            <a:ext cx="2615184" cy="365760"/>
           </a:xfrm>
           <a:prstGeom prst="rect">
             <a:avLst/>
@@ -15014,8 +16111,8 @@
         </p:nvSpPr>
         <p:spPr>
           <a:xfrm>
-            <a:off x="7836408" y="2532888"/>
-            <a:ext cx="2980944" cy="137160"/>
+            <a:off x="8659368" y="2441448"/>
+            <a:ext cx="2615184" cy="137160"/>
           </a:xfrm>
           <a:prstGeom prst="rect">
             <a:avLst/>
@@ -15055,8 +16152,8 @@
         </p:nvSpPr>
         <p:spPr>
           <a:xfrm>
-            <a:off x="7680960" y="3154680"/>
-            <a:ext cx="3291840" cy="1554480"/>
+            <a:off x="8503920" y="3017520"/>
+            <a:ext cx="2788920" cy="1691640"/>
           </a:xfrm>
           <a:prstGeom prst="rect">
             <a:avLst/>
@@ -15074,7 +16171,7 @@
               <a:buNone/>
             </a:pPr>
             <a:r>
-              <a:rPr lang="en-US" sz="1400" dirty="0">
+              <a:rPr lang="en-US" sz="1250" dirty="0">
                 <a:solidFill>
                   <a:srgbClr val="17212B"/>
                 </a:solidFill>
@@ -15084,14 +16181,14 @@
               </a:rPr>
               <a:t>Detector classification: Honeycombing</a:t>
             </a:r>
-            <a:endParaRPr lang="en-US" sz="1400" dirty="0"/>
+            <a:endParaRPr lang="en-US" sz="1250" dirty="0"/>
           </a:p>
           <a:p>
             <a:pPr algn="l" indent="0" marL="0">
               <a:buNone/>
             </a:pPr>
             <a:r>
-              <a:rPr lang="en-US" sz="1400" dirty="0">
+              <a:rPr lang="en-US" sz="1250" dirty="0">
                 <a:solidFill>
                   <a:srgbClr val="17212B"/>
                 </a:solidFill>
@@ -15101,14 +16198,14 @@
               </a:rPr>
               <a:t>Confidence: 0.004553093574941158</a:t>
             </a:r>
-            <a:endParaRPr lang="en-US" sz="1400" dirty="0"/>
+            <a:endParaRPr lang="en-US" sz="1250" dirty="0"/>
           </a:p>
           <a:p>
             <a:pPr algn="l" indent="0" marL="0">
               <a:buNone/>
             </a:pPr>
             <a:r>
-              <a:rPr lang="en-US" sz="1400" dirty="0">
+              <a:rPr lang="en-US" sz="1250" dirty="0">
                 <a:solidFill>
                   <a:srgbClr val="17212B"/>
                 </a:solidFill>
@@ -15118,14 +16215,14 @@
               </a:rPr>
               <a:t>Observation count: 1</a:t>
             </a:r>
-            <a:endParaRPr lang="en-US" sz="1400" dirty="0"/>
+            <a:endParaRPr lang="en-US" sz="1250" dirty="0"/>
           </a:p>
           <a:p>
             <a:pPr algn="l" indent="0" marL="0">
               <a:buNone/>
             </a:pPr>
             <a:r>
-              <a:rPr lang="en-US" sz="1400" dirty="0">
+              <a:rPr lang="en-US" sz="1250" dirty="0">
                 <a:solidFill>
                   <a:srgbClr val="17212B"/>
                 </a:solidFill>
@@ -15135,7 +16232,7 @@
               </a:rPr>
               <a:t>Model: DET-FINAL-v1</a:t>
             </a:r>
-            <a:endParaRPr lang="en-US" sz="1400" dirty="0"/>
+            <a:endParaRPr lang="en-US" sz="1250" dirty="0"/>
           </a:p>
         </p:txBody>
       </p:sp>
@@ -15147,8 +16244,8 @@
         </p:nvSpPr>
         <p:spPr>
           <a:xfrm>
-            <a:off x="7635240" y="5074920"/>
-            <a:ext cx="3429000" cy="502920"/>
+            <a:off x="8430768" y="5230368"/>
+            <a:ext cx="2907792" cy="502920"/>
           </a:xfrm>
           <a:prstGeom prst="rect">
             <a:avLst/>
@@ -15166,7 +16263,7 @@
               <a:buNone/>
             </a:pPr>
             <a:r>
-              <a:rPr lang="en-US" sz="1250" b="1" dirty="0">
+              <a:rPr lang="en-US" sz="1125" b="1" dirty="0">
                 <a:solidFill>
                   <a:srgbClr val="B42318"/>
                 </a:solidFill>
@@ -15176,7 +16273,7 @@
               </a:rPr>
               <a:t>Extremely-low-confidence, unreviewed machine output used to demonstrate system lineage.</a:t>
             </a:r>
-            <a:endParaRPr lang="en-US" sz="1250" dirty="0"/>
+            <a:endParaRPr lang="en-US" sz="1125" dirty="0"/>
           </a:p>
         </p:txBody>
       </p:sp>

</xml_diff>

<commit_message>
docs(p20): ingest final MSI presentation evidence
</commit_message>
<xml_diff>
--- a/outputs/presentation/AegisInspect_P20_working_draft.pptx
+++ b/outputs/presentation/AegisInspect_P20_working_draft.pptx
@@ -520,9 +520,9 @@
           <a:p>
             <a:r>
               <a:rPr lang="en-US" dirty="0"/>
-              <a:t>P20 FINALIZATION_READY_FOR_LAST-EVIDENCE_INGESTION
+              <a:t>P20 FINALIZATION_READY_FOR_LAST_ARMOURY_EVIDENCE
 Assembly source: docs/presentation/assembly/slide_content.md
-Assembly SHA-256: a9756b6937c47f1129abc87917e7df5fd7b23d087d03117ea2de3666c84bc012
+Assembly SHA-256: 069ed214d6ba35a7db18680172c06e99621b8b5b90bc394c256ecbe25f7a92fe
 Speaker note: Open with the product purpose, then state that every claim is evidence-bound and that full autonomy is not claimed.</a:t>
             </a:r>
             <a:endParaRPr lang="en-US" dirty="0"/>
@@ -611,10 +611,10 @@
           <a:p>
             <a:r>
               <a:rPr lang="en-US" dirty="0"/>
-              <a:t>P20 FINALIZATION_READY_FOR_LAST-EVIDENCE_INGESTION
+              <a:t>P20 FINALIZATION_READY_FOR_LAST_ARMOURY_EVIDENCE
 Assembly source: docs/presentation/assembly/slide_content.md
-Assembly SHA-256: a9756b6937c47f1129abc87917e7df5fd7b23d087d03117ea2de3666c84bc012
-Speaker note: Point out that the report preserves coordinates, confidence, provenance and review state without inventing severity, repairs or safety conclusions.</a:t>
+Assembly SHA-256: 069ed214d6ba35a7db18680172c06e99621b8b5b90bc394c256ecbe25f7a92fe
+Speaker note: Use this short excerpt from the accepted P18 inspection report. It preserves session-local coordinates, confidence, provenance and UNREVIEWED state without inventing severity, repairs or safety conclusions.</a:t>
             </a:r>
             <a:endParaRPr lang="en-US" dirty="0"/>
           </a:p>
@@ -702,9 +702,9 @@
           <a:p>
             <a:r>
               <a:rPr lang="en-US" dirty="0"/>
-              <a:t>P20 FINALIZATION_READY_FOR_LAST-EVIDENCE_INGESTION
+              <a:t>P20 FINALIZATION_READY_FOR_LAST_ARMOURY_EVIDENCE
 Assembly source: docs/presentation/assembly/slide_content.md
-Assembly SHA-256: a9756b6937c47f1129abc87917e7df5fd7b23d087d03117ea2de3666c84bc012
+Assembly SHA-256: 069ed214d6ba35a7db18680172c06e99621b8b5b90bc394c256ecbe25f7a92fe
 Speaker note: The first retry validated the same-observation chain but missed the browser capture; the accepted completion package supplies that screenshot. This is integration evidence, not full autonomy.</a:t>
             </a:r>
             <a:endParaRPr lang="en-US" dirty="0"/>
@@ -793,10 +793,10 @@
           <a:p>
             <a:r>
               <a:rPr lang="en-US" dirty="0"/>
-              <a:t>P20 FINALIZATION_READY_FOR_LAST-EVIDENCE_INGESTION
+              <a:t>P20 FINALIZATION_READY_FOR_LAST_ARMOURY_EVIDENCE
 Assembly source: docs/presentation/assembly/slide_content.md
-Assembly SHA-256: a9756b6937c47f1129abc87917e7df5fd7b23d087d03117ea2de3666c84bc012
-Speaker note: Explain that a new execution identity repeated detection-to-report behavior under unchanged source and configuration, including browser evidence.</a:t>
+Assembly SHA-256: 069ed214d6ba35a7db18680172c06e99621b8b5b90bc394c256ecbe25f7a92fe
+Speaker note: Use the primary accepted P18 overview. Explain that one low-confidence machine observation moved through depth projection, session-local mapping, persistence, dashboard and deterministic reporting. Human review remained UNREVIEWED.</a:t>
             </a:r>
             <a:endParaRPr lang="en-US" dirty="0"/>
           </a:p>
@@ -884,10 +884,10 @@
           <a:p>
             <a:r>
               <a:rPr lang="en-US" dirty="0"/>
-              <a:t>P20 FINALIZATION_READY_FOR_LAST-EVIDENCE_INGESTION
+              <a:t>P20 FINALIZATION_READY_FOR_LAST_ARMOURY_EVIDENCE
 Assembly source: docs/presentation/assembly/slide_content.md
-Assembly SHA-256: a9756b6937c47f1129abc87917e7df5fd7b23d087d03117ea2de3666c84bc012
-Speaker note: Report all three values with the frozen interval and alignment method. They are measured against simulation ground truth and are not classified PASS or FAIL.</a:t>
+Assembly SHA-256: 069ed214d6ba35a7db18680172c06e99621b8b5b90bc394c256ecbe25f7a92fe
+Speaker note: Report the presentation-rounded values and sample counts. Mandatory qualification: these metrics evaluate localization trajectory accuracy, not absolute defect-position accuracy.</a:t>
             </a:r>
             <a:endParaRPr lang="en-US" dirty="0"/>
           </a:p>
@@ -975,10 +975,10 @@
           <a:p>
             <a:r>
               <a:rPr lang="en-US" dirty="0"/>
-              <a:t>P20 FINALIZATION_READY_FOR_LAST-EVIDENCE_INGESTION
+              <a:t>P20 FINALIZATION_READY_FOR_LAST_ARMOURY_EVIDENCE
 Assembly source: docs/presentation/assembly/slide_content.md
-Assembly SHA-256: a9756b6937c47f1129abc87917e7df5fd7b23d087d03117ea2de3666c84bc012
-Speaker note: State the implemented and demonstrated spatial chain, the measured localization result, and the one bounded pending item. Do not frame the pending correspondence as integrated-system failure.</a:t>
+Assembly SHA-256: 069ed214d6ba35a7db18680172c06e99621b8b5b90bc394c256ecbe25f7a92fe
+Speaker note: P19 development is closed for the capstone. For technical Q&amp;A only: qualifying receipt index 710; RGB and depth binding PASS; startup alignment PASS; truth PASS; 307,200 of 307,200 target pixels; operational GT publication NO. This is advanced R&amp;D validation infrastructure, not a production runtime requirement.</a:t>
             </a:r>
             <a:endParaRPr lang="en-US" dirty="0"/>
           </a:p>
@@ -1066,9 +1066,9 @@
           <a:p>
             <a:r>
               <a:rPr lang="en-US" dirty="0"/>
-              <a:t>P20 FINALIZATION_READY_FOR_LAST-EVIDENCE_INGESTION
+              <a:t>P20 FINALIZATION_READY_FOR_LAST_ARMOURY_EVIDENCE
 Assembly source: docs/presentation/assembly/slide_content.md
-Assembly SHA-256: a9756b6937c47f1129abc87917e7df5fd7b23d087d03117ea2de3666c84bc012
+Assembly SHA-256: 069ed214d6ba35a7db18680172c06e99621b8b5b90bc394c256ecbe25f7a92fe
 Speaker note: Explain the monotonic RAW degradation, that CLAHE is worse at L0-L3 and offers no general recovery, and that both are effectively collapsed at L4. The LL-DETECTOR slot remains optional.</a:t>
             </a:r>
             <a:endParaRPr lang="en-US" dirty="0"/>
@@ -1157,9 +1157,9 @@
           <a:p>
             <a:r>
               <a:rPr lang="en-US" dirty="0"/>
-              <a:t>P20 FINALIZATION_READY_FOR_LAST-EVIDENCE_INGESTION
+              <a:t>P20 FINALIZATION_READY_FOR_LAST_ARMOURY_EVIDENCE
 Assembly source: docs/presentation/assembly/slide_content.md
-Assembly SHA-256: a9756b6937c47f1129abc87917e7df5fd7b23d087d03117ea2de3666c84bc012
+Assembly SHA-256: 069ed214d6ba35a7db18680172c06e99621b8b5b90bc394c256ecbe25f7a92fe
 Speaker note: Use this only for Q&amp;A: identify the compact evidence index and explain that accepted artifacts are preserved rather than rewritten.</a:t>
             </a:r>
             <a:endParaRPr lang="en-US" dirty="0"/>
@@ -1248,10 +1248,10 @@
           <a:p>
             <a:r>
               <a:rPr lang="en-US" dirty="0"/>
-              <a:t>P20 FINALIZATION_READY_FOR_LAST-EVIDENCE_INGESTION
+              <a:t>P20 FINALIZATION_READY_FOR_LAST_ARMOURY_EVIDENCE
 Assembly source: docs/presentation/assembly/slide_content.md
-Assembly SHA-256: a9756b6937c47f1129abc87917e7df5fd7b23d087d03117ea2de3666c84bc012
-Speaker note: Be direct: detector performance is modest, external transfer is weak, simulation is not field accuracy, and two bounded final inputs remain open.</a:t>
+Assembly SHA-256: 069ed214d6ba35a7db18680172c06e99621b8b5b90bc394c256ecbe25f7a92fe
+Speaker note: Be direct: detector performance is modest, external transfer is weak, simulation is not field accuracy, P19 3D is frozen pending, and only the ARMOURY result remains open.</a:t>
             </a:r>
             <a:endParaRPr lang="en-US" dirty="0"/>
           </a:p>
@@ -1339,9 +1339,9 @@
           <a:p>
             <a:r>
               <a:rPr lang="en-US" dirty="0"/>
-              <a:t>P20 FINALIZATION_READY_FOR_LAST-EVIDENCE_INGESTION
+              <a:t>P20 FINALIZATION_READY_FOR_LAST_ARMOURY_EVIDENCE
 Assembly source: docs/presentation/assembly/slide_content.md
-Assembly SHA-256: a9756b6937c47f1129abc87917e7df5fd7b23d087d03117ea2de3666c84bc012
+Assembly SHA-256: 069ed214d6ba35a7db18680172c06e99621b8b5b90bc394c256ecbe25f7a92fe
 Speaker note: Translate the engineering into user value: repeatable evidence capture, traceable review, and modular deployment. These are application benefits, not market validation or production-readiness claims.</a:t>
             </a:r>
             <a:endParaRPr lang="en-US" dirty="0"/>
@@ -1430,10 +1430,10 @@
           <a:p>
             <a:r>
               <a:rPr lang="en-US" dirty="0"/>
-              <a:t>P20 FINALIZATION_READY_FOR_LAST-EVIDENCE_INGESTION
+              <a:t>P20 FINALIZATION_READY_FOR_LAST_ARMOURY_EVIDENCE
 Assembly source: docs/presentation/assembly/slide_content.md
-Assembly SHA-256: a9756b6937c47f1129abc87917e7df5fd7b23d087d03117ea2de3666c84bc012
-Speaker note: Close on what works today, then name only the two bounded inputs still expected from ARMOURY and MSI.</a:t>
+Assembly SHA-256: 069ed214d6ba35a7db18680172c06e99621b8b5b90bc394c256ecbe25f7a92fe
+Speaker note: Close on what works today, state that the MSI disposition is resolved, and name ARMOURY LL-DETECTOR as the only remaining late-evidence input.</a:t>
             </a:r>
             <a:endParaRPr lang="en-US" dirty="0"/>
           </a:p>
@@ -1521,9 +1521,9 @@
           <a:p>
             <a:r>
               <a:rPr lang="en-US" dirty="0"/>
-              <a:t>P20 FINALIZATION_READY_FOR_LAST-EVIDENCE_INGESTION
+              <a:t>P20 FINALIZATION_READY_FOR_LAST_ARMOURY_EVIDENCE
 Assembly source: docs/presentation/assembly/slide_content.md
-Assembly SHA-256: a9756b6937c47f1129abc87917e7df5fd7b23d087d03117ea2de3666c84bc012
+Assembly SHA-256: 069ed214d6ba35a7db18680172c06e99621b8b5b90bc394c256ecbe25f7a92fe
 Speaker note: Frame the problem as repeatable evidence capture and traceable review. The objective is an integrated, measurable workflow—not a claim of a validated autonomous mission.</a:t>
             </a:r>
             <a:endParaRPr lang="en-US" dirty="0"/>
@@ -1612,10 +1612,10 @@
           <a:p>
             <a:r>
               <a:rPr lang="en-US" dirty="0"/>
-              <a:t>P20 FINALIZATION_READY_FOR_LAST-EVIDENCE_INGESTION
+              <a:t>P20 FINALIZATION_READY_FOR_LAST_ARMOURY_EVIDENCE
 Assembly source: docs/presentation/assembly/slide_content.md
-Assembly SHA-256: a9756b6937c47f1129abc87917e7df5fd7b23d087d03117ea2de3666c84bc012
-Speaker note: Walk left to right from sensing to report. Call out demonstrated P16-P18 handoff, measured localization, and the bounded P19/LL pending items.</a:t>
+Assembly SHA-256: 069ed214d6ba35a7db18680172c06e99621b8b5b90bc394c256ecbe25f7a92fe
+Speaker note: Walk left to right from sensing to report. Call out accepted P18 core integration, measured localization, the frozen-pending P19 3D disposition, and the still-open LL-DETECTOR slot.</a:t>
             </a:r>
             <a:endParaRPr lang="en-US" dirty="0"/>
           </a:p>
@@ -1703,9 +1703,9 @@
           <a:p>
             <a:r>
               <a:rPr lang="en-US" dirty="0"/>
-              <a:t>P20 FINALIZATION_READY_FOR_LAST-EVIDENCE_INGESTION
+              <a:t>P20 FINALIZATION_READY_FOR_LAST_ARMOURY_EVIDENCE
 Assembly source: docs/presentation/assembly/slide_content.md
-Assembly SHA-256: a9756b6937c47f1129abc87917e7df5fd7b23d087d03117ea2de3666c84bc012
+Assembly SHA-256: 069ed214d6ba35a7db18680172c06e99621b8b5b90bc394c256ecbe25f7a92fe
 Speaker note: State the frozen dataset counts and six classes. These counts establish the data foundation; they are not performance metrics.</a:t>
             </a:r>
             <a:endParaRPr lang="en-US" dirty="0"/>
@@ -1794,9 +1794,9 @@
           <a:p>
             <a:r>
               <a:rPr lang="en-US" dirty="0"/>
-              <a:t>P20 FINALIZATION_READY_FOR_LAST-EVIDENCE_INGESTION
+              <a:t>P20 FINALIZATION_READY_FOR_LAST_ARMOURY_EVIDENCE
 Assembly source: docs/presentation/assembly/slide_content.md
-Assembly SHA-256: a9756b6937c47f1129abc87917e7df5fd7b23d087d03117ea2de3666c84bc012
+Assembly SHA-256: 069ed214d6ba35a7db18680172c06e99621b8b5b90bc394c256ecbe25f7a92fe
 Speaker note: Present mAP as detection performance on the one-time held-out split. The diagnostic confidence came from validation; no threshold was tuned on test.</a:t>
             </a:r>
             <a:endParaRPr lang="en-US" dirty="0"/>
@@ -1885,9 +1885,9 @@
           <a:p>
             <a:r>
               <a:rPr lang="en-US" dirty="0"/>
-              <a:t>P20 FINALIZATION_READY_FOR_LAST-EVIDENCE_INGESTION
+              <a:t>P20 FINALIZATION_READY_FOR_LAST_ARMOURY_EVIDENCE
 Assembly source: docs/presentation/assembly/slide_content.md
-Assembly SHA-256: a9756b6937c47f1129abc87917e7df5fd7b23d087d03117ea2de3666c84bc012
+Assembly SHA-256: 069ed214d6ba35a7db18680172c06e99621b8b5b90bc394c256ecbe25f7a92fe
 Speaker note: Separate runtime acceptance from accuracy: LiDAR ICP ran successfully, while trajectory accuracy is reported later as MEASURED without a PASS threshold.</a:t>
             </a:r>
             <a:endParaRPr lang="en-US" dirty="0"/>
@@ -1976,9 +1976,9 @@
           <a:p>
             <a:r>
               <a:rPr lang="en-US" dirty="0"/>
-              <a:t>P20 FINALIZATION_READY_FOR_LAST-EVIDENCE_INGESTION
+              <a:t>P20 FINALIZATION_READY_FOR_LAST_ARMOURY_EVIDENCE
 Assembly source: docs/presentation/assembly/slide_content.md
-Assembly SHA-256: a9756b6937c47f1129abc87917e7df5fd7b23d087d03117ea2de3666c84bc012
+Assembly SHA-256: 069ed214d6ba35a7db18680172c06e99621b8b5b90bc394c256ecbe25f7a92fe
 Speaker note: Explain the metric-depth contract and ProjectCamera output frame. This is simulation/runtime evidence, not real-world depth or global-position accuracy.</a:t>
             </a:r>
             <a:endParaRPr lang="en-US" dirty="0"/>
@@ -2067,10 +2067,10 @@
           <a:p>
             <a:r>
               <a:rPr lang="en-US" dirty="0"/>
-              <a:t>P20 FINALIZATION_READY_FOR_LAST-EVIDENCE_INGESTION
+              <a:t>P20 FINALIZATION_READY_FOR_LAST_ARMOURY_EVIDENCE
 Assembly source: docs/presentation/assembly/slide_content.md
-Assembly SHA-256: a9756b6937c47f1129abc87917e7df5fd7b23d087d03117ea2de3666c84bc012
-Speaker note: Trace one accepted record from camera geometry through pose transform, aggregation and map XYZ. Final quantitative 3D correspondence remains pending.</a:t>
+Assembly SHA-256: 069ed214d6ba35a7db18680172c06e99621b8b5b90bc394c256ecbe25f7a92fe
+Speaker note: Trace the accepted P18 observation from depth-based camera XYZ into session-local map XYZ and the persisted record. These are not globally surveyed coordinates.</a:t>
             </a:r>
             <a:endParaRPr lang="en-US" dirty="0"/>
           </a:p>
@@ -2158,9 +2158,9 @@
           <a:p>
             <a:r>
               <a:rPr lang="en-US" dirty="0"/>
-              <a:t>P20 FINALIZATION_READY_FOR_LAST-EVIDENCE_INGESTION
+              <a:t>P20 FINALIZATION_READY_FOR_LAST_ARMOURY_EVIDENCE
 Assembly source: docs/presentation/assembly/slide_content.md
-Assembly SHA-256: a9756b6937c47f1129abc87917e7df5fd7b23d087d03117ea2de3666c84bc012
+Assembly SHA-256: 069ed214d6ba35a7db18680172c06e99621b8b5b90bc394c256ecbe25f7a92fe
 Speaker note: Show that the record persists and is reviewable. Stress that it is extremely-low-confidence and UNREVIEWED, not a confirmed physical defect.</a:t>
             </a:r>
             <a:endParaRPr lang="en-US" dirty="0"/>
@@ -2841,7 +2841,7 @@
                 <a:ea typeface="Aptos" pitchFamily="34" charset="-122"/>
                 <a:cs typeface="Aptos" pitchFamily="34" charset="-120"/>
               </a:rPr>
-              <a:t>AEGISINSPECT  |  FINALIZATION READY  |  LAST-EVIDENCE INGESTION OPEN</a:t>
+              <a:t>AEGISINSPECT  |  FINALIZATION READY  |  LAST ARMOURY EVIDENCE OPEN</a:t>
             </a:r>
             <a:endParaRPr lang="en-US" sz="750" dirty="0"/>
           </a:p>
@@ -3083,7 +3083,7 @@
                 <a:ea typeface="Aptos" pitchFamily="34" charset="-122"/>
                 <a:cs typeface="Aptos" pitchFamily="34" charset="-120"/>
               </a:rPr>
-              <a:t>DEMONSTRATED / VERIFIED REAL HANDOFF</a:t>
+              <a:t>DEMONSTRATED / ACCEPTED P18 REPORT</a:t>
             </a:r>
             <a:endParaRPr lang="en-US" sz="750" dirty="0"/>
           </a:p>
@@ -3190,7 +3190,7 @@
                 <a:ea typeface="Courier New" pitchFamily="34" charset="-122"/>
                 <a:cs typeface="Courier New" pitchFamily="34" charset="-120"/>
               </a:rPr>
-              <a:t>Inspection ID: 2026091901</a:t>
+              <a:t>Inspection ID: 2026091904</a:t>
             </a:r>
             <a:endParaRPr lang="en-US" sz="1350" dirty="0"/>
           </a:p>
@@ -3207,7 +3207,7 @@
                 <a:ea typeface="Courier New" pitchFamily="34" charset="-122"/>
                 <a:cs typeface="Courier New" pitchFamily="34" charset="-120"/>
               </a:rPr>
-              <a:t>Defect ID: P15D-10627c5f-3f84-5c64-ab2d-3e574b6e97ee</a:t>
+              <a:t>Defect ID: P15D-9b8ae056-1255-5cf4-ba40-e57a11f35e13</a:t>
             </a:r>
             <a:endParaRPr lang="en-US" sz="1350" dirty="0"/>
           </a:p>
@@ -3241,7 +3241,7 @@
                 <a:ea typeface="Courier New" pitchFamily="34" charset="-122"/>
                 <a:cs typeface="Courier New" pitchFamily="34" charset="-120"/>
               </a:rPr>
-              <a:t>Confidence: 0.004553093574941158</a:t>
+              <a:t>Confidence: 0.011138029396533966</a:t>
             </a:r>
             <a:endParaRPr lang="en-US" sz="1350" dirty="0"/>
           </a:p>
@@ -3258,7 +3258,7 @@
                 <a:ea typeface="Courier New" pitchFamily="34" charset="-122"/>
                 <a:cs typeface="Courier New" pitchFamily="34" charset="-120"/>
               </a:rPr>
-              <a:t>Coordinate frame: map</a:t>
+              <a:t>Coordinate frame: map (session-local)</a:t>
             </a:r>
             <a:endParaRPr lang="en-US" sz="1350" dirty="0"/>
           </a:p>
@@ -3467,7 +3467,7 @@
                 <a:ea typeface="Aptos" pitchFamily="34" charset="-122"/>
                 <a:cs typeface="Aptos" pitchFamily="34" charset="-120"/>
               </a:rPr>
-              <a:t>deterministic P17 report</a:t>
+              <a:t>accepted P18 / P17 report</a:t>
             </a:r>
             <a:endParaRPr lang="en-US" sz="750" dirty="0"/>
           </a:p>
@@ -3570,7 +3570,7 @@
                 <a:ea typeface="Aptos" pitchFamily="34" charset="-122"/>
                 <a:cs typeface="Aptos" pitchFamily="34" charset="-120"/>
               </a:rPr>
-              <a:t>AEGISINSPECT  |  FINALIZATION READY  |  LAST-EVIDENCE INGESTION OPEN</a:t>
+              <a:t>AEGISINSPECT  |  FINALIZATION READY  |  LAST ARMOURY EVIDENCE OPEN</a:t>
             </a:r>
             <a:endParaRPr lang="en-US" sz="750" dirty="0"/>
           </a:p>
@@ -4154,7 +4154,7 @@
                 <a:ea typeface="Aptos" pitchFamily="34" charset="-122"/>
                 <a:cs typeface="Aptos" pitchFamily="34" charset="-120"/>
               </a:rPr>
-              <a:t>AEGISINSPECT  |  FINALIZATION READY  |  LAST-EVIDENCE INGESTION OPEN</a:t>
+              <a:t>AEGISINSPECT  |  FINALIZATION READY  |  LAST ARMOURY EVIDENCE OPEN</a:t>
             </a:r>
             <a:endParaRPr lang="en-US" sz="750" dirty="0"/>
           </a:p>
@@ -4305,7 +4305,7 @@
                 <a:ea typeface="Aptos" pitchFamily="34" charset="-122"/>
                 <a:cs typeface="Aptos" pitchFamily="34" charset="-120"/>
               </a:rPr>
-              <a:t>P18 Clean Repeatability</a:t>
+              <a:t>P18 Integrated Inspection Evidence</a:t>
             </a:r>
             <a:endParaRPr lang="en-US" sz="2500" dirty="0"/>
           </a:p>
@@ -4396,7 +4396,7 @@
                 <a:ea typeface="Aptos" pitchFamily="34" charset="-122"/>
                 <a:cs typeface="Aptos" pitchFamily="34" charset="-120"/>
               </a:rPr>
-              <a:t>DEMONSTRATED / VERIFIED PACKAGE</a:t>
+              <a:t>DEMONSTRATED / CORE INTEGRATION ACCEPTED</a:t>
             </a:r>
             <a:endParaRPr lang="en-US" sz="750" dirty="0"/>
           </a:p>
@@ -4512,7 +4512,7 @@
                 <a:ea typeface="Aptos" pitchFamily="34" charset="-122"/>
                 <a:cs typeface="Aptos" pitchFamily="34" charset="-120"/>
               </a:rPr>
-              <a:t>CLEAN REPEATABILITY</a:t>
+              <a:t>P18 CORE INTEGRATION</a:t>
             </a:r>
             <a:endParaRPr lang="en-US" sz="720" dirty="0"/>
           </a:p>
@@ -4553,7 +4553,7 @@
                 <a:ea typeface="Aptos" pitchFamily="34" charset="-122"/>
                 <a:cs typeface="Aptos" pitchFamily="34" charset="-120"/>
               </a:rPr>
-              <a:t>PASS</a:t>
+              <a:t>ACCEPTED</a:t>
             </a:r>
             <a:endParaRPr lang="en-US" sz="2000" dirty="0"/>
           </a:p>
@@ -4594,7 +4594,7 @@
                 <a:ea typeface="Aptos" pitchFamily="34" charset="-122"/>
                 <a:cs typeface="Aptos" pitchFamily="34" charset="-120"/>
               </a:rPr>
-              <a:t>accepted execution identity</a:t>
+              <a:t>repeatability PASS</a:t>
             </a:r>
             <a:endParaRPr lang="en-US" sz="750" dirty="0"/>
           </a:p>
@@ -4608,8 +4608,8 @@
         </p:nvSpPr>
         <p:spPr>
           <a:xfrm>
-            <a:off x="8430768" y="2999232"/>
-            <a:ext cx="2907792" cy="1783080"/>
+            <a:off x="8430768" y="2907792"/>
+            <a:ext cx="2907792" cy="1965960"/>
           </a:xfrm>
           <a:prstGeom prst="rect">
             <a:avLst/>
@@ -4627,7 +4627,7 @@
               <a:buNone/>
             </a:pPr>
             <a:r>
-              <a:rPr lang="en-US" sz="1230" dirty="0">
+              <a:rPr lang="en-US" sz="1080" dirty="0">
                 <a:solidFill>
                   <a:srgbClr val="17212B"/>
                 </a:solidFill>
@@ -4635,9 +4635,77 @@
                 <a:ea typeface="Aptos" pitchFamily="34" charset="-122"/>
                 <a:cs typeface="Aptos" pitchFamily="34" charset="-120"/>
               </a:rPr>
-              <a:t>The clean repeatability package records a new detection and mapped-defect identity, P16 PASS, browser screenshots PASS and P17 PASS under unchanged source and configuration.</a:t>
-            </a:r>
-            <a:endParaRPr lang="en-US" sz="1230" dirty="0"/>
+              <a:t>Honeycombing machine class</a:t>
+            </a:r>
+            <a:endParaRPr lang="en-US" sz="1080" dirty="0"/>
+          </a:p>
+          <a:p>
+            <a:pPr algn="ctr" indent="0" marL="0">
+              <a:buNone/>
+            </a:pPr>
+            <a:r>
+              <a:rPr lang="en-US" sz="1080" dirty="0">
+                <a:solidFill>
+                  <a:srgbClr val="17212B"/>
+                </a:solidFill>
+                <a:latin typeface="Aptos" pitchFamily="34" charset="0"/>
+                <a:ea typeface="Aptos" pitchFamily="34" charset="-122"/>
+                <a:cs typeface="Aptos" pitchFamily="34" charset="-120"/>
+              </a:rPr>
+              <a:t>Confidence: 0.011138029396533966</a:t>
+            </a:r>
+            <a:endParaRPr lang="en-US" sz="1080" dirty="0"/>
+          </a:p>
+          <a:p>
+            <a:pPr algn="ctr" indent="0" marL="0">
+              <a:buNone/>
+            </a:pPr>
+            <a:r>
+              <a:rPr lang="en-US" sz="1080" dirty="0">
+                <a:solidFill>
+                  <a:srgbClr val="17212B"/>
+                </a:solidFill>
+                <a:latin typeface="Aptos" pitchFamily="34" charset="0"/>
+                <a:ea typeface="Aptos" pitchFamily="34" charset="-122"/>
+                <a:cs typeface="Aptos" pitchFamily="34" charset="-120"/>
+              </a:rPr>
+              <a:t>Camera XYZ: approx. [0.0056, -0.0028, 3.1251] m</a:t>
+            </a:r>
+            <a:endParaRPr lang="en-US" sz="1080" dirty="0"/>
+          </a:p>
+          <a:p>
+            <a:pPr algn="ctr" indent="0" marL="0">
+              <a:buNone/>
+            </a:pPr>
+            <a:r>
+              <a:rPr lang="en-US" sz="1080" dirty="0">
+                <a:solidFill>
+                  <a:srgbClr val="17212B"/>
+                </a:solidFill>
+                <a:latin typeface="Aptos" pitchFamily="34" charset="0"/>
+                <a:ea typeface="Aptos" pitchFamily="34" charset="-122"/>
+                <a:cs typeface="Aptos" pitchFamily="34" charset="-120"/>
+              </a:rPr>
+              <a:t>Session-local map XYZ: approx. [3.8882, 0.0712, -0.0035] m</a:t>
+            </a:r>
+            <a:endParaRPr lang="en-US" sz="1080" dirty="0"/>
+          </a:p>
+          <a:p>
+            <a:pPr algn="ctr" indent="0" marL="0">
+              <a:buNone/>
+            </a:pPr>
+            <a:r>
+              <a:rPr lang="en-US" sz="1080" dirty="0">
+                <a:solidFill>
+                  <a:srgbClr val="17212B"/>
+                </a:solidFill>
+                <a:latin typeface="Aptos" pitchFamily="34" charset="0"/>
+                <a:ea typeface="Aptos" pitchFamily="34" charset="-122"/>
+                <a:cs typeface="Aptos" pitchFamily="34" charset="-120"/>
+              </a:rPr>
+              <a:t>Review: UNREVIEWED</a:t>
+            </a:r>
+            <a:endParaRPr lang="en-US" sz="1080" dirty="0"/>
           </a:p>
         </p:txBody>
       </p:sp>
@@ -4676,7 +4744,7 @@
                 <a:ea typeface="Aptos" pitchFamily="34" charset="-122"/>
                 <a:cs typeface="Aptos" pitchFamily="34" charset="-120"/>
               </a:rPr>
-              <a:t>P19 3D correspondence and LL-DETECTOR evaluation remain pending.</a:t>
+              <a:t>Not a confirmed physical defect, diagnosis or structural-safety finding.</a:t>
             </a:r>
             <a:endParaRPr lang="en-US" sz="1070" dirty="0"/>
           </a:p>
@@ -4738,7 +4806,7 @@
                 <a:ea typeface="Aptos" pitchFamily="34" charset="-122"/>
                 <a:cs typeface="Aptos" pitchFamily="34" charset="-120"/>
               </a:rPr>
-              <a:t>AEGISINSPECT  |  FINALIZATION READY  |  LAST-EVIDENCE INGESTION OPEN</a:t>
+              <a:t>AEGISINSPECT  |  FINALIZATION READY  |  LAST ARMOURY EVIDENCE OPEN</a:t>
             </a:r>
             <a:endParaRPr lang="en-US" sz="750" dirty="0"/>
           </a:p>
@@ -5114,7 +5182,7 @@
                 <a:ea typeface="Aptos" pitchFamily="34" charset="-122"/>
                 <a:cs typeface="Aptos" pitchFamily="34" charset="-120"/>
               </a:rPr>
-              <a:t>0.595396782192 m</a:t>
+              <a:t>0.595 m</a:t>
             </a:r>
             <a:endParaRPr lang="en-US" sz="2000" dirty="0"/>
           </a:p>
@@ -5155,7 +5223,7 @@
                 <a:ea typeface="Aptos" pitchFamily="34" charset="-122"/>
                 <a:cs typeface="Aptos" pitchFamily="34" charset="-120"/>
               </a:rPr>
-              <a:t>76 matched samples; interval 3-18 s</a:t>
+              <a:t>76 samples; interval 3-18 s</a:t>
             </a:r>
             <a:endParaRPr lang="en-US" sz="750" dirty="0"/>
           </a:p>
@@ -5289,7 +5357,7 @@
                 <a:ea typeface="Aptos" pitchFamily="34" charset="-122"/>
                 <a:cs typeface="Aptos" pitchFamily="34" charset="-120"/>
               </a:rPr>
-              <a:t>0.340604743330 m</a:t>
+              <a:t>0.341 m</a:t>
             </a:r>
             <a:endParaRPr lang="en-US" sz="2000" dirty="0"/>
           </a:p>
@@ -5464,7 +5532,7 @@
                 <a:ea typeface="Aptos" pitchFamily="34" charset="-122"/>
                 <a:cs typeface="Aptos" pitchFamily="34" charset="-120"/>
               </a:rPr>
-              <a:t>1.707265244063 deg</a:t>
+              <a:t>1.707 degrees</a:t>
             </a:r>
             <a:endParaRPr lang="en-US" sz="2000" dirty="0"/>
           </a:p>
@@ -5587,7 +5655,7 @@
                 <a:ea typeface="Aptos" pitchFamily="34" charset="-122"/>
                 <a:cs typeface="Aptos" pitchFamily="34" charset="-120"/>
               </a:rPr>
-              <a:t>Runtime acceptance: PASS. Localization accuracy: MEASURED. No frozen localization-accuracy pass/fail threshold exists.</a:t>
+              <a:t>These metrics evaluate localization trajectory accuracy, not absolute defect-position accuracy.</a:t>
             </a:r>
             <a:endParaRPr lang="en-US" sz="1700" dirty="0"/>
           </a:p>
@@ -5649,7 +5717,7 @@
                 <a:ea typeface="Aptos" pitchFamily="34" charset="-122"/>
                 <a:cs typeface="Aptos" pitchFamily="34" charset="-120"/>
               </a:rPr>
-              <a:t>AEGISINSPECT  |  FINALIZATION READY  |  LAST-EVIDENCE INGESTION OPEN</a:t>
+              <a:t>AEGISINSPECT  |  FINALIZATION READY  |  LAST ARMOURY EVIDENCE OPEN</a:t>
             </a:r>
             <a:endParaRPr lang="en-US" sz="750" dirty="0"/>
           </a:p>
@@ -5800,7 +5868,7 @@
                 <a:ea typeface="Aptos" pitchFamily="34" charset="-122"/>
                 <a:cs typeface="Aptos" pitchFamily="34" charset="-120"/>
               </a:rPr>
-              <a:t>P19 Spatial Validation Status</a:t>
+              <a:t>P19 Capstone Disposition</a:t>
             </a:r>
             <a:endParaRPr lang="en-US" sz="2500" dirty="0"/>
           </a:p>
@@ -5891,7 +5959,7 @@
                 <a:ea typeface="Aptos" pitchFamily="34" charset="-122"/>
                 <a:cs typeface="Aptos" pitchFamily="34" charset="-120"/>
               </a:rPr>
-              <a:t>PENDING / FINAL 3D CORRESPONDENCE</a:t>
+              <a:t>PENDING / FROZEN CAPSTONE DISPOSITION</a:t>
             </a:r>
             <a:endParaRPr lang="en-US" sz="750" dirty="0"/>
           </a:p>
@@ -6724,8 +6792,8 @@
         </p:nvSpPr>
         <p:spPr>
           <a:xfrm>
-            <a:off x="7040880" y="3310128"/>
-            <a:ext cx="4023360" cy="1325880"/>
+            <a:off x="7040880" y="3264408"/>
+            <a:ext cx="4023360" cy="1417320"/>
           </a:xfrm>
           <a:prstGeom prst="rect">
             <a:avLst/>
@@ -6743,7 +6811,7 @@
               <a:buNone/>
             </a:pPr>
             <a:r>
-              <a:rPr lang="en-US" sz="1250" dirty="0">
+              <a:rPr lang="en-US" sz="1200" dirty="0">
                 <a:solidFill>
                   <a:srgbClr val="17212B"/>
                 </a:solidFill>
@@ -6751,16 +6819,16 @@
                 <a:ea typeface="Aptos" pitchFamily="34" charset="-122"/>
                 <a:cs typeface="Aptos" pitchFamily="34" charset="-120"/>
               </a:rPr>
-              <a:t>FINAL RESULT SLOT</a:t>
-            </a:r>
-            <a:endParaRPr lang="en-US" sz="1250" dirty="0"/>
+              <a:t>FROZEN PENDING</a:t>
+            </a:r>
+            <a:endParaRPr lang="en-US" sz="1200" dirty="0"/>
           </a:p>
           <a:p>
             <a:pPr algn="ctr" indent="0" marL="0">
               <a:buNone/>
             </a:pPr>
             <a:r>
-              <a:rPr lang="en-US" sz="1250" dirty="0">
+              <a:rPr lang="en-US" sz="1200" dirty="0">
                 <a:solidFill>
                   <a:srgbClr val="17212B"/>
                 </a:solidFill>
@@ -6768,22 +6836,22 @@
                 <a:ea typeface="Aptos" pitchFamily="34" charset="-122"/>
                 <a:cs typeface="Aptos" pitchFamily="34" charset="-120"/>
               </a:rPr>
-              <a:t>If accepted: insert actual GT↔mapped-defect correspondence and metric.</a:t>
-            </a:r>
-            <a:endParaRPr lang="en-US" sz="1250" dirty="0"/>
+              <a:t>Final quantitative simulator-ground-truth correspondence validation of absolute defect-position accuracy remained pending at the capstone freeze.</a:t>
+            </a:r>
+            <a:endParaRPr lang="en-US" sz="1200" dirty="0"/>
           </a:p>
           <a:p>
             <a:pPr algn="ctr" indent="0" marL="0">
               <a:buNone/>
             </a:pPr>
-            <a:endParaRPr lang="en-US" sz="1250" dirty="0"/>
+            <a:endParaRPr lang="en-US" sz="1200" dirty="0"/>
           </a:p>
           <a:p>
             <a:pPr algn="ctr" indent="0" marL="0">
               <a:buNone/>
             </a:pPr>
             <a:r>
-              <a:rPr lang="en-US" sz="1250" dirty="0">
+              <a:rPr lang="en-US" sz="1200" dirty="0">
                 <a:solidFill>
                   <a:srgbClr val="17212B"/>
                 </a:solidFill>
@@ -6791,9 +6859,9 @@
                 <a:ea typeface="Aptos" pitchFamily="34" charset="-122"/>
                 <a:cs typeface="Aptos" pitchFamily="34" charset="-120"/>
               </a:rPr>
-              <a:t>Fallback: final quantitative simulator-ground-truth correspondence validation for 3D defect-position accuracy remains pending.</a:t>
-            </a:r>
-            <a:endParaRPr lang="en-US" sz="1250" dirty="0"/>
+              <a:t>P19 development: CLOSED</a:t>
+            </a:r>
+            <a:endParaRPr lang="en-US" sz="1200" dirty="0"/>
           </a:p>
         </p:txBody>
       </p:sp>
@@ -6805,8 +6873,8 @@
         </p:nvSpPr>
         <p:spPr>
           <a:xfrm>
-            <a:off x="1051560" y="5349240"/>
-            <a:ext cx="10058400" cy="320040"/>
+            <a:off x="1051560" y="5285232"/>
+            <a:ext cx="10058400" cy="438912"/>
           </a:xfrm>
           <a:prstGeom prst="rect">
             <a:avLst/>
@@ -6832,7 +6900,7 @@
                 <a:ea typeface="Aptos" pitchFamily="34" charset="-122"/>
                 <a:cs typeface="Aptos" pitchFamily="34" charset="-120"/>
               </a:rPr>
-              <a:t>The pending P19 research measurement does not invalidate the demonstrated P18 integrated chain.</a:t>
+              <a:t>3D defect-to-map integration was demonstrated through P18; localization accuracy was quantitatively measured.</a:t>
             </a:r>
             <a:endParaRPr lang="en-US" sz="1400" dirty="0"/>
           </a:p>
@@ -6894,7 +6962,7 @@
                 <a:ea typeface="Aptos" pitchFamily="34" charset="-122"/>
                 <a:cs typeface="Aptos" pitchFamily="34" charset="-120"/>
               </a:rPr>
-              <a:t>AEGISINSPECT  |  FINALIZATION READY  |  LAST-EVIDENCE INGESTION OPEN</a:t>
+              <a:t>AEGISINSPECT  |  FINALIZATION READY  |  LAST ARMOURY EVIDENCE OPEN</a:t>
             </a:r>
             <a:endParaRPr lang="en-US" sz="750" dirty="0"/>
           </a:p>
@@ -8575,7 +8643,7 @@
                 <a:ea typeface="Aptos" pitchFamily="34" charset="-122"/>
                 <a:cs typeface="Aptos" pitchFamily="34" charset="-120"/>
               </a:rPr>
-              <a:t>AEGISINSPECT  |  FINALIZATION READY  |  LAST-EVIDENCE INGESTION OPEN</a:t>
+              <a:t>AEGISINSPECT  |  FINALIZATION READY  |  LAST ARMOURY EVIDENCE OPEN</a:t>
             </a:r>
             <a:endParaRPr lang="en-US" sz="750" dirty="0"/>
           </a:p>
@@ -9238,7 +9306,7 @@
                 <a:ea typeface="Aptos" pitchFamily="34" charset="-122"/>
                 <a:cs typeface="Aptos" pitchFamily="34" charset="-120"/>
               </a:rPr>
-              <a:t>AEGISINSPECT  |  FINALIZATION READY  |  LAST-EVIDENCE INGESTION OPEN</a:t>
+              <a:t>AEGISINSPECT  |  FINALIZATION READY  |  LAST ARMOURY EVIDENCE OPEN</a:t>
             </a:r>
             <a:endParaRPr lang="en-US" sz="750" dirty="0"/>
           </a:p>
@@ -9555,7 +9623,7 @@
                 <a:ea typeface="Aptos" pitchFamily="34" charset="-122"/>
                 <a:cs typeface="Aptos" pitchFamily="34" charset="-120"/>
               </a:rPr>
-              <a:t>- Accepted P16/P17 example is extremely-low-confidence, unreviewed machine output</a:t>
+              <a:t>- Accepted dashboard examples are low-confidence, unreviewed machine output</a:t>
             </a:r>
             <a:endParaRPr lang="en-US" sz="1600" dirty="0"/>
           </a:p>
@@ -9572,7 +9640,7 @@
                 <a:ea typeface="Aptos" pitchFamily="34" charset="-122"/>
                 <a:cs typeface="Aptos" pitchFamily="34" charset="-120"/>
               </a:rPr>
-              <a:t>- P19 localization is measured, not threshold-classified as accurate</a:t>
+              <a:t>- P19 localization is measured trajectory accuracy, not defect-position accuracy</a:t>
             </a:r>
             <a:endParaRPr lang="en-US" sz="1600" dirty="0"/>
           </a:p>
@@ -9589,7 +9657,7 @@
                 <a:ea typeface="Aptos" pitchFamily="34" charset="-122"/>
                 <a:cs typeface="Aptos" pitchFamily="34" charset="-120"/>
               </a:rPr>
-              <a:t>- P19 3D requires final explicit simulator-ground-truth correspondence</a:t>
+              <a:t>- P19 3D correspondence validation is frozen pending at capstone close</a:t>
             </a:r>
             <a:endParaRPr lang="en-US" sz="1600" dirty="0"/>
           </a:p>
@@ -9685,7 +9753,7 @@
                 <a:ea typeface="Aptos" pitchFamily="34" charset="-122"/>
                 <a:cs typeface="Aptos" pitchFamily="34" charset="-120"/>
               </a:rPr>
-              <a:t>AEGISINSPECT  |  FINALIZATION READY  |  LAST-EVIDENCE INGESTION OPEN</a:t>
+              <a:t>AEGISINSPECT  |  FINALIZATION READY  |  LAST ARMOURY EVIDENCE OPEN</a:t>
             </a:r>
             <a:endParaRPr lang="en-US" sz="750" dirty="0"/>
           </a:p>
@@ -10647,7 +10715,7 @@
                 <a:ea typeface="Aptos" pitchFamily="34" charset="-122"/>
                 <a:cs typeface="Aptos" pitchFamily="34" charset="-120"/>
               </a:rPr>
-              <a:t>AEGISINSPECT  |  FINALIZATION READY  |  LAST-EVIDENCE INGESTION OPEN</a:t>
+              <a:t>AEGISINSPECT  |  FINALIZATION READY  |  LAST ARMOURY EVIDENCE OPEN</a:t>
             </a:r>
             <a:endParaRPr lang="en-US" sz="750" dirty="0"/>
           </a:p>
@@ -10971,7 +11039,7 @@
                 <a:ea typeface="Aptos" pitchFamily="34" charset="-122"/>
                 <a:cs typeface="Aptos" pitchFamily="34" charset="-120"/>
               </a:rPr>
-              <a:t>Next accepted inputs: final P19 3D correspondence; LL-DETECTOR L0-L4 evaluation.</a:t>
+              <a:t>Only remaining late-evidence input: accepted LL-DETECTOR L0-L4 evaluation, if completed.</a:t>
             </a:r>
             <a:endParaRPr lang="en-US" sz="1800" dirty="0"/>
           </a:p>
@@ -11012,7 +11080,7 @@
                 <a:ea typeface="Aptos" pitchFamily="34" charset="-122"/>
                 <a:cs typeface="Aptos" pitchFamily="34" charset="-120"/>
               </a:rPr>
-              <a:t>Implemented is not the same as measured. Pending results remain visible.</a:t>
+              <a:t>Implemented is not the same as measured. The frozen-pending status remains visible.</a:t>
             </a:r>
             <a:endParaRPr lang="en-US" sz="1600" dirty="0"/>
           </a:p>
@@ -11074,7 +11142,7 @@
                 <a:ea typeface="Aptos" pitchFamily="34" charset="-122"/>
                 <a:cs typeface="Aptos" pitchFamily="34" charset="-120"/>
               </a:rPr>
-              <a:t>AEGISINSPECT  |  FINALIZATION READY  |  LAST-EVIDENCE INGESTION OPEN</a:t>
+              <a:t>AEGISINSPECT  |  FINALIZATION READY  |  LAST ARMOURY EVIDENCE OPEN</a:t>
             </a:r>
             <a:endParaRPr lang="en-US" sz="750" dirty="0"/>
           </a:p>
@@ -11552,7 +11620,7 @@
                 <a:ea typeface="Aptos" pitchFamily="34" charset="-122"/>
                 <a:cs typeface="Aptos" pitchFamily="34" charset="-120"/>
               </a:rPr>
-              <a:t>AEGISINSPECT  |  FINALIZATION READY  |  LAST-EVIDENCE INGESTION OPEN</a:t>
+              <a:t>AEGISINSPECT  |  FINALIZATION READY  |  LAST ARMOURY EVIDENCE OPEN</a:t>
             </a:r>
             <a:endParaRPr lang="en-US" sz="750" dirty="0"/>
           </a:p>
@@ -13090,7 +13158,7 @@
                 <a:ea typeface="Aptos" pitchFamily="34" charset="-122"/>
                 <a:cs typeface="Aptos" pitchFamily="34" charset="-120"/>
               </a:rPr>
-              <a:t>P19 3D + LL detector</a:t>
+              <a:t>P19 frozen / LL open</a:t>
             </a:r>
             <a:endParaRPr lang="en-US" sz="1600" dirty="0"/>
           </a:p>
@@ -13131,7 +13199,7 @@
                 <a:ea typeface="Aptos" pitchFamily="34" charset="-122"/>
                 <a:cs typeface="Aptos" pitchFamily="34" charset="-120"/>
               </a:rPr>
-              <a:t>final correspondence / learned model</a:t>
+              <a:t>capstone disposition / learned model</a:t>
             </a:r>
             <a:endParaRPr lang="en-US" sz="750" dirty="0"/>
           </a:p>
@@ -13193,7 +13261,7 @@
                 <a:ea typeface="Aptos" pitchFamily="34" charset="-122"/>
                 <a:cs typeface="Aptos" pitchFamily="34" charset="-120"/>
               </a:rPr>
-              <a:t>AEGISINSPECT  |  FINALIZATION READY  |  LAST-EVIDENCE INGESTION OPEN</a:t>
+              <a:t>AEGISINSPECT  |  FINALIZATION READY  |  LAST ARMOURY EVIDENCE OPEN</a:t>
             </a:r>
             <a:endParaRPr lang="en-US" sz="750" dirty="0"/>
           </a:p>
@@ -14364,7 +14432,7 @@
                 <a:ea typeface="Aptos" pitchFamily="34" charset="-122"/>
                 <a:cs typeface="Aptos" pitchFamily="34" charset="-120"/>
               </a:rPr>
-              <a:t>AEGISINSPECT  |  FINALIZATION READY  |  LAST-EVIDENCE INGESTION OPEN</a:t>
+              <a:t>AEGISINSPECT  |  FINALIZATION READY  |  LAST ARMOURY EVIDENCE OPEN</a:t>
             </a:r>
             <a:endParaRPr lang="en-US" sz="750" dirty="0"/>
           </a:p>
@@ -15367,7 +15435,7 @@
                 <a:ea typeface="Aptos" pitchFamily="34" charset="-122"/>
                 <a:cs typeface="Aptos" pitchFamily="34" charset="-120"/>
               </a:rPr>
-              <a:t>AEGISINSPECT  |  FINALIZATION READY  |  LAST-EVIDENCE INGESTION OPEN</a:t>
+              <a:t>AEGISINSPECT  |  FINALIZATION READY  |  LAST ARMOURY EVIDENCE OPEN</a:t>
             </a:r>
             <a:endParaRPr lang="en-US" sz="750" dirty="0"/>
           </a:p>
@@ -16154,7 +16222,7 @@
                 <a:ea typeface="Aptos" pitchFamily="34" charset="-122"/>
                 <a:cs typeface="Aptos" pitchFamily="34" charset="-120"/>
               </a:rPr>
-              <a:t>AEGISINSPECT  |  FINALIZATION READY  |  LAST-EVIDENCE INGESTION OPEN</a:t>
+              <a:t>AEGISINSPECT  |  FINALIZATION READY  |  LAST ARMOURY EVIDENCE OPEN</a:t>
             </a:r>
             <a:endParaRPr lang="en-US" sz="750" dirty="0"/>
           </a:p>
@@ -17199,7 +17267,7 @@
                 <a:ea typeface="Aptos" pitchFamily="34" charset="-122"/>
                 <a:cs typeface="Aptos" pitchFamily="34" charset="-120"/>
               </a:rPr>
-              <a:t>AEGISINSPECT  |  FINALIZATION READY  |  LAST-EVIDENCE INGESTION OPEN</a:t>
+              <a:t>AEGISINSPECT  |  FINALIZATION READY  |  LAST ARMOURY EVIDENCE OPEN</a:t>
             </a:r>
             <a:endParaRPr lang="en-US" sz="750" dirty="0"/>
           </a:p>
@@ -17441,7 +17509,7 @@
                 <a:ea typeface="Aptos" pitchFamily="34" charset="-122"/>
                 <a:cs typeface="Aptos" pitchFamily="34" charset="-120"/>
               </a:rPr>
-              <a:t>DEMONSTRATED / VERIFIED REAL HANDOFF</a:t>
+              <a:t>DEMONSTRATED / ACCEPTED P18 HANDOFF</a:t>
             </a:r>
             <a:endParaRPr lang="en-US" sz="750" dirty="0"/>
           </a:p>
@@ -17648,7 +17716,7 @@
                 <a:ea typeface="Aptos" pitchFamily="34" charset="-122"/>
                 <a:cs typeface="Aptos" pitchFamily="34" charset="-120"/>
               </a:rPr>
-              <a:t>Accepted mapped-defect lineage</a:t>
+              <a:t>Accepted P18 mapped-defect lineage</a:t>
             </a:r>
             <a:endParaRPr lang="en-US" sz="2000" dirty="0"/>
           </a:p>
@@ -17662,8 +17730,8 @@
         </p:nvSpPr>
         <p:spPr>
           <a:xfrm>
-            <a:off x="4251960" y="2331720"/>
-            <a:ext cx="6629400" cy="1463040"/>
+            <a:off x="4251960" y="2267712"/>
+            <a:ext cx="6629400" cy="1600200"/>
           </a:xfrm>
           <a:prstGeom prst="rect">
             <a:avLst/>
@@ -17681,7 +17749,7 @@
               <a:buNone/>
             </a:pPr>
             <a:r>
-              <a:rPr lang="en-US" sz="1550" dirty="0">
+              <a:rPr lang="en-US" sz="1500" dirty="0">
                 <a:solidFill>
                   <a:srgbClr val="17212B"/>
                 </a:solidFill>
@@ -17689,16 +17757,16 @@
                 <a:ea typeface="Aptos" pitchFamily="34" charset="-122"/>
                 <a:cs typeface="Aptos" pitchFamily="34" charset="-120"/>
               </a:rPr>
-              <a:t>P15D-10627c5f-3f84-5c64-ab2d-3e574b6e97ee</a:t>
-            </a:r>
-            <a:endParaRPr lang="en-US" sz="1550" dirty="0"/>
+              <a:t>Machine class: Honeycombing</a:t>
+            </a:r>
+            <a:endParaRPr lang="en-US" sz="1500" dirty="0"/>
           </a:p>
           <a:p>
             <a:pPr algn="l" indent="0" marL="0">
               <a:buNone/>
             </a:pPr>
             <a:r>
-              <a:rPr lang="en-US" sz="1550" dirty="0">
+              <a:rPr lang="en-US" sz="1500" dirty="0">
                 <a:solidFill>
                   <a:srgbClr val="17212B"/>
                 </a:solidFill>
@@ -17706,16 +17774,16 @@
                 <a:ea typeface="Aptos" pitchFamily="34" charset="-122"/>
                 <a:cs typeface="Aptos" pitchFamily="34" charset="-120"/>
               </a:rPr>
-              <a:t>map XYZ: (3.9000027127470087, -0.09877989958311785, 0.0032930137079122536)</a:t>
-            </a:r>
-            <a:endParaRPr lang="en-US" sz="1550" dirty="0"/>
+              <a:t>Camera XYZ: approximately (0.0056, -0.0028, 3.1251) m</a:t>
+            </a:r>
+            <a:endParaRPr lang="en-US" sz="1500" dirty="0"/>
           </a:p>
           <a:p>
             <a:pPr algn="l" indent="0" marL="0">
               <a:buNone/>
             </a:pPr>
             <a:r>
-              <a:rPr lang="en-US" sz="1550" dirty="0">
+              <a:rPr lang="en-US" sz="1500" dirty="0">
                 <a:solidFill>
                   <a:srgbClr val="17212B"/>
                 </a:solidFill>
@@ -17723,9 +17791,26 @@
                 <a:ea typeface="Aptos" pitchFamily="34" charset="-122"/>
                 <a:cs typeface="Aptos" pitchFamily="34" charset="-120"/>
               </a:rPr>
-              <a:t>Timestamp: 1970-01-01T00:00:21.813000Z</a:t>
-            </a:r>
-            <a:endParaRPr lang="en-US" sz="1550" dirty="0"/>
+              <a:t>Session-local map XYZ: approximately (3.8882, 0.0712, -0.0035) m</a:t>
+            </a:r>
+            <a:endParaRPr lang="en-US" sz="1500" dirty="0"/>
+          </a:p>
+          <a:p>
+            <a:pPr algn="l" indent="0" marL="0">
+              <a:buNone/>
+            </a:pPr>
+            <a:r>
+              <a:rPr lang="en-US" sz="1500" dirty="0">
+                <a:solidFill>
+                  <a:srgbClr val="17212B"/>
+                </a:solidFill>
+                <a:latin typeface="Aptos" pitchFamily="34" charset="0"/>
+                <a:ea typeface="Aptos" pitchFamily="34" charset="-122"/>
+                <a:cs typeface="Aptos" pitchFamily="34" charset="-120"/>
+              </a:rPr>
+              <a:t>Model: DET-FINAL-v1</a:t>
+            </a:r>
+            <a:endParaRPr lang="en-US" sz="1500" dirty="0"/>
           </a:p>
         </p:txBody>
       </p:sp>
@@ -17737,7 +17822,7 @@
         </p:nvSpPr>
         <p:spPr>
           <a:xfrm>
-            <a:off x="4251960" y="4297680"/>
+            <a:off x="4251960" y="4370832"/>
             <a:ext cx="6629400" cy="685800"/>
           </a:xfrm>
           <a:prstGeom prst="rect">
@@ -17756,7 +17841,7 @@
               <a:buNone/>
             </a:pPr>
             <a:r>
-              <a:rPr lang="en-US" sz="1500" b="1" dirty="0">
+              <a:rPr lang="en-US" sz="1450" b="1" dirty="0">
                 <a:solidFill>
                   <a:srgbClr val="B42318"/>
                 </a:solidFill>
@@ -17764,9 +17849,9 @@
                 <a:ea typeface="Aptos" pitchFamily="34" charset="-122"/>
                 <a:cs typeface="Aptos" pitchFamily="34" charset="-120"/>
               </a:rPr>
-              <a:t>P19 3D evaluation remains pending a controlled experiment with accepted explicit GT-to-mapped-defect correspondence.</a:t>
-            </a:r>
-            <a:endParaRPr lang="en-US" sz="1500" dirty="0"/>
+              <a:t>Low-confidence, machine-generated and UNREVIEWED. Final quantitative absolute defect-position correspondence was not completed.</a:t>
+            </a:r>
+            <a:endParaRPr lang="en-US" sz="1450" dirty="0"/>
           </a:p>
         </p:txBody>
       </p:sp>
@@ -17826,7 +17911,7 @@
                 <a:ea typeface="Aptos" pitchFamily="34" charset="-122"/>
                 <a:cs typeface="Aptos" pitchFamily="34" charset="-120"/>
               </a:rPr>
-              <a:t>AEGISINSPECT  |  FINALIZATION READY  |  LAST-EVIDENCE INGESTION OPEN</a:t>
+              <a:t>AEGISINSPECT  |  FINALIZATION READY  |  LAST ARMOURY EVIDENCE OPEN</a:t>
             </a:r>
             <a:endParaRPr lang="en-US" sz="750" dirty="0"/>
           </a:p>
@@ -18461,7 +18546,7 @@
                 <a:ea typeface="Aptos" pitchFamily="34" charset="-122"/>
                 <a:cs typeface="Aptos" pitchFamily="34" charset="-120"/>
               </a:rPr>
-              <a:t>AEGISINSPECT  |  FINALIZATION READY  |  LAST-EVIDENCE INGESTION OPEN</a:t>
+              <a:t>AEGISINSPECT  |  FINALIZATION READY  |  LAST ARMOURY EVIDENCE OPEN</a:t>
             </a:r>
             <a:endParaRPr lang="en-US" sz="750" dirty="0"/>
           </a:p>

</xml_diff>

<commit_message>
docs(p20): ingest final ARMOURY low-light evidence
</commit_message>
<xml_diff>
--- a/outputs/presentation/AegisInspect_P20_working_draft.pptx
+++ b/outputs/presentation/AegisInspect_P20_working_draft.pptx
@@ -520,9 +520,9 @@
           <a:p>
             <a:r>
               <a:rPr lang="en-US" dirty="0"/>
-              <a:t>P20 FINALIZATION_READY_FOR_LAST_ARMOURY_EVIDENCE
+              <a:t>P20_READY_FOR_FINAL_FREEZE
 Assembly source: docs/presentation/assembly/slide_content.md
-Assembly SHA-256: 069ed214d6ba35a7db18680172c06e99621b8b5b90bc394c256ecbe25f7a92fe
+Assembly SHA-256: 2dcfb698bab92e2401d6982288d0d9397d474ff987f51f0fcc515bdb079acc51
 Speaker note: Open with the product purpose, then state that every claim is evidence-bound and that full autonomy is not claimed.</a:t>
             </a:r>
             <a:endParaRPr lang="en-US" dirty="0"/>
@@ -611,9 +611,9 @@
           <a:p>
             <a:r>
               <a:rPr lang="en-US" dirty="0"/>
-              <a:t>P20 FINALIZATION_READY_FOR_LAST_ARMOURY_EVIDENCE
+              <a:t>P20_READY_FOR_FINAL_FREEZE
 Assembly source: docs/presentation/assembly/slide_content.md
-Assembly SHA-256: 069ed214d6ba35a7db18680172c06e99621b8b5b90bc394c256ecbe25f7a92fe
+Assembly SHA-256: 2dcfb698bab92e2401d6982288d0d9397d474ff987f51f0fcc515bdb079acc51
 Speaker note: Use this short excerpt from the accepted P18 inspection report. It preserves session-local coordinates, confidence, provenance and UNREVIEWED state without inventing severity, repairs or safety conclusions.</a:t>
             </a:r>
             <a:endParaRPr lang="en-US" dirty="0"/>
@@ -702,9 +702,9 @@
           <a:p>
             <a:r>
               <a:rPr lang="en-US" dirty="0"/>
-              <a:t>P20 FINALIZATION_READY_FOR_LAST_ARMOURY_EVIDENCE
+              <a:t>P20_READY_FOR_FINAL_FREEZE
 Assembly source: docs/presentation/assembly/slide_content.md
-Assembly SHA-256: 069ed214d6ba35a7db18680172c06e99621b8b5b90bc394c256ecbe25f7a92fe
+Assembly SHA-256: 2dcfb698bab92e2401d6982288d0d9397d474ff987f51f0fcc515bdb079acc51
 Speaker note: The first retry validated the same-observation chain but missed the browser capture; the accepted completion package supplies that screenshot. This is integration evidence, not full autonomy.</a:t>
             </a:r>
             <a:endParaRPr lang="en-US" dirty="0"/>
@@ -793,9 +793,9 @@
           <a:p>
             <a:r>
               <a:rPr lang="en-US" dirty="0"/>
-              <a:t>P20 FINALIZATION_READY_FOR_LAST_ARMOURY_EVIDENCE
+              <a:t>P20_READY_FOR_FINAL_FREEZE
 Assembly source: docs/presentation/assembly/slide_content.md
-Assembly SHA-256: 069ed214d6ba35a7db18680172c06e99621b8b5b90bc394c256ecbe25f7a92fe
+Assembly SHA-256: 2dcfb698bab92e2401d6982288d0d9397d474ff987f51f0fcc515bdb079acc51
 Speaker note: Use the primary accepted P18 overview. Explain that one low-confidence machine observation moved through depth projection, session-local mapping, persistence, dashboard and deterministic reporting. Human review remained UNREVIEWED.</a:t>
             </a:r>
             <a:endParaRPr lang="en-US" dirty="0"/>
@@ -884,9 +884,9 @@
           <a:p>
             <a:r>
               <a:rPr lang="en-US" dirty="0"/>
-              <a:t>P20 FINALIZATION_READY_FOR_LAST_ARMOURY_EVIDENCE
+              <a:t>P20_READY_FOR_FINAL_FREEZE
 Assembly source: docs/presentation/assembly/slide_content.md
-Assembly SHA-256: 069ed214d6ba35a7db18680172c06e99621b8b5b90bc394c256ecbe25f7a92fe
+Assembly SHA-256: 2dcfb698bab92e2401d6982288d0d9397d474ff987f51f0fcc515bdb079acc51
 Speaker note: Report the presentation-rounded values and sample counts. Mandatory qualification: these metrics evaluate localization trajectory accuracy, not absolute defect-position accuracy.</a:t>
             </a:r>
             <a:endParaRPr lang="en-US" dirty="0"/>
@@ -975,9 +975,9 @@
           <a:p>
             <a:r>
               <a:rPr lang="en-US" dirty="0"/>
-              <a:t>P20 FINALIZATION_READY_FOR_LAST_ARMOURY_EVIDENCE
+              <a:t>P20_READY_FOR_FINAL_FREEZE
 Assembly source: docs/presentation/assembly/slide_content.md
-Assembly SHA-256: 069ed214d6ba35a7db18680172c06e99621b8b5b90bc394c256ecbe25f7a92fe
+Assembly SHA-256: 2dcfb698bab92e2401d6982288d0d9397d474ff987f51f0fcc515bdb079acc51
 Speaker note: P19 development is closed for the capstone. For technical Q&amp;A only: qualifying receipt index 710; RGB and depth binding PASS; startup alignment PASS; truth PASS; 307,200 of 307,200 target pixels; operational GT publication NO. This is advanced R&amp;D validation infrastructure, not a production runtime requirement.</a:t>
             </a:r>
             <a:endParaRPr lang="en-US" dirty="0"/>
@@ -1066,10 +1066,10 @@
           <a:p>
             <a:r>
               <a:rPr lang="en-US" dirty="0"/>
-              <a:t>P20 FINALIZATION_READY_FOR_LAST_ARMOURY_EVIDENCE
+              <a:t>P20_READY_FOR_FINAL_FREEZE
 Assembly source: docs/presentation/assembly/slide_content.md
-Assembly SHA-256: 069ed214d6ba35a7db18680172c06e99621b8b5b90bc394c256ecbe25f7a92fe
-Speaker note: Explain the monotonic RAW degradation, that CLAHE is worse at L0-L3 and offers no general recovery, and that both are effectively collapsed at L4. The LL-DETECTOR slot remains optional.</a:t>
+Assembly SHA-256: 2dcfb698bab92e2401d6982288d0d9397d474ff987f51f0fcc515bdb079acc51
+Speaker note: Preliminary learned low-light adaptation substantially improved robustness under severe controlled low-light conditions, while producing a small tradeoff under normal and mild illumination. It is slightly below RAW at L0-L1, slightly above RAW at L2, substantially above RAW at L3-L4, and above CLAHE throughout. This is a PRESENTATION / DEMONSTRATION MODEL evaluated on validation development data; it is not the canonical scientific LL-DETECTOR, production-qualified, or locked-test evidence. For Q&amp;A: inference executed exactly once; results-only finalization repaired a CSV schema omission. Inference was not rerun; predictions were not changed; training was not rerun.</a:t>
             </a:r>
             <a:endParaRPr lang="en-US" dirty="0"/>
           </a:p>
@@ -1157,10 +1157,10 @@
           <a:p>
             <a:r>
               <a:rPr lang="en-US" dirty="0"/>
-              <a:t>P20 FINALIZATION_READY_FOR_LAST_ARMOURY_EVIDENCE
+              <a:t>P20_READY_FOR_FINAL_FREEZE
 Assembly source: docs/presentation/assembly/slide_content.md
-Assembly SHA-256: 069ed214d6ba35a7db18680172c06e99621b8b5b90bc394c256ecbe25f7a92fe
-Speaker note: Use this only for Q&amp;A: identify the compact evidence index and explain that accepted artifacts are preserved rather than rewritten.</a:t>
+Assembly SHA-256: 2dcfb698bab92e2401d6982288d0d9397d474ff987f51f0fcc515bdb079acc51
+Speaker note: Use this only for Q&amp;A: identify the compact evidence index and explain that accepted artifacts are preserved rather than rewritten. The ARMOURY presentation model and its 21-file evaluation package are hash-bound in the index.</a:t>
             </a:r>
             <a:endParaRPr lang="en-US" dirty="0"/>
           </a:p>
@@ -1248,10 +1248,10 @@
           <a:p>
             <a:r>
               <a:rPr lang="en-US" dirty="0"/>
-              <a:t>P20 FINALIZATION_READY_FOR_LAST_ARMOURY_EVIDENCE
+              <a:t>P20_READY_FOR_FINAL_FREEZE
 Assembly source: docs/presentation/assembly/slide_content.md
-Assembly SHA-256: 069ed214d6ba35a7db18680172c06e99621b8b5b90bc394c256ecbe25f7a92fe
-Speaker note: Be direct: detector performance is modest, external transfer is weak, simulation is not field accuracy, P19 3D is frozen pending, and only the ARMOURY result remains open.</a:t>
+Assembly SHA-256: 2dcfb698bab92e2401d6982288d0d9397d474ff987f51f0fcc515bdb079acc51
+Speaker note: Be direct: detector performance is modest, external transfer is weak, simulation is not field accuracy, P19 3D is frozen pending, and the LL-DETECTOR result is limited to a presentation/demo model on controlled validation data.</a:t>
             </a:r>
             <a:endParaRPr lang="en-US" dirty="0"/>
           </a:p>
@@ -1339,9 +1339,9 @@
           <a:p>
             <a:r>
               <a:rPr lang="en-US" dirty="0"/>
-              <a:t>P20 FINALIZATION_READY_FOR_LAST_ARMOURY_EVIDENCE
+              <a:t>P20_READY_FOR_FINAL_FREEZE
 Assembly source: docs/presentation/assembly/slide_content.md
-Assembly SHA-256: 069ed214d6ba35a7db18680172c06e99621b8b5b90bc394c256ecbe25f7a92fe
+Assembly SHA-256: 2dcfb698bab92e2401d6982288d0d9397d474ff987f51f0fcc515bdb079acc51
 Speaker note: Translate the engineering into user value: repeatable evidence capture, traceable review, and modular deployment. These are application benefits, not market validation or production-readiness claims.</a:t>
             </a:r>
             <a:endParaRPr lang="en-US" dirty="0"/>
@@ -1430,10 +1430,10 @@
           <a:p>
             <a:r>
               <a:rPr lang="en-US" dirty="0"/>
-              <a:t>P20 FINALIZATION_READY_FOR_LAST_ARMOURY_EVIDENCE
+              <a:t>P20_READY_FOR_FINAL_FREEZE
 Assembly source: docs/presentation/assembly/slide_content.md
-Assembly SHA-256: 069ed214d6ba35a7db18680172c06e99621b8b5b90bc394c256ecbe25f7a92fe
-Speaker note: Close on what works today, state that the MSI disposition is resolved, and name ARMOURY LL-DETECTOR as the only remaining late-evidence input.</a:t>
+Assembly SHA-256: 2dcfb698bab92e2401d6982288d0d9397d474ff987f51f0fcc515bdb079acc51
+Speaker note: Close on what works today: P18 core integration is accepted, P19 remains frozen pending, and the ARMOURY presentation-model low-light evaluation is complete. All scientific evidence dependencies are closed for final-freeze review.</a:t>
             </a:r>
             <a:endParaRPr lang="en-US" dirty="0"/>
           </a:p>
@@ -1521,9 +1521,9 @@
           <a:p>
             <a:r>
               <a:rPr lang="en-US" dirty="0"/>
-              <a:t>P20 FINALIZATION_READY_FOR_LAST_ARMOURY_EVIDENCE
+              <a:t>P20_READY_FOR_FINAL_FREEZE
 Assembly source: docs/presentation/assembly/slide_content.md
-Assembly SHA-256: 069ed214d6ba35a7db18680172c06e99621b8b5b90bc394c256ecbe25f7a92fe
+Assembly SHA-256: 2dcfb698bab92e2401d6982288d0d9397d474ff987f51f0fcc515bdb079acc51
 Speaker note: Frame the problem as repeatable evidence capture and traceable review. The objective is an integrated, measurable workflow—not a claim of a validated autonomous mission.</a:t>
             </a:r>
             <a:endParaRPr lang="en-US" dirty="0"/>
@@ -1612,10 +1612,10 @@
           <a:p>
             <a:r>
               <a:rPr lang="en-US" dirty="0"/>
-              <a:t>P20 FINALIZATION_READY_FOR_LAST_ARMOURY_EVIDENCE
+              <a:t>P20_READY_FOR_FINAL_FREEZE
 Assembly source: docs/presentation/assembly/slide_content.md
-Assembly SHA-256: 069ed214d6ba35a7db18680172c06e99621b8b5b90bc394c256ecbe25f7a92fe
-Speaker note: Walk left to right from sensing to report. Call out accepted P18 core integration, measured localization, the frozen-pending P19 3D disposition, and the still-open LL-DETECTOR slot.</a:t>
+Assembly SHA-256: 2dcfb698bab92e2401d6982288d0d9397d474ff987f51f0fcc515bdb079acc51
+Speaker note: Walk left to right from sensing to report. Call out accepted P18 core integration, measured localization, the frozen-pending P19 3D disposition, and the completed presentation-model low-light evaluation.</a:t>
             </a:r>
             <a:endParaRPr lang="en-US" dirty="0"/>
           </a:p>
@@ -1703,9 +1703,9 @@
           <a:p>
             <a:r>
               <a:rPr lang="en-US" dirty="0"/>
-              <a:t>P20 FINALIZATION_READY_FOR_LAST_ARMOURY_EVIDENCE
+              <a:t>P20_READY_FOR_FINAL_FREEZE
 Assembly source: docs/presentation/assembly/slide_content.md
-Assembly SHA-256: 069ed214d6ba35a7db18680172c06e99621b8b5b90bc394c256ecbe25f7a92fe
+Assembly SHA-256: 2dcfb698bab92e2401d6982288d0d9397d474ff987f51f0fcc515bdb079acc51
 Speaker note: State the frozen dataset counts and six classes. These counts establish the data foundation; they are not performance metrics.</a:t>
             </a:r>
             <a:endParaRPr lang="en-US" dirty="0"/>
@@ -1794,9 +1794,9 @@
           <a:p>
             <a:r>
               <a:rPr lang="en-US" dirty="0"/>
-              <a:t>P20 FINALIZATION_READY_FOR_LAST_ARMOURY_EVIDENCE
+              <a:t>P20_READY_FOR_FINAL_FREEZE
 Assembly source: docs/presentation/assembly/slide_content.md
-Assembly SHA-256: 069ed214d6ba35a7db18680172c06e99621b8b5b90bc394c256ecbe25f7a92fe
+Assembly SHA-256: 2dcfb698bab92e2401d6982288d0d9397d474ff987f51f0fcc515bdb079acc51
 Speaker note: Present mAP as detection performance on the one-time held-out split. The diagnostic confidence came from validation; no threshold was tuned on test.</a:t>
             </a:r>
             <a:endParaRPr lang="en-US" dirty="0"/>
@@ -1885,9 +1885,9 @@
           <a:p>
             <a:r>
               <a:rPr lang="en-US" dirty="0"/>
-              <a:t>P20 FINALIZATION_READY_FOR_LAST_ARMOURY_EVIDENCE
+              <a:t>P20_READY_FOR_FINAL_FREEZE
 Assembly source: docs/presentation/assembly/slide_content.md
-Assembly SHA-256: 069ed214d6ba35a7db18680172c06e99621b8b5b90bc394c256ecbe25f7a92fe
+Assembly SHA-256: 2dcfb698bab92e2401d6982288d0d9397d474ff987f51f0fcc515bdb079acc51
 Speaker note: Separate runtime acceptance from accuracy: LiDAR ICP ran successfully, while trajectory accuracy is reported later as MEASURED without a PASS threshold.</a:t>
             </a:r>
             <a:endParaRPr lang="en-US" dirty="0"/>
@@ -1976,9 +1976,9 @@
           <a:p>
             <a:r>
               <a:rPr lang="en-US" dirty="0"/>
-              <a:t>P20 FINALIZATION_READY_FOR_LAST_ARMOURY_EVIDENCE
+              <a:t>P20_READY_FOR_FINAL_FREEZE
 Assembly source: docs/presentation/assembly/slide_content.md
-Assembly SHA-256: 069ed214d6ba35a7db18680172c06e99621b8b5b90bc394c256ecbe25f7a92fe
+Assembly SHA-256: 2dcfb698bab92e2401d6982288d0d9397d474ff987f51f0fcc515bdb079acc51
 Speaker note: Explain the metric-depth contract and ProjectCamera output frame. This is simulation/runtime evidence, not real-world depth or global-position accuracy.</a:t>
             </a:r>
             <a:endParaRPr lang="en-US" dirty="0"/>
@@ -2067,9 +2067,9 @@
           <a:p>
             <a:r>
               <a:rPr lang="en-US" dirty="0"/>
-              <a:t>P20 FINALIZATION_READY_FOR_LAST_ARMOURY_EVIDENCE
+              <a:t>P20_READY_FOR_FINAL_FREEZE
 Assembly source: docs/presentation/assembly/slide_content.md
-Assembly SHA-256: 069ed214d6ba35a7db18680172c06e99621b8b5b90bc394c256ecbe25f7a92fe
+Assembly SHA-256: 2dcfb698bab92e2401d6982288d0d9397d474ff987f51f0fcc515bdb079acc51
 Speaker note: Trace the accepted P18 observation from depth-based camera XYZ into session-local map XYZ and the persisted record. These are not globally surveyed coordinates.</a:t>
             </a:r>
             <a:endParaRPr lang="en-US" dirty="0"/>
@@ -2158,9 +2158,9 @@
           <a:p>
             <a:r>
               <a:rPr lang="en-US" dirty="0"/>
-              <a:t>P20 FINALIZATION_READY_FOR_LAST_ARMOURY_EVIDENCE
+              <a:t>P20_READY_FOR_FINAL_FREEZE
 Assembly source: docs/presentation/assembly/slide_content.md
-Assembly SHA-256: 069ed214d6ba35a7db18680172c06e99621b8b5b90bc394c256ecbe25f7a92fe
+Assembly SHA-256: 2dcfb698bab92e2401d6982288d0d9397d474ff987f51f0fcc515bdb079acc51
 Speaker note: Show that the record persists and is reviewable. Stress that it is extremely-low-confidence and UNREVIEWED, not a confirmed physical defect.</a:t>
             </a:r>
             <a:endParaRPr lang="en-US" dirty="0"/>
@@ -2841,7 +2841,7 @@
                 <a:ea typeface="Aptos" pitchFamily="34" charset="-122"/>
                 <a:cs typeface="Aptos" pitchFamily="34" charset="-120"/>
               </a:rPr>
-              <a:t>AEGISINSPECT  |  FINALIZATION READY  |  LAST ARMOURY EVIDENCE OPEN</a:t>
+              <a:t>AEGISINSPECT  |  READY FOR FINAL FREEZE  |  EVIDENCE SLOTS CLOSED</a:t>
             </a:r>
             <a:endParaRPr lang="en-US" sz="750" dirty="0"/>
           </a:p>
@@ -3570,7 +3570,7 @@
                 <a:ea typeface="Aptos" pitchFamily="34" charset="-122"/>
                 <a:cs typeface="Aptos" pitchFamily="34" charset="-120"/>
               </a:rPr>
-              <a:t>AEGISINSPECT  |  FINALIZATION READY  |  LAST ARMOURY EVIDENCE OPEN</a:t>
+              <a:t>AEGISINSPECT  |  READY FOR FINAL FREEZE  |  EVIDENCE SLOTS CLOSED</a:t>
             </a:r>
             <a:endParaRPr lang="en-US" sz="750" dirty="0"/>
           </a:p>
@@ -3820,7 +3820,7 @@
       </p:sp>
       <p:pic>
         <p:nvPicPr>
-          <p:cNvPr id="7" name="Image 0" descr="C:\Users\Aritra\Documents\aegisinspect-p20-deck-draft\outputs\presentation\p18_evidence\dashboard\dashboard_completion_overview_final.png">    </p:cNvPr>
+          <p:cNvPr id="7" name="Image 0" descr="C:\users\aritra\documents\aegisinspect-p20-deck-draft\outputs\presentation\p18_evidence\dashboard\dashboard_completion_overview_final.png">    </p:cNvPr>
           <p:cNvPicPr>
             <a:picLocks noChangeAspect="1"/>
           </p:cNvPicPr>
@@ -4154,7 +4154,7 @@
                 <a:ea typeface="Aptos" pitchFamily="34" charset="-122"/>
                 <a:cs typeface="Aptos" pitchFamily="34" charset="-120"/>
               </a:rPr>
-              <a:t>AEGISINSPECT  |  FINALIZATION READY  |  LAST ARMOURY EVIDENCE OPEN</a:t>
+              <a:t>AEGISINSPECT  |  READY FOR FINAL FREEZE  |  EVIDENCE SLOTS CLOSED</a:t>
             </a:r>
             <a:endParaRPr lang="en-US" sz="750" dirty="0"/>
           </a:p>
@@ -4404,7 +4404,7 @@
       </p:sp>
       <p:pic>
         <p:nvPicPr>
-          <p:cNvPr id="7" name="Image 0" descr="C:\Users\Aritra\Documents\aegisinspect-p20-deck-draft\outputs\presentation\p18_evidence\dashboard\clean_repeatability_overview.png">    </p:cNvPr>
+          <p:cNvPr id="7" name="Image 0" descr="C:\users\aritra\documents\aegisinspect-p20-deck-draft\outputs\presentation\p18_evidence\dashboard\clean_repeatability_overview.png">    </p:cNvPr>
           <p:cNvPicPr>
             <a:picLocks noChangeAspect="1"/>
           </p:cNvPicPr>
@@ -4806,7 +4806,7 @@
                 <a:ea typeface="Aptos" pitchFamily="34" charset="-122"/>
                 <a:cs typeface="Aptos" pitchFamily="34" charset="-120"/>
               </a:rPr>
-              <a:t>AEGISINSPECT  |  FINALIZATION READY  |  LAST ARMOURY EVIDENCE OPEN</a:t>
+              <a:t>AEGISINSPECT  |  READY FOR FINAL FREEZE  |  EVIDENCE SLOTS CLOSED</a:t>
             </a:r>
             <a:endParaRPr lang="en-US" sz="750" dirty="0"/>
           </a:p>
@@ -5717,7 +5717,7 @@
                 <a:ea typeface="Aptos" pitchFamily="34" charset="-122"/>
                 <a:cs typeface="Aptos" pitchFamily="34" charset="-120"/>
               </a:rPr>
-              <a:t>AEGISINSPECT  |  FINALIZATION READY  |  LAST ARMOURY EVIDENCE OPEN</a:t>
+              <a:t>AEGISINSPECT  |  READY FOR FINAL FREEZE  |  EVIDENCE SLOTS CLOSED</a:t>
             </a:r>
             <a:endParaRPr lang="en-US" sz="750" dirty="0"/>
           </a:p>
@@ -6962,7 +6962,7 @@
                 <a:ea typeface="Aptos" pitchFamily="34" charset="-122"/>
                 <a:cs typeface="Aptos" pitchFamily="34" charset="-120"/>
               </a:rPr>
-              <a:t>AEGISINSPECT  |  FINALIZATION READY  |  LAST ARMOURY EVIDENCE OPEN</a:t>
+              <a:t>AEGISINSPECT  |  READY FOR FINAL FREEZE  |  EVIDENCE SLOTS CLOSED</a:t>
             </a:r>
             <a:endParaRPr lang="en-US" sz="750" dirty="0"/>
           </a:p>
@@ -7204,30 +7204,225 @@
                 <a:ea typeface="Aptos" pitchFamily="34" charset="-122"/>
                 <a:cs typeface="Aptos" pitchFamily="34" charset="-120"/>
               </a:rPr>
-              <a:t>SUPPORTED / FROZEN VALIDATION BENCHMARK</a:t>
+              <a:t>MEASURED / CONTROLLED VALIDATION</a:t>
             </a:r>
             <a:endParaRPr lang="en-US" sz="750" dirty="0"/>
           </a:p>
         </p:txBody>
       </p:sp>
-      <p:sp>
-        <p:nvSpPr>
-          <p:cNvPr id="7" name="Shape 5"/>
-          <p:cNvSpPr/>
-          <p:nvPr/>
-        </p:nvSpPr>
-        <p:spPr>
-          <a:xfrm>
-            <a:off x="868680" y="4846320"/>
-            <a:ext cx="6080760" cy="0"/>
-          </a:xfrm>
-          <a:prstGeom prst="line">
-            <a:avLst/>
-          </a:prstGeom>
-          <a:noFill/>
-          <a:ln w="7620">
+      <p:pic>
+        <p:nvPicPr>
+          <p:cNvPr id="7" name="Image 0" descr="C:\users\aritra\documents\aegisinspect-p20-deck-draft\outputs\presentation\low_light_evidence\raw_clahe_ll_detector_map50.png">    </p:cNvPr>
+          <p:cNvPicPr>
+            <a:picLocks noChangeAspect="1"/>
+          </p:cNvPicPr>
+          <p:nvPr/>
+        </p:nvPicPr>
+        <p:blipFill>
+          <a:blip r:embed="rId1"/>
+          <a:stretch>
+            <a:fillRect/>
+          </a:stretch>
+        </p:blipFill>
+        <p:spPr>
+          <a:xfrm>
+            <a:off x="594360" y="1627632"/>
+            <a:ext cx="6492240" cy="3968496"/>
+          </a:xfrm>
+          <a:prstGeom prst="rect">
+            <a:avLst/>
+          </a:prstGeom>
+        </p:spPr>
+      </p:pic>
+      <p:sp>
+        <p:nvSpPr>
+          <p:cNvPr id="8" name="Text 5"/>
+          <p:cNvSpPr/>
+          <p:nvPr/>
+        </p:nvSpPr>
+        <p:spPr>
+          <a:xfrm>
+            <a:off x="7269480" y="1627632"/>
+            <a:ext cx="4160520" cy="256032"/>
+          </a:xfrm>
+          <a:prstGeom prst="rect">
+            <a:avLst/>
+          </a:prstGeom>
+          <a:noFill/>
+          <a:ln/>
+        </p:spPr>
+        <p:txBody>
+          <a:bodyPr wrap="square" lIns="508" tIns="508" rIns="508" bIns="508" rtlCol="0" anchor="t">
+            <a:normAutofit/>
+          </a:bodyPr>
+          <a:lstStyle/>
+          <a:p>
+            <a:pPr algn="ctr" indent="0" marL="0">
+              <a:buNone/>
+            </a:pPr>
+            <a:r>
+              <a:rPr lang="en-US" sz="1600" b="1" dirty="0">
+                <a:solidFill>
+                  <a:srgbClr val="0B1F33"/>
+                </a:solidFill>
+                <a:latin typeface="Aptos" pitchFamily="34" charset="0"/>
+                <a:ea typeface="Aptos" pitchFamily="34" charset="-122"/>
+                <a:cs typeface="Aptos" pitchFamily="34" charset="-120"/>
+              </a:rPr>
+              <a:t>RAW / CLAHE / LL-DETECTOR mAP50</a:t>
+            </a:r>
+            <a:endParaRPr lang="en-US" sz="1600" dirty="0"/>
+          </a:p>
+        </p:txBody>
+      </p:sp>
+      <p:sp>
+        <p:nvSpPr>
+          <p:cNvPr id="9" name="Text 6"/>
+          <p:cNvSpPr/>
+          <p:nvPr/>
+        </p:nvSpPr>
+        <p:spPr>
+          <a:xfrm>
+            <a:off x="7269480" y="2011680"/>
+            <a:ext cx="4160520" cy="1600200"/>
+          </a:xfrm>
+          <a:prstGeom prst="rect">
+            <a:avLst/>
+          </a:prstGeom>
+          <a:noFill/>
+          <a:ln/>
+        </p:spPr>
+        <p:txBody>
+          <a:bodyPr wrap="square" lIns="508" tIns="508" rIns="508" bIns="508" rtlCol="0" anchor="t">
+            <a:normAutofit/>
+          </a:bodyPr>
+          <a:lstStyle/>
+          <a:p>
+            <a:pPr algn="l" indent="0" marL="0">
+              <a:buNone/>
+            </a:pPr>
+            <a:r>
+              <a:rPr lang="en-US" sz="1020" dirty="0">
+                <a:solidFill>
+                  <a:srgbClr val="17212B"/>
+                </a:solidFill>
+                <a:latin typeface="Aptos" pitchFamily="34" charset="0"/>
+                <a:ea typeface="Aptos" pitchFamily="34" charset="-122"/>
+                <a:cs typeface="Aptos" pitchFamily="34" charset="-120"/>
+              </a:rPr>
+              <a:t>Level      RAW       CLAHE      LL-DETECTOR</a:t>
+            </a:r>
+            <a:endParaRPr lang="en-US" sz="1020" dirty="0"/>
+          </a:p>
+          <a:p>
+            <a:pPr algn="l" indent="0" marL="0">
+              <a:buNone/>
+            </a:pPr>
+            <a:r>
+              <a:rPr lang="en-US" sz="1020" dirty="0">
+                <a:solidFill>
+                  <a:srgbClr val="17212B"/>
+                </a:solidFill>
+                <a:latin typeface="Aptos" pitchFamily="34" charset="0"/>
+                <a:ea typeface="Aptos" pitchFamily="34" charset="-122"/>
+                <a:cs typeface="Aptos" pitchFamily="34" charset="-120"/>
+              </a:rPr>
+              <a:t>L0   0.388692   0.265739   0.365913</a:t>
+            </a:r>
+            <a:endParaRPr lang="en-US" sz="1020" dirty="0"/>
+          </a:p>
+          <a:p>
+            <a:pPr algn="l" indent="0" marL="0">
+              <a:buNone/>
+            </a:pPr>
+            <a:r>
+              <a:rPr lang="en-US" sz="1020" dirty="0">
+                <a:solidFill>
+                  <a:srgbClr val="17212B"/>
+                </a:solidFill>
+                <a:latin typeface="Aptos" pitchFamily="34" charset="0"/>
+                <a:ea typeface="Aptos" pitchFamily="34" charset="-122"/>
+                <a:cs typeface="Aptos" pitchFamily="34" charset="-120"/>
+              </a:rPr>
+              <a:t>L1   0.379628   0.265642   0.359985</a:t>
+            </a:r>
+            <a:endParaRPr lang="en-US" sz="1020" dirty="0"/>
+          </a:p>
+          <a:p>
+            <a:pPr algn="l" indent="0" marL="0">
+              <a:buNone/>
+            </a:pPr>
+            <a:r>
+              <a:rPr lang="en-US" sz="1020" dirty="0">
+                <a:solidFill>
+                  <a:srgbClr val="17212B"/>
+                </a:solidFill>
+                <a:latin typeface="Aptos" pitchFamily="34" charset="0"/>
+                <a:ea typeface="Aptos" pitchFamily="34" charset="-122"/>
+                <a:cs typeface="Aptos" pitchFamily="34" charset="-120"/>
+              </a:rPr>
+              <a:t>L2   0.334249   0.224084   0.343849</a:t>
+            </a:r>
+            <a:endParaRPr lang="en-US" sz="1020" dirty="0"/>
+          </a:p>
+          <a:p>
+            <a:pPr algn="l" indent="0" marL="0">
+              <a:buNone/>
+            </a:pPr>
+            <a:r>
+              <a:rPr lang="en-US" sz="1020" dirty="0">
+                <a:solidFill>
+                  <a:srgbClr val="17212B"/>
+                </a:solidFill>
+                <a:latin typeface="Aptos" pitchFamily="34" charset="0"/>
+                <a:ea typeface="Aptos" pitchFamily="34" charset="-122"/>
+                <a:cs typeface="Aptos" pitchFamily="34" charset="-120"/>
+              </a:rPr>
+              <a:t>L3   0.126310   0.074616   0.290425</a:t>
+            </a:r>
+            <a:endParaRPr lang="en-US" sz="1020" dirty="0"/>
+          </a:p>
+          <a:p>
+            <a:pPr algn="l" indent="0" marL="0">
+              <a:buNone/>
+            </a:pPr>
+            <a:r>
+              <a:rPr lang="en-US" sz="1020" dirty="0">
+                <a:solidFill>
+                  <a:srgbClr val="17212B"/>
+                </a:solidFill>
+                <a:latin typeface="Aptos" pitchFamily="34" charset="0"/>
+                <a:ea typeface="Aptos" pitchFamily="34" charset="-122"/>
+                <a:cs typeface="Aptos" pitchFamily="34" charset="-120"/>
+              </a:rPr>
+              <a:t>L4   0.003130   0.003388   0.124129</a:t>
+            </a:r>
+            <a:endParaRPr lang="en-US" sz="1020" dirty="0"/>
+          </a:p>
+        </p:txBody>
+      </p:sp>
+      <p:sp>
+        <p:nvSpPr>
+          <p:cNvPr id="10" name="Shape 7"/>
+          <p:cNvSpPr/>
+          <p:nvPr/>
+        </p:nvSpPr>
+        <p:spPr>
+          <a:xfrm>
+            <a:off x="7269480" y="3794760"/>
+            <a:ext cx="4160520" cy="1783080"/>
+          </a:xfrm>
+          <a:prstGeom prst="roundRect">
+            <a:avLst>
+              <a:gd name="adj" fmla="val 2051"/>
+            </a:avLst>
+          </a:prstGeom>
+          <a:solidFill>
+            <a:srgbClr val="F0FAF7"/>
+          </a:solidFill>
+          <a:ln w="10160">
             <a:solidFill>
-              <a:srgbClr val="DCE6ED"/>
+              <a:srgbClr val="00796B"/>
             </a:solidFill>
             <a:prstDash val="solid"/>
           </a:ln>
@@ -7235,930 +7430,14 @@
       </p:sp>
       <p:sp>
         <p:nvSpPr>
-          <p:cNvPr id="8" name="Text 6"/>
-          <p:cNvSpPr/>
-          <p:nvPr/>
-        </p:nvSpPr>
-        <p:spPr>
-          <a:xfrm>
-            <a:off x="411480" y="4773168"/>
-            <a:ext cx="365760" cy="146304"/>
-          </a:xfrm>
-          <a:prstGeom prst="rect">
-            <a:avLst/>
-          </a:prstGeom>
-          <a:noFill/>
-          <a:ln/>
-        </p:spPr>
-        <p:txBody>
-          <a:bodyPr wrap="square" lIns="0" tIns="0" rIns="0" bIns="0" rtlCol="0" anchor="ctr"/>
-          <a:lstStyle/>
-          <a:p>
-            <a:pPr algn="r" indent="0" marL="0">
-              <a:buNone/>
-            </a:pPr>
-            <a:r>
-              <a:rPr lang="en-US" sz="800" dirty="0">
-                <a:solidFill>
-                  <a:srgbClr val="52616B"/>
-                </a:solidFill>
-                <a:latin typeface="Aptos" pitchFamily="34" charset="0"/>
-                <a:ea typeface="Aptos" pitchFamily="34" charset="-122"/>
-                <a:cs typeface="Aptos" pitchFamily="34" charset="-120"/>
-              </a:rPr>
-              <a:t>0.0</a:t>
-            </a:r>
-            <a:endParaRPr lang="en-US" sz="800" dirty="0"/>
-          </a:p>
-        </p:txBody>
-      </p:sp>
-      <p:sp>
-        <p:nvSpPr>
-          <p:cNvPr id="9" name="Shape 7"/>
-          <p:cNvSpPr/>
-          <p:nvPr/>
-        </p:nvSpPr>
-        <p:spPr>
-          <a:xfrm>
-            <a:off x="868680" y="4138749"/>
-            <a:ext cx="6080760" cy="0"/>
-          </a:xfrm>
-          <a:prstGeom prst="line">
-            <a:avLst/>
-          </a:prstGeom>
-          <a:noFill/>
-          <a:ln w="7620">
-            <a:solidFill>
-              <a:srgbClr val="DCE6ED"/>
-            </a:solidFill>
-            <a:prstDash val="solid"/>
-          </a:ln>
-        </p:spPr>
-      </p:sp>
-      <p:sp>
-        <p:nvSpPr>
-          <p:cNvPr id="10" name="Text 8"/>
-          <p:cNvSpPr/>
-          <p:nvPr/>
-        </p:nvSpPr>
-        <p:spPr>
-          <a:xfrm>
-            <a:off x="411480" y="4065597"/>
-            <a:ext cx="365760" cy="146304"/>
-          </a:xfrm>
-          <a:prstGeom prst="rect">
-            <a:avLst/>
-          </a:prstGeom>
-          <a:noFill/>
-          <a:ln/>
-        </p:spPr>
-        <p:txBody>
-          <a:bodyPr wrap="square" lIns="0" tIns="0" rIns="0" bIns="0" rtlCol="0" anchor="ctr"/>
-          <a:lstStyle/>
-          <a:p>
-            <a:pPr algn="r" indent="0" marL="0">
-              <a:buNone/>
-            </a:pPr>
-            <a:r>
-              <a:rPr lang="en-US" sz="800" dirty="0">
-                <a:solidFill>
-                  <a:srgbClr val="52616B"/>
-                </a:solidFill>
-                <a:latin typeface="Aptos" pitchFamily="34" charset="0"/>
-                <a:ea typeface="Aptos" pitchFamily="34" charset="-122"/>
-                <a:cs typeface="Aptos" pitchFamily="34" charset="-120"/>
-              </a:rPr>
-              <a:t>0.1</a:t>
-            </a:r>
-            <a:endParaRPr lang="en-US" sz="800" dirty="0"/>
-          </a:p>
-        </p:txBody>
-      </p:sp>
-      <p:sp>
-        <p:nvSpPr>
-          <p:cNvPr id="11" name="Shape 9"/>
-          <p:cNvSpPr/>
-          <p:nvPr/>
-        </p:nvSpPr>
-        <p:spPr>
-          <a:xfrm>
-            <a:off x="868680" y="3431177"/>
-            <a:ext cx="6080760" cy="0"/>
-          </a:xfrm>
-          <a:prstGeom prst="line">
-            <a:avLst/>
-          </a:prstGeom>
-          <a:noFill/>
-          <a:ln w="7620">
-            <a:solidFill>
-              <a:srgbClr val="DCE6ED"/>
-            </a:solidFill>
-            <a:prstDash val="solid"/>
-          </a:ln>
-        </p:spPr>
-      </p:sp>
-      <p:sp>
-        <p:nvSpPr>
-          <p:cNvPr id="12" name="Text 10"/>
-          <p:cNvSpPr/>
-          <p:nvPr/>
-        </p:nvSpPr>
-        <p:spPr>
-          <a:xfrm>
-            <a:off x="411480" y="3358025"/>
-            <a:ext cx="365760" cy="146304"/>
-          </a:xfrm>
-          <a:prstGeom prst="rect">
-            <a:avLst/>
-          </a:prstGeom>
-          <a:noFill/>
-          <a:ln/>
-        </p:spPr>
-        <p:txBody>
-          <a:bodyPr wrap="square" lIns="0" tIns="0" rIns="0" bIns="0" rtlCol="0" anchor="ctr"/>
-          <a:lstStyle/>
-          <a:p>
-            <a:pPr algn="r" indent="0" marL="0">
-              <a:buNone/>
-            </a:pPr>
-            <a:r>
-              <a:rPr lang="en-US" sz="800" dirty="0">
-                <a:solidFill>
-                  <a:srgbClr val="52616B"/>
-                </a:solidFill>
-                <a:latin typeface="Aptos" pitchFamily="34" charset="0"/>
-                <a:ea typeface="Aptos" pitchFamily="34" charset="-122"/>
-                <a:cs typeface="Aptos" pitchFamily="34" charset="-120"/>
-              </a:rPr>
-              <a:t>0.2</a:t>
-            </a:r>
-            <a:endParaRPr lang="en-US" sz="800" dirty="0"/>
-          </a:p>
-        </p:txBody>
-      </p:sp>
-      <p:sp>
-        <p:nvSpPr>
-          <p:cNvPr id="13" name="Shape 11"/>
-          <p:cNvSpPr/>
-          <p:nvPr/>
-        </p:nvSpPr>
-        <p:spPr>
-          <a:xfrm>
-            <a:off x="868680" y="2723606"/>
-            <a:ext cx="6080760" cy="0"/>
-          </a:xfrm>
-          <a:prstGeom prst="line">
-            <a:avLst/>
-          </a:prstGeom>
-          <a:noFill/>
-          <a:ln w="7620">
-            <a:solidFill>
-              <a:srgbClr val="DCE6ED"/>
-            </a:solidFill>
-            <a:prstDash val="solid"/>
-          </a:ln>
-        </p:spPr>
-      </p:sp>
-      <p:sp>
-        <p:nvSpPr>
-          <p:cNvPr id="14" name="Text 12"/>
-          <p:cNvSpPr/>
-          <p:nvPr/>
-        </p:nvSpPr>
-        <p:spPr>
-          <a:xfrm>
-            <a:off x="411480" y="2650454"/>
-            <a:ext cx="365760" cy="146304"/>
-          </a:xfrm>
-          <a:prstGeom prst="rect">
-            <a:avLst/>
-          </a:prstGeom>
-          <a:noFill/>
-          <a:ln/>
-        </p:spPr>
-        <p:txBody>
-          <a:bodyPr wrap="square" lIns="0" tIns="0" rIns="0" bIns="0" rtlCol="0" anchor="ctr"/>
-          <a:lstStyle/>
-          <a:p>
-            <a:pPr algn="r" indent="0" marL="0">
-              <a:buNone/>
-            </a:pPr>
-            <a:r>
-              <a:rPr lang="en-US" sz="800" dirty="0">
-                <a:solidFill>
-                  <a:srgbClr val="52616B"/>
-                </a:solidFill>
-                <a:latin typeface="Aptos" pitchFamily="34" charset="0"/>
-                <a:ea typeface="Aptos" pitchFamily="34" charset="-122"/>
-                <a:cs typeface="Aptos" pitchFamily="34" charset="-120"/>
-              </a:rPr>
-              <a:t>0.3</a:t>
-            </a:r>
-            <a:endParaRPr lang="en-US" sz="800" dirty="0"/>
-          </a:p>
-        </p:txBody>
-      </p:sp>
-      <p:sp>
-        <p:nvSpPr>
-          <p:cNvPr id="15" name="Shape 13"/>
-          <p:cNvSpPr/>
-          <p:nvPr/>
-        </p:nvSpPr>
-        <p:spPr>
-          <a:xfrm>
-            <a:off x="868680" y="2016034"/>
-            <a:ext cx="6080760" cy="0"/>
-          </a:xfrm>
-          <a:prstGeom prst="line">
-            <a:avLst/>
-          </a:prstGeom>
-          <a:noFill/>
-          <a:ln w="7620">
-            <a:solidFill>
-              <a:srgbClr val="DCE6ED"/>
-            </a:solidFill>
-            <a:prstDash val="solid"/>
-          </a:ln>
-        </p:spPr>
-      </p:sp>
-      <p:sp>
-        <p:nvSpPr>
-          <p:cNvPr id="16" name="Text 14"/>
-          <p:cNvSpPr/>
-          <p:nvPr/>
-        </p:nvSpPr>
-        <p:spPr>
-          <a:xfrm>
-            <a:off x="411480" y="1942882"/>
-            <a:ext cx="365760" cy="146304"/>
-          </a:xfrm>
-          <a:prstGeom prst="rect">
-            <a:avLst/>
-          </a:prstGeom>
-          <a:noFill/>
-          <a:ln/>
-        </p:spPr>
-        <p:txBody>
-          <a:bodyPr wrap="square" lIns="0" tIns="0" rIns="0" bIns="0" rtlCol="0" anchor="ctr"/>
-          <a:lstStyle/>
-          <a:p>
-            <a:pPr algn="r" indent="0" marL="0">
-              <a:buNone/>
-            </a:pPr>
-            <a:r>
-              <a:rPr lang="en-US" sz="800" dirty="0">
-                <a:solidFill>
-                  <a:srgbClr val="52616B"/>
-                </a:solidFill>
-                <a:latin typeface="Aptos" pitchFamily="34" charset="0"/>
-                <a:ea typeface="Aptos" pitchFamily="34" charset="-122"/>
-                <a:cs typeface="Aptos" pitchFamily="34" charset="-120"/>
-              </a:rPr>
-              <a:t>0.4</a:t>
-            </a:r>
-            <a:endParaRPr lang="en-US" sz="800" dirty="0"/>
-          </a:p>
-        </p:txBody>
-      </p:sp>
-      <p:sp>
-        <p:nvSpPr>
-          <p:cNvPr id="17" name="Shape 15"/>
-          <p:cNvSpPr/>
-          <p:nvPr/>
-        </p:nvSpPr>
-        <p:spPr>
-          <a:xfrm>
-            <a:off x="1307592" y="2032040"/>
-            <a:ext cx="128016" cy="128016"/>
-          </a:xfrm>
-          <a:prstGeom prst="ellipse">
-            <a:avLst/>
-          </a:prstGeom>
-          <a:solidFill>
-            <a:srgbClr val="1565C0"/>
-          </a:solidFill>
-          <a:ln w="12700">
-            <a:solidFill>
-              <a:srgbClr val="1565C0"/>
-            </a:solidFill>
-            <a:prstDash val="solid"/>
-          </a:ln>
-        </p:spPr>
-      </p:sp>
-      <p:sp>
-        <p:nvSpPr>
-          <p:cNvPr id="18" name="Shape 16"/>
-          <p:cNvSpPr/>
-          <p:nvPr/>
-        </p:nvSpPr>
-        <p:spPr>
-          <a:xfrm>
-            <a:off x="1371600" y="2096048"/>
-            <a:ext cx="1280160" cy="64132"/>
-          </a:xfrm>
-          <a:prstGeom prst="line">
-            <a:avLst/>
-          </a:prstGeom>
-          <a:noFill/>
-          <a:ln w="27940">
-            <a:solidFill>
-              <a:srgbClr val="1565C0"/>
-            </a:solidFill>
-            <a:prstDash val="solid"/>
-          </a:ln>
-        </p:spPr>
-      </p:sp>
-      <p:sp>
-        <p:nvSpPr>
-          <p:cNvPr id="19" name="Shape 17"/>
-          <p:cNvSpPr/>
-          <p:nvPr/>
-        </p:nvSpPr>
-        <p:spPr>
-          <a:xfrm>
-            <a:off x="2587752" y="2096172"/>
-            <a:ext cx="128016" cy="128016"/>
-          </a:xfrm>
-          <a:prstGeom prst="ellipse">
-            <a:avLst/>
-          </a:prstGeom>
-          <a:solidFill>
-            <a:srgbClr val="1565C0"/>
-          </a:solidFill>
-          <a:ln w="12700">
-            <a:solidFill>
-              <a:srgbClr val="1565C0"/>
-            </a:solidFill>
-            <a:prstDash val="solid"/>
-          </a:ln>
-        </p:spPr>
-      </p:sp>
-      <p:sp>
-        <p:nvSpPr>
-          <p:cNvPr id="20" name="Shape 18"/>
-          <p:cNvSpPr/>
-          <p:nvPr/>
-        </p:nvSpPr>
-        <p:spPr>
-          <a:xfrm>
-            <a:off x="2651760" y="2160180"/>
-            <a:ext cx="1280160" cy="321089"/>
-          </a:xfrm>
-          <a:prstGeom prst="line">
-            <a:avLst/>
-          </a:prstGeom>
-          <a:noFill/>
-          <a:ln w="27940">
-            <a:solidFill>
-              <a:srgbClr val="1565C0"/>
-            </a:solidFill>
-            <a:prstDash val="solid"/>
-          </a:ln>
-        </p:spPr>
-      </p:sp>
-      <p:sp>
-        <p:nvSpPr>
-          <p:cNvPr id="21" name="Shape 19"/>
-          <p:cNvSpPr/>
-          <p:nvPr/>
-        </p:nvSpPr>
-        <p:spPr>
-          <a:xfrm>
-            <a:off x="3867912" y="2417262"/>
-            <a:ext cx="128016" cy="128016"/>
-          </a:xfrm>
-          <a:prstGeom prst="ellipse">
-            <a:avLst/>
-          </a:prstGeom>
-          <a:solidFill>
-            <a:srgbClr val="1565C0"/>
-          </a:solidFill>
-          <a:ln w="12700">
-            <a:solidFill>
-              <a:srgbClr val="1565C0"/>
-            </a:solidFill>
-            <a:prstDash val="solid"/>
-          </a:ln>
-        </p:spPr>
-      </p:sp>
-      <p:sp>
-        <p:nvSpPr>
-          <p:cNvPr id="22" name="Shape 20"/>
-          <p:cNvSpPr/>
-          <p:nvPr/>
-        </p:nvSpPr>
-        <p:spPr>
-          <a:xfrm>
-            <a:off x="3931920" y="2481270"/>
-            <a:ext cx="1280160" cy="1471318"/>
-          </a:xfrm>
-          <a:prstGeom prst="line">
-            <a:avLst/>
-          </a:prstGeom>
-          <a:noFill/>
-          <a:ln w="27940">
-            <a:solidFill>
-              <a:srgbClr val="1565C0"/>
-            </a:solidFill>
-            <a:prstDash val="solid"/>
-          </a:ln>
-        </p:spPr>
-      </p:sp>
-      <p:sp>
-        <p:nvSpPr>
-          <p:cNvPr id="23" name="Shape 21"/>
-          <p:cNvSpPr/>
-          <p:nvPr/>
-        </p:nvSpPr>
-        <p:spPr>
-          <a:xfrm>
-            <a:off x="5148072" y="3888579"/>
-            <a:ext cx="128016" cy="128016"/>
-          </a:xfrm>
-          <a:prstGeom prst="ellipse">
-            <a:avLst/>
-          </a:prstGeom>
-          <a:solidFill>
-            <a:srgbClr val="1565C0"/>
-          </a:solidFill>
-          <a:ln w="12700">
-            <a:solidFill>
-              <a:srgbClr val="1565C0"/>
-            </a:solidFill>
-            <a:prstDash val="solid"/>
-          </a:ln>
-        </p:spPr>
-      </p:sp>
-      <p:sp>
-        <p:nvSpPr>
-          <p:cNvPr id="24" name="Shape 22"/>
-          <p:cNvSpPr/>
-          <p:nvPr/>
-        </p:nvSpPr>
-        <p:spPr>
-          <a:xfrm>
-            <a:off x="5212080" y="3952587"/>
-            <a:ext cx="1280160" cy="871584"/>
-          </a:xfrm>
-          <a:prstGeom prst="line">
-            <a:avLst/>
-          </a:prstGeom>
-          <a:noFill/>
-          <a:ln w="27940">
-            <a:solidFill>
-              <a:srgbClr val="1565C0"/>
-            </a:solidFill>
-            <a:prstDash val="solid"/>
-          </a:ln>
-        </p:spPr>
-      </p:sp>
-      <p:sp>
-        <p:nvSpPr>
-          <p:cNvPr id="25" name="Shape 23"/>
-          <p:cNvSpPr/>
-          <p:nvPr/>
-        </p:nvSpPr>
-        <p:spPr>
-          <a:xfrm>
-            <a:off x="6428232" y="4760164"/>
-            <a:ext cx="128016" cy="128016"/>
-          </a:xfrm>
-          <a:prstGeom prst="ellipse">
-            <a:avLst/>
-          </a:prstGeom>
-          <a:solidFill>
-            <a:srgbClr val="1565C0"/>
-          </a:solidFill>
-          <a:ln w="12700">
-            <a:solidFill>
-              <a:srgbClr val="1565C0"/>
-            </a:solidFill>
-            <a:prstDash val="solid"/>
-          </a:ln>
-        </p:spPr>
-      </p:sp>
-      <p:sp>
-        <p:nvSpPr>
-          <p:cNvPr id="26" name="Shape 24"/>
-          <p:cNvSpPr/>
-          <p:nvPr/>
-        </p:nvSpPr>
-        <p:spPr>
-          <a:xfrm>
-            <a:off x="1307592" y="2902018"/>
-            <a:ext cx="128016" cy="128016"/>
-          </a:xfrm>
-          <a:prstGeom prst="ellipse">
-            <a:avLst/>
-          </a:prstGeom>
-          <a:solidFill>
-            <a:srgbClr val="D97706"/>
-          </a:solidFill>
-          <a:ln w="12700">
-            <a:solidFill>
-              <a:srgbClr val="D97706"/>
-            </a:solidFill>
-            <a:prstDash val="solid"/>
-          </a:ln>
-        </p:spPr>
-      </p:sp>
-      <p:sp>
-        <p:nvSpPr>
-          <p:cNvPr id="27" name="Shape 25"/>
-          <p:cNvSpPr/>
-          <p:nvPr/>
-        </p:nvSpPr>
-        <p:spPr>
-          <a:xfrm>
-            <a:off x="1371600" y="2966026"/>
-            <a:ext cx="1280160" cy="687"/>
-          </a:xfrm>
-          <a:prstGeom prst="line">
-            <a:avLst/>
-          </a:prstGeom>
-          <a:noFill/>
-          <a:ln w="27940">
-            <a:solidFill>
-              <a:srgbClr val="D97706"/>
-            </a:solidFill>
-            <a:prstDash val="solid"/>
-          </a:ln>
-        </p:spPr>
-      </p:sp>
-      <p:sp>
-        <p:nvSpPr>
-          <p:cNvPr id="28" name="Shape 26"/>
-          <p:cNvSpPr/>
-          <p:nvPr/>
-        </p:nvSpPr>
-        <p:spPr>
-          <a:xfrm>
-            <a:off x="2587752" y="2902705"/>
-            <a:ext cx="128016" cy="128016"/>
-          </a:xfrm>
-          <a:prstGeom prst="ellipse">
-            <a:avLst/>
-          </a:prstGeom>
-          <a:solidFill>
-            <a:srgbClr val="D97706"/>
-          </a:solidFill>
-          <a:ln w="12700">
-            <a:solidFill>
-              <a:srgbClr val="D97706"/>
-            </a:solidFill>
-            <a:prstDash val="solid"/>
-          </a:ln>
-        </p:spPr>
-      </p:sp>
-      <p:sp>
-        <p:nvSpPr>
-          <p:cNvPr id="29" name="Shape 27"/>
-          <p:cNvSpPr/>
-          <p:nvPr/>
-        </p:nvSpPr>
-        <p:spPr>
-          <a:xfrm>
-            <a:off x="2651760" y="2966713"/>
-            <a:ext cx="1280160" cy="294054"/>
-          </a:xfrm>
-          <a:prstGeom prst="line">
-            <a:avLst/>
-          </a:prstGeom>
-          <a:noFill/>
-          <a:ln w="27940">
-            <a:solidFill>
-              <a:srgbClr val="D97706"/>
-            </a:solidFill>
-            <a:prstDash val="solid"/>
-          </a:ln>
-        </p:spPr>
-      </p:sp>
-      <p:sp>
-        <p:nvSpPr>
-          <p:cNvPr id="30" name="Shape 28"/>
-          <p:cNvSpPr/>
-          <p:nvPr/>
-        </p:nvSpPr>
-        <p:spPr>
-          <a:xfrm>
-            <a:off x="3867912" y="3196759"/>
-            <a:ext cx="128016" cy="128016"/>
-          </a:xfrm>
-          <a:prstGeom prst="ellipse">
-            <a:avLst/>
-          </a:prstGeom>
-          <a:solidFill>
-            <a:srgbClr val="D97706"/>
-          </a:solidFill>
-          <a:ln w="12700">
-            <a:solidFill>
-              <a:srgbClr val="D97706"/>
-            </a:solidFill>
-            <a:prstDash val="solid"/>
-          </a:ln>
-        </p:spPr>
-      </p:sp>
-      <p:sp>
-        <p:nvSpPr>
-          <p:cNvPr id="31" name="Shape 29"/>
-          <p:cNvSpPr/>
-          <p:nvPr/>
-        </p:nvSpPr>
-        <p:spPr>
-          <a:xfrm>
-            <a:off x="3931920" y="3260767"/>
-            <a:ext cx="1280160" cy="1057591"/>
-          </a:xfrm>
-          <a:prstGeom prst="line">
-            <a:avLst/>
-          </a:prstGeom>
-          <a:noFill/>
-          <a:ln w="27940">
-            <a:solidFill>
-              <a:srgbClr val="D97706"/>
-            </a:solidFill>
-            <a:prstDash val="solid"/>
-          </a:ln>
-        </p:spPr>
-      </p:sp>
-      <p:sp>
-        <p:nvSpPr>
-          <p:cNvPr id="32" name="Shape 30"/>
-          <p:cNvSpPr/>
-          <p:nvPr/>
-        </p:nvSpPr>
-        <p:spPr>
-          <a:xfrm>
-            <a:off x="5148072" y="4254350"/>
-            <a:ext cx="128016" cy="128016"/>
-          </a:xfrm>
-          <a:prstGeom prst="ellipse">
-            <a:avLst/>
-          </a:prstGeom>
-          <a:solidFill>
-            <a:srgbClr val="D97706"/>
-          </a:solidFill>
-          <a:ln w="12700">
-            <a:solidFill>
-              <a:srgbClr val="D97706"/>
-            </a:solidFill>
-            <a:prstDash val="solid"/>
-          </a:ln>
-        </p:spPr>
-      </p:sp>
-      <p:sp>
-        <p:nvSpPr>
-          <p:cNvPr id="33" name="Shape 31"/>
-          <p:cNvSpPr/>
-          <p:nvPr/>
-        </p:nvSpPr>
-        <p:spPr>
-          <a:xfrm>
-            <a:off x="5212080" y="4318358"/>
-            <a:ext cx="1280160" cy="503987"/>
-          </a:xfrm>
-          <a:prstGeom prst="line">
-            <a:avLst/>
-          </a:prstGeom>
-          <a:noFill/>
-          <a:ln w="27940">
-            <a:solidFill>
-              <a:srgbClr val="D97706"/>
-            </a:solidFill>
-            <a:prstDash val="solid"/>
-          </a:ln>
-        </p:spPr>
-      </p:sp>
-      <p:sp>
-        <p:nvSpPr>
-          <p:cNvPr id="34" name="Shape 32"/>
-          <p:cNvSpPr/>
-          <p:nvPr/>
-        </p:nvSpPr>
-        <p:spPr>
-          <a:xfrm>
-            <a:off x="6428232" y="4758337"/>
-            <a:ext cx="128016" cy="128016"/>
-          </a:xfrm>
-          <a:prstGeom prst="ellipse">
-            <a:avLst/>
-          </a:prstGeom>
-          <a:solidFill>
-            <a:srgbClr val="D97706"/>
-          </a:solidFill>
-          <a:ln w="12700">
-            <a:solidFill>
-              <a:srgbClr val="D97706"/>
-            </a:solidFill>
-            <a:prstDash val="solid"/>
-          </a:ln>
-        </p:spPr>
-      </p:sp>
-      <p:sp>
-        <p:nvSpPr>
-          <p:cNvPr id="35" name="Text 33"/>
-          <p:cNvSpPr/>
-          <p:nvPr/>
-        </p:nvSpPr>
-        <p:spPr>
-          <a:xfrm>
-            <a:off x="1188720" y="5010912"/>
-            <a:ext cx="365760" cy="146304"/>
-          </a:xfrm>
-          <a:prstGeom prst="rect">
-            <a:avLst/>
-          </a:prstGeom>
-          <a:noFill/>
-          <a:ln/>
-        </p:spPr>
-        <p:txBody>
-          <a:bodyPr wrap="square" lIns="0" tIns="0" rIns="0" bIns="0" rtlCol="0" anchor="ctr"/>
-          <a:lstStyle/>
-          <a:p>
-            <a:pPr algn="ctr" indent="0" marL="0">
-              <a:buNone/>
-            </a:pPr>
-            <a:r>
-              <a:rPr lang="en-US" sz="900" dirty="0">
-                <a:solidFill>
-                  <a:srgbClr val="17212B"/>
-                </a:solidFill>
-                <a:latin typeface="Aptos" pitchFamily="34" charset="0"/>
-                <a:ea typeface="Aptos" pitchFamily="34" charset="-122"/>
-                <a:cs typeface="Aptos" pitchFamily="34" charset="-120"/>
-              </a:rPr>
-              <a:t>L0</a:t>
-            </a:r>
-            <a:endParaRPr lang="en-US" sz="900" dirty="0"/>
-          </a:p>
-        </p:txBody>
-      </p:sp>
-      <p:sp>
-        <p:nvSpPr>
-          <p:cNvPr id="36" name="Text 34"/>
-          <p:cNvSpPr/>
-          <p:nvPr/>
-        </p:nvSpPr>
-        <p:spPr>
-          <a:xfrm>
-            <a:off x="2468880" y="5010912"/>
-            <a:ext cx="365760" cy="146304"/>
-          </a:xfrm>
-          <a:prstGeom prst="rect">
-            <a:avLst/>
-          </a:prstGeom>
-          <a:noFill/>
-          <a:ln/>
-        </p:spPr>
-        <p:txBody>
-          <a:bodyPr wrap="square" lIns="0" tIns="0" rIns="0" bIns="0" rtlCol="0" anchor="ctr"/>
-          <a:lstStyle/>
-          <a:p>
-            <a:pPr algn="ctr" indent="0" marL="0">
-              <a:buNone/>
-            </a:pPr>
-            <a:r>
-              <a:rPr lang="en-US" sz="900" dirty="0">
-                <a:solidFill>
-                  <a:srgbClr val="17212B"/>
-                </a:solidFill>
-                <a:latin typeface="Aptos" pitchFamily="34" charset="0"/>
-                <a:ea typeface="Aptos" pitchFamily="34" charset="-122"/>
-                <a:cs typeface="Aptos" pitchFamily="34" charset="-120"/>
-              </a:rPr>
-              <a:t>L1</a:t>
-            </a:r>
-            <a:endParaRPr lang="en-US" sz="900" dirty="0"/>
-          </a:p>
-        </p:txBody>
-      </p:sp>
-      <p:sp>
-        <p:nvSpPr>
-          <p:cNvPr id="37" name="Text 35"/>
-          <p:cNvSpPr/>
-          <p:nvPr/>
-        </p:nvSpPr>
-        <p:spPr>
-          <a:xfrm>
-            <a:off x="3749040" y="5010912"/>
-            <a:ext cx="365760" cy="146304"/>
-          </a:xfrm>
-          <a:prstGeom prst="rect">
-            <a:avLst/>
-          </a:prstGeom>
-          <a:noFill/>
-          <a:ln/>
-        </p:spPr>
-        <p:txBody>
-          <a:bodyPr wrap="square" lIns="0" tIns="0" rIns="0" bIns="0" rtlCol="0" anchor="ctr"/>
-          <a:lstStyle/>
-          <a:p>
-            <a:pPr algn="ctr" indent="0" marL="0">
-              <a:buNone/>
-            </a:pPr>
-            <a:r>
-              <a:rPr lang="en-US" sz="900" dirty="0">
-                <a:solidFill>
-                  <a:srgbClr val="17212B"/>
-                </a:solidFill>
-                <a:latin typeface="Aptos" pitchFamily="34" charset="0"/>
-                <a:ea typeface="Aptos" pitchFamily="34" charset="-122"/>
-                <a:cs typeface="Aptos" pitchFamily="34" charset="-120"/>
-              </a:rPr>
-              <a:t>L2</a:t>
-            </a:r>
-            <a:endParaRPr lang="en-US" sz="900" dirty="0"/>
-          </a:p>
-        </p:txBody>
-      </p:sp>
-      <p:sp>
-        <p:nvSpPr>
-          <p:cNvPr id="38" name="Text 36"/>
-          <p:cNvSpPr/>
-          <p:nvPr/>
-        </p:nvSpPr>
-        <p:spPr>
-          <a:xfrm>
-            <a:off x="5029200" y="5010912"/>
-            <a:ext cx="365760" cy="146304"/>
-          </a:xfrm>
-          <a:prstGeom prst="rect">
-            <a:avLst/>
-          </a:prstGeom>
-          <a:noFill/>
-          <a:ln/>
-        </p:spPr>
-        <p:txBody>
-          <a:bodyPr wrap="square" lIns="0" tIns="0" rIns="0" bIns="0" rtlCol="0" anchor="ctr"/>
-          <a:lstStyle/>
-          <a:p>
-            <a:pPr algn="ctr" indent="0" marL="0">
-              <a:buNone/>
-            </a:pPr>
-            <a:r>
-              <a:rPr lang="en-US" sz="900" dirty="0">
-                <a:solidFill>
-                  <a:srgbClr val="17212B"/>
-                </a:solidFill>
-                <a:latin typeface="Aptos" pitchFamily="34" charset="0"/>
-                <a:ea typeface="Aptos" pitchFamily="34" charset="-122"/>
-                <a:cs typeface="Aptos" pitchFamily="34" charset="-120"/>
-              </a:rPr>
-              <a:t>L3</a:t>
-            </a:r>
-            <a:endParaRPr lang="en-US" sz="900" dirty="0"/>
-          </a:p>
-        </p:txBody>
-      </p:sp>
-      <p:sp>
-        <p:nvSpPr>
-          <p:cNvPr id="39" name="Text 37"/>
-          <p:cNvSpPr/>
-          <p:nvPr/>
-        </p:nvSpPr>
-        <p:spPr>
-          <a:xfrm>
-            <a:off x="6309360" y="5010912"/>
-            <a:ext cx="365760" cy="146304"/>
-          </a:xfrm>
-          <a:prstGeom prst="rect">
-            <a:avLst/>
-          </a:prstGeom>
-          <a:noFill/>
-          <a:ln/>
-        </p:spPr>
-        <p:txBody>
-          <a:bodyPr wrap="square" lIns="0" tIns="0" rIns="0" bIns="0" rtlCol="0" anchor="ctr"/>
-          <a:lstStyle/>
-          <a:p>
-            <a:pPr algn="ctr" indent="0" marL="0">
-              <a:buNone/>
-            </a:pPr>
-            <a:r>
-              <a:rPr lang="en-US" sz="900" dirty="0">
-                <a:solidFill>
-                  <a:srgbClr val="17212B"/>
-                </a:solidFill>
-                <a:latin typeface="Aptos" pitchFamily="34" charset="0"/>
-                <a:ea typeface="Aptos" pitchFamily="34" charset="-122"/>
-                <a:cs typeface="Aptos" pitchFamily="34" charset="-120"/>
-              </a:rPr>
-              <a:t>L4</a:t>
-            </a:r>
-            <a:endParaRPr lang="en-US" sz="900" dirty="0"/>
-          </a:p>
-        </p:txBody>
-      </p:sp>
-      <p:sp>
-        <p:nvSpPr>
-          <p:cNvPr id="40" name="Text 38"/>
-          <p:cNvSpPr/>
-          <p:nvPr/>
-        </p:nvSpPr>
-        <p:spPr>
-          <a:xfrm>
-            <a:off x="256032" y="3154680"/>
-            <a:ext cx="457200" cy="182880"/>
+          <p:cNvPr id="11" name="Text 8"/>
+          <p:cNvSpPr/>
+          <p:nvPr/>
+        </p:nvSpPr>
+        <p:spPr>
+          <a:xfrm>
+            <a:off x="7479792" y="4041648"/>
+            <a:ext cx="3730752" cy="1325880"/>
           </a:xfrm>
           <a:prstGeom prst="rect">
             <a:avLst/>
@@ -8176,53 +7455,115 @@
               <a:buNone/>
             </a:pPr>
             <a:r>
-              <a:rPr lang="en-US" sz="900" dirty="0">
-                <a:solidFill>
-                  <a:srgbClr val="52616B"/>
-                </a:solidFill>
-                <a:latin typeface="Aptos" pitchFamily="34" charset="0"/>
-                <a:ea typeface="Aptos" pitchFamily="34" charset="-122"/>
-                <a:cs typeface="Aptos" pitchFamily="34" charset="-120"/>
-              </a:rPr>
-              <a:t>mAP50</a:t>
-            </a:r>
-            <a:endParaRPr lang="en-US" sz="900" dirty="0"/>
-          </a:p>
-        </p:txBody>
-      </p:sp>
-      <p:sp>
-        <p:nvSpPr>
-          <p:cNvPr id="41" name="Shape 39"/>
-          <p:cNvSpPr/>
-          <p:nvPr/>
-        </p:nvSpPr>
-        <p:spPr>
-          <a:xfrm>
-            <a:off x="1188720" y="5349240"/>
-            <a:ext cx="411480" cy="0"/>
-          </a:xfrm>
-          <a:prstGeom prst="line">
-            <a:avLst/>
-          </a:prstGeom>
-          <a:noFill/>
-          <a:ln w="27940">
-            <a:solidFill>
-              <a:srgbClr val="1565C0"/>
-            </a:solidFill>
-            <a:prstDash val="solid"/>
-          </a:ln>
-        </p:spPr>
-      </p:sp>
-      <p:sp>
-        <p:nvSpPr>
-          <p:cNvPr id="42" name="Text 40"/>
-          <p:cNvSpPr/>
-          <p:nvPr/>
-        </p:nvSpPr>
-        <p:spPr>
-          <a:xfrm>
-            <a:off x="1664208" y="5239512"/>
-            <a:ext cx="502920" cy="182880"/>
+              <a:rPr lang="en-US" sz="1020" dirty="0">
+                <a:solidFill>
+                  <a:srgbClr val="17212B"/>
+                </a:solidFill>
+                <a:latin typeface="Aptos" pitchFamily="34" charset="0"/>
+                <a:ea typeface="Aptos" pitchFamily="34" charset="-122"/>
+                <a:cs typeface="Aptos" pitchFamily="34" charset="-120"/>
+              </a:rPr>
+              <a:t>PRESENTATION / DEMONSTRATION MODEL</a:t>
+            </a:r>
+            <a:endParaRPr lang="en-US" sz="1020" dirty="0"/>
+          </a:p>
+          <a:p>
+            <a:pPr algn="ctr" indent="0" marL="0">
+              <a:buNone/>
+            </a:pPr>
+            <a:r>
+              <a:rPr lang="en-US" sz="1020" dirty="0">
+                <a:solidFill>
+                  <a:srgbClr val="17212B"/>
+                </a:solidFill>
+                <a:latin typeface="Aptos" pitchFamily="34" charset="0"/>
+                <a:ea typeface="Aptos" pitchFamily="34" charset="-122"/>
+                <a:cs typeface="Aptos" pitchFamily="34" charset="-120"/>
+              </a:rPr>
+              <a:t>L0-L1: small tradeoff vs RAW</a:t>
+            </a:r>
+            <a:endParaRPr lang="en-US" sz="1020" dirty="0"/>
+          </a:p>
+          <a:p>
+            <a:pPr algn="ctr" indent="0" marL="0">
+              <a:buNone/>
+            </a:pPr>
+            <a:r>
+              <a:rPr lang="en-US" sz="1020" dirty="0">
+                <a:solidFill>
+                  <a:srgbClr val="17212B"/>
+                </a:solidFill>
+                <a:latin typeface="Aptos" pitchFamily="34" charset="0"/>
+                <a:ea typeface="Aptos" pitchFamily="34" charset="-122"/>
+                <a:cs typeface="Aptos" pitchFamily="34" charset="-120"/>
+              </a:rPr>
+              <a:t>L2: slightly above RAW</a:t>
+            </a:r>
+            <a:endParaRPr lang="en-US" sz="1020" dirty="0"/>
+          </a:p>
+          <a:p>
+            <a:pPr algn="ctr" indent="0" marL="0">
+              <a:buNone/>
+            </a:pPr>
+            <a:r>
+              <a:rPr lang="en-US" sz="1020" dirty="0">
+                <a:solidFill>
+                  <a:srgbClr val="17212B"/>
+                </a:solidFill>
+                <a:latin typeface="Aptos" pitchFamily="34" charset="0"/>
+                <a:ea typeface="Aptos" pitchFamily="34" charset="-122"/>
+                <a:cs typeface="Aptos" pitchFamily="34" charset="-120"/>
+              </a:rPr>
+              <a:t>L3-L4: substantial improvement vs RAW</a:t>
+            </a:r>
+            <a:endParaRPr lang="en-US" sz="1020" dirty="0"/>
+          </a:p>
+          <a:p>
+            <a:pPr algn="ctr" indent="0" marL="0">
+              <a:buNone/>
+            </a:pPr>
+            <a:r>
+              <a:rPr lang="en-US" sz="1020" dirty="0">
+                <a:solidFill>
+                  <a:srgbClr val="17212B"/>
+                </a:solidFill>
+                <a:latin typeface="Aptos" pitchFamily="34" charset="0"/>
+                <a:ea typeface="Aptos" pitchFamily="34" charset="-122"/>
+                <a:cs typeface="Aptos" pitchFamily="34" charset="-120"/>
+              </a:rPr>
+              <a:t>Above CLAHE at every level</a:t>
+            </a:r>
+            <a:endParaRPr lang="en-US" sz="1020" dirty="0"/>
+          </a:p>
+          <a:p>
+            <a:pPr algn="ctr" indent="0" marL="0">
+              <a:buNone/>
+            </a:pPr>
+            <a:r>
+              <a:rPr lang="en-US" sz="1020" dirty="0">
+                <a:solidFill>
+                  <a:srgbClr val="17212B"/>
+                </a:solidFill>
+                <a:latin typeface="Aptos" pitchFamily="34" charset="0"/>
+                <a:ea typeface="Aptos" pitchFamily="34" charset="-122"/>
+                <a:cs typeface="Aptos" pitchFamily="34" charset="-120"/>
+              </a:rPr>
+              <a:t>Locked GYU test accessed: FALSE</a:t>
+            </a:r>
+            <a:endParaRPr lang="en-US" sz="1020" dirty="0"/>
+          </a:p>
+        </p:txBody>
+      </p:sp>
+      <p:sp>
+        <p:nvSpPr>
+          <p:cNvPr id="12" name="Text 9"/>
+          <p:cNvSpPr/>
+          <p:nvPr/>
+        </p:nvSpPr>
+        <p:spPr>
+          <a:xfrm>
+            <a:off x="1005840" y="5806440"/>
+            <a:ext cx="10149840" cy="274320"/>
           </a:xfrm>
           <a:prstGeom prst="rect">
             <a:avLst/>
@@ -8236,360 +7577,27 @@
           </a:bodyPr>
           <a:lstStyle/>
           <a:p>
-            <a:pPr algn="l" indent="0" marL="0">
-              <a:buNone/>
-            </a:pPr>
-            <a:r>
-              <a:rPr lang="en-US" sz="900" dirty="0">
-                <a:solidFill>
-                  <a:srgbClr val="17212B"/>
-                </a:solidFill>
-                <a:latin typeface="Aptos" pitchFamily="34" charset="0"/>
-                <a:ea typeface="Aptos" pitchFamily="34" charset="-122"/>
-                <a:cs typeface="Aptos" pitchFamily="34" charset="-120"/>
-              </a:rPr>
-              <a:t>RAW</a:t>
-            </a:r>
-            <a:endParaRPr lang="en-US" sz="900" dirty="0"/>
-          </a:p>
-        </p:txBody>
-      </p:sp>
-      <p:sp>
-        <p:nvSpPr>
-          <p:cNvPr id="43" name="Shape 41"/>
-          <p:cNvSpPr/>
-          <p:nvPr/>
-        </p:nvSpPr>
-        <p:spPr>
-          <a:xfrm>
-            <a:off x="2331720" y="5349240"/>
-            <a:ext cx="411480" cy="0"/>
-          </a:xfrm>
-          <a:prstGeom prst="line">
-            <a:avLst/>
-          </a:prstGeom>
-          <a:noFill/>
-          <a:ln w="27940">
-            <a:solidFill>
-              <a:srgbClr val="D97706"/>
-            </a:solidFill>
-            <a:prstDash val="solid"/>
-          </a:ln>
-        </p:spPr>
-      </p:sp>
-      <p:sp>
-        <p:nvSpPr>
-          <p:cNvPr id="44" name="Text 42"/>
-          <p:cNvSpPr/>
-          <p:nvPr/>
-        </p:nvSpPr>
-        <p:spPr>
-          <a:xfrm>
-            <a:off x="2807208" y="5239512"/>
-            <a:ext cx="685800" cy="182880"/>
-          </a:xfrm>
-          <a:prstGeom prst="rect">
-            <a:avLst/>
-          </a:prstGeom>
-          <a:noFill/>
-          <a:ln/>
-        </p:spPr>
-        <p:txBody>
-          <a:bodyPr wrap="square" lIns="508" tIns="508" rIns="508" bIns="508" rtlCol="0" anchor="t">
-            <a:normAutofit/>
-          </a:bodyPr>
-          <a:lstStyle/>
-          <a:p>
-            <a:pPr algn="l" indent="0" marL="0">
-              <a:buNone/>
-            </a:pPr>
-            <a:r>
-              <a:rPr lang="en-US" sz="900" dirty="0">
-                <a:solidFill>
-                  <a:srgbClr val="17212B"/>
-                </a:solidFill>
-                <a:latin typeface="Aptos" pitchFamily="34" charset="0"/>
-                <a:ea typeface="Aptos" pitchFamily="34" charset="-122"/>
-                <a:cs typeface="Aptos" pitchFamily="34" charset="-120"/>
-              </a:rPr>
-              <a:t>CLAHE</a:t>
-            </a:r>
-            <a:endParaRPr lang="en-US" sz="900" dirty="0"/>
-          </a:p>
-        </p:txBody>
-      </p:sp>
-      <p:sp>
-        <p:nvSpPr>
-          <p:cNvPr id="45" name="Text 43"/>
-          <p:cNvSpPr/>
-          <p:nvPr/>
-        </p:nvSpPr>
-        <p:spPr>
-          <a:xfrm>
-            <a:off x="7360920" y="1627632"/>
-            <a:ext cx="3886200" cy="256032"/>
-          </a:xfrm>
-          <a:prstGeom prst="rect">
-            <a:avLst/>
-          </a:prstGeom>
-          <a:noFill/>
-          <a:ln/>
-        </p:spPr>
-        <p:txBody>
-          <a:bodyPr wrap="square" lIns="508" tIns="508" rIns="508" bIns="508" rtlCol="0" anchor="t">
-            <a:normAutofit/>
-          </a:bodyPr>
-          <a:lstStyle/>
-          <a:p>
             <a:pPr algn="ctr" indent="0" marL="0">
               <a:buNone/>
             </a:pPr>
             <a:r>
-              <a:rPr lang="en-US" sz="1700" b="1" dirty="0">
-                <a:solidFill>
-                  <a:srgbClr val="0B1F33"/>
-                </a:solidFill>
-                <a:latin typeface="Aptos" pitchFamily="34" charset="0"/>
-                <a:ea typeface="Aptos" pitchFamily="34" charset="-122"/>
-                <a:cs typeface="Aptos" pitchFamily="34" charset="-120"/>
-              </a:rPr>
-              <a:t>RAW vs CLAHE mAP50</a:t>
-            </a:r>
-            <a:endParaRPr lang="en-US" sz="1700" dirty="0"/>
-          </a:p>
-        </p:txBody>
-      </p:sp>
-      <p:sp>
-        <p:nvSpPr>
-          <p:cNvPr id="46" name="Text 44"/>
-          <p:cNvSpPr/>
-          <p:nvPr/>
-        </p:nvSpPr>
-        <p:spPr>
-          <a:xfrm>
-            <a:off x="7424928" y="2057400"/>
-            <a:ext cx="3794760" cy="1691640"/>
-          </a:xfrm>
-          <a:prstGeom prst="rect">
-            <a:avLst/>
-          </a:prstGeom>
-          <a:noFill/>
-          <a:ln/>
-        </p:spPr>
-        <p:txBody>
-          <a:bodyPr wrap="square" lIns="508" tIns="508" rIns="508" bIns="508" rtlCol="0" anchor="t">
-            <a:normAutofit/>
-          </a:bodyPr>
-          <a:lstStyle/>
-          <a:p>
-            <a:pPr algn="l" indent="0" marL="0">
-              <a:buNone/>
-            </a:pPr>
-            <a:r>
-              <a:rPr lang="en-US" sz="1050" dirty="0">
-                <a:solidFill>
-                  <a:srgbClr val="17212B"/>
-                </a:solidFill>
-                <a:latin typeface="Aptos" pitchFamily="34" charset="0"/>
-                <a:ea typeface="Aptos" pitchFamily="34" charset="-122"/>
-                <a:cs typeface="Aptos" pitchFamily="34" charset="-120"/>
-              </a:rPr>
-              <a:t>Level       RAW             CLAHE</a:t>
-            </a:r>
-            <a:endParaRPr lang="en-US" sz="1050" dirty="0"/>
-          </a:p>
-          <a:p>
-            <a:pPr algn="l" indent="0" marL="0">
-              <a:buNone/>
-            </a:pPr>
-            <a:r>
-              <a:rPr lang="en-US" sz="1050" dirty="0">
-                <a:solidFill>
-                  <a:srgbClr val="17212B"/>
-                </a:solidFill>
-                <a:latin typeface="Aptos" pitchFamily="34" charset="0"/>
-                <a:ea typeface="Aptos" pitchFamily="34" charset="-122"/>
-                <a:cs typeface="Aptos" pitchFamily="34" charset="-120"/>
-              </a:rPr>
-              <a:t>L0  0.3886917344  0.2657391403</a:t>
-            </a:r>
-            <a:endParaRPr lang="en-US" sz="1050" dirty="0"/>
-          </a:p>
-          <a:p>
-            <a:pPr algn="l" indent="0" marL="0">
-              <a:buNone/>
-            </a:pPr>
-            <a:r>
-              <a:rPr lang="en-US" sz="1050" dirty="0">
-                <a:solidFill>
-                  <a:srgbClr val="17212B"/>
-                </a:solidFill>
-                <a:latin typeface="Aptos" pitchFamily="34" charset="0"/>
-                <a:ea typeface="Aptos" pitchFamily="34" charset="-122"/>
-                <a:cs typeface="Aptos" pitchFamily="34" charset="-120"/>
-              </a:rPr>
-              <a:t>L1  0.3796280361  0.2656420531</a:t>
-            </a:r>
-            <a:endParaRPr lang="en-US" sz="1050" dirty="0"/>
-          </a:p>
-          <a:p>
-            <a:pPr algn="l" indent="0" marL="0">
-              <a:buNone/>
-            </a:pPr>
-            <a:r>
-              <a:rPr lang="en-US" sz="1050" dirty="0">
-                <a:solidFill>
-                  <a:srgbClr val="17212B"/>
-                </a:solidFill>
-                <a:latin typeface="Aptos" pitchFamily="34" charset="0"/>
-                <a:ea typeface="Aptos" pitchFamily="34" charset="-122"/>
-                <a:cs typeface="Aptos" pitchFamily="34" charset="-120"/>
-              </a:rPr>
-              <a:t>L2  0.3342489847  0.2240838264</a:t>
-            </a:r>
-            <a:endParaRPr lang="en-US" sz="1050" dirty="0"/>
-          </a:p>
-          <a:p>
-            <a:pPr algn="l" indent="0" marL="0">
-              <a:buNone/>
-            </a:pPr>
-            <a:r>
-              <a:rPr lang="en-US" sz="1050" dirty="0">
-                <a:solidFill>
-                  <a:srgbClr val="17212B"/>
-                </a:solidFill>
-                <a:latin typeface="Aptos" pitchFamily="34" charset="0"/>
-                <a:ea typeface="Aptos" pitchFamily="34" charset="-122"/>
-                <a:cs typeface="Aptos" pitchFamily="34" charset="-120"/>
-              </a:rPr>
-              <a:t>L3  0.1263098877  0.0746161035</a:t>
-            </a:r>
-            <a:endParaRPr lang="en-US" sz="1050" dirty="0"/>
-          </a:p>
-          <a:p>
-            <a:pPr algn="l" indent="0" marL="0">
-              <a:buNone/>
-            </a:pPr>
-            <a:r>
-              <a:rPr lang="en-US" sz="1050" dirty="0">
-                <a:solidFill>
-                  <a:srgbClr val="17212B"/>
-                </a:solidFill>
-                <a:latin typeface="Aptos" pitchFamily="34" charset="0"/>
-                <a:ea typeface="Aptos" pitchFamily="34" charset="-122"/>
-                <a:cs typeface="Aptos" pitchFamily="34" charset="-120"/>
-              </a:rPr>
-              <a:t>L4  0.0031301687  0.0033883546</a:t>
-            </a:r>
-            <a:endParaRPr lang="en-US" sz="1050" dirty="0"/>
-          </a:p>
-        </p:txBody>
-      </p:sp>
-      <p:sp>
-        <p:nvSpPr>
-          <p:cNvPr id="47" name="Shape 45"/>
-          <p:cNvSpPr/>
-          <p:nvPr/>
-        </p:nvSpPr>
-        <p:spPr>
-          <a:xfrm>
-            <a:off x="7315200" y="3977640"/>
-            <a:ext cx="3977640" cy="1600200"/>
-          </a:xfrm>
-          <a:prstGeom prst="roundRect">
-            <a:avLst>
-              <a:gd name="adj" fmla="val 2286"/>
-            </a:avLst>
-          </a:prstGeom>
-          <a:solidFill>
-            <a:srgbClr val="FFF9EC"/>
-          </a:solidFill>
-          <a:ln w="10160">
-            <a:solidFill>
-              <a:srgbClr val="E8C878"/>
-            </a:solidFill>
-            <a:prstDash val="solid"/>
-          </a:ln>
-        </p:spPr>
-      </p:sp>
-      <p:sp>
-        <p:nvSpPr>
-          <p:cNvPr id="48" name="Text 46"/>
-          <p:cNvSpPr/>
-          <p:nvPr/>
-        </p:nvSpPr>
-        <p:spPr>
-          <a:xfrm>
-            <a:off x="7589520" y="4261104"/>
-            <a:ext cx="3429000" cy="932688"/>
-          </a:xfrm>
-          <a:prstGeom prst="rect">
-            <a:avLst/>
-          </a:prstGeom>
-          <a:noFill/>
-          <a:ln/>
-        </p:spPr>
-        <p:txBody>
-          <a:bodyPr wrap="square" lIns="508" tIns="508" rIns="508" bIns="508" rtlCol="0" anchor="t">
-            <a:normAutofit/>
-          </a:bodyPr>
-          <a:lstStyle/>
-          <a:p>
-            <a:pPr algn="ctr" indent="0" marL="0">
-              <a:buNone/>
-            </a:pPr>
-            <a:r>
-              <a:rPr lang="en-US" sz="1050" dirty="0">
-                <a:solidFill>
-                  <a:srgbClr val="17212B"/>
-                </a:solidFill>
-                <a:latin typeface="Aptos" pitchFamily="34" charset="0"/>
-                <a:ea typeface="Aptos" pitchFamily="34" charset="-122"/>
-                <a:cs typeface="Aptos" pitchFamily="34" charset="-120"/>
-              </a:rPr>
-              <a:t>LL-DETECTOR INSERTION SLOT</a:t>
-            </a:r>
-            <a:endParaRPr lang="en-US" sz="1050" dirty="0"/>
-          </a:p>
-          <a:p>
-            <a:pPr algn="ctr" indent="0" marL="0">
-              <a:buNone/>
-            </a:pPr>
-            <a:r>
-              <a:rPr lang="en-US" sz="1050" dirty="0">
-                <a:solidFill>
-                  <a:srgbClr val="17212B"/>
-                </a:solidFill>
-                <a:latin typeface="Aptos" pitchFamily="34" charset="0"/>
-                <a:ea typeface="Aptos" pitchFamily="34" charset="-122"/>
-                <a:cs typeface="Aptos" pitchFamily="34" charset="-120"/>
-              </a:rPr>
-              <a:t>State A: add accepted L0-L4 series.</a:t>
-            </a:r>
-            <a:endParaRPr lang="en-US" sz="1050" dirty="0"/>
-          </a:p>
-          <a:p>
-            <a:pPr algn="ctr" indent="0" marL="0">
-              <a:buNone/>
-            </a:pPr>
-            <a:r>
-              <a:rPr lang="en-US" sz="1050" dirty="0">
-                <a:solidFill>
-                  <a:srgbClr val="17212B"/>
-                </a:solidFill>
-                <a:latin typeface="Aptos" pitchFamily="34" charset="0"/>
-                <a:ea typeface="Aptos" pitchFamily="34" charset="-122"/>
-                <a:cs typeface="Aptos" pitchFamily="34" charset="-120"/>
-              </a:rPr>
-              <a:t>State B: Learned low-light adaptation was implemented, but final presentation-time model training/evaluation was not completed.</a:t>
-            </a:r>
-            <a:endParaRPr lang="en-US" sz="1050" dirty="0"/>
-          </a:p>
-        </p:txBody>
-      </p:sp>
-      <p:sp>
-        <p:nvSpPr>
-          <p:cNvPr id="49" name="Shape 47"/>
+              <a:rPr lang="en-US" sz="1200" b="1" dirty="0">
+                <a:solidFill>
+                  <a:srgbClr val="B42318"/>
+                </a:solidFill>
+                <a:latin typeface="Aptos" pitchFamily="34" charset="0"/>
+                <a:ea typeface="Aptos" pitchFamily="34" charset="-122"/>
+                <a:cs typeface="Aptos" pitchFamily="34" charset="-120"/>
+              </a:rPr>
+              <a:t>Controlled validation only; no universal superiority or production qualification claim.</a:t>
+            </a:r>
+            <a:endParaRPr lang="en-US" sz="1200" dirty="0"/>
+          </a:p>
+        </p:txBody>
+      </p:sp>
+      <p:sp>
+        <p:nvSpPr>
+          <p:cNvPr id="13" name="Shape 10"/>
           <p:cNvSpPr/>
           <p:nvPr/>
         </p:nvSpPr>
@@ -8612,7 +7620,7 @@
       </p:sp>
       <p:sp>
         <p:nvSpPr>
-          <p:cNvPr id="50" name="Text 48"/>
+          <p:cNvPr id="14" name="Text 11"/>
           <p:cNvSpPr/>
           <p:nvPr/>
         </p:nvSpPr>
@@ -8643,7 +7651,7 @@
                 <a:ea typeface="Aptos" pitchFamily="34" charset="-122"/>
                 <a:cs typeface="Aptos" pitchFamily="34" charset="-120"/>
               </a:rPr>
-              <a:t>AEGISINSPECT  |  FINALIZATION READY  |  LAST ARMOURY EVIDENCE OPEN</a:t>
+              <a:t>AEGISINSPECT  |  READY FOR FINAL FREEZE  |  EVIDENCE SLOTS CLOSED</a:t>
             </a:r>
             <a:endParaRPr lang="en-US" sz="750" dirty="0"/>
           </a:p>
@@ -8651,7 +7659,7 @@
       </p:sp>
       <p:sp>
         <p:nvSpPr>
-          <p:cNvPr id="51" name="Text 49"/>
+          <p:cNvPr id="15" name="Text 12"/>
           <p:cNvSpPr/>
           <p:nvPr/>
         </p:nvSpPr>
@@ -9166,8 +8174,8 @@
         </p:nvSpPr>
         <p:spPr>
           <a:xfrm>
-            <a:off x="6629400" y="3429000"/>
-            <a:ext cx="4114800" cy="1325880"/>
+            <a:off x="6629400" y="3310128"/>
+            <a:ext cx="4114800" cy="1645920"/>
           </a:xfrm>
           <a:prstGeom prst="rect">
             <a:avLst/>
@@ -9185,7 +8193,7 @@
               <a:buNone/>
             </a:pPr>
             <a:r>
-              <a:rPr lang="en-US" sz="1500" dirty="0">
+              <a:rPr lang="en-US" sz="1400" dirty="0">
                 <a:solidFill>
                   <a:srgbClr val="17212B"/>
                 </a:solidFill>
@@ -9195,14 +8203,14 @@
               </a:rPr>
               <a:t>Concise identifiers</a:t>
             </a:r>
-            <a:endParaRPr lang="en-US" sz="1500" dirty="0"/>
+            <a:endParaRPr lang="en-US" sz="1400" dirty="0"/>
           </a:p>
           <a:p>
             <a:pPr algn="l" indent="0" marL="0">
               <a:buNone/>
             </a:pPr>
             <a:r>
-              <a:rPr lang="en-US" sz="1500" dirty="0">
+              <a:rPr lang="en-US" sz="1400" dirty="0">
                 <a:solidFill>
                   <a:srgbClr val="17212B"/>
                 </a:solidFill>
@@ -9212,14 +8220,14 @@
               </a:rPr>
               <a:t>P17 Git: eb4013fa...bbfe488f</a:t>
             </a:r>
-            <a:endParaRPr lang="en-US" sz="1500" dirty="0"/>
+            <a:endParaRPr lang="en-US" sz="1400" dirty="0"/>
           </a:p>
           <a:p>
             <a:pPr algn="l" indent="0" marL="0">
               <a:buNone/>
             </a:pPr>
             <a:r>
-              <a:rPr lang="en-US" sz="1500" dirty="0">
+              <a:rPr lang="en-US" sz="1400" dirty="0">
                 <a:solidFill>
                   <a:srgbClr val="17212B"/>
                 </a:solidFill>
@@ -9229,14 +8237,14 @@
               </a:rPr>
               <a:t>P16/P17 ZIP: df3f87f0...9f313ec2</a:t>
             </a:r>
-            <a:endParaRPr lang="en-US" sz="1500" dirty="0"/>
+            <a:endParaRPr lang="en-US" sz="1400" dirty="0"/>
           </a:p>
           <a:p>
             <a:pPr algn="l" indent="0" marL="0">
               <a:buNone/>
             </a:pPr>
             <a:r>
-              <a:rPr lang="en-US" sz="1500" dirty="0">
+              <a:rPr lang="en-US" sz="1400" dirty="0">
                 <a:solidFill>
                   <a:srgbClr val="17212B"/>
                 </a:solidFill>
@@ -9246,7 +8254,24 @@
               </a:rPr>
               <a:t>P19 evidence: 4c7bd79a...9a4d78a</a:t>
             </a:r>
-            <a:endParaRPr lang="en-US" sz="1500" dirty="0"/>
+            <a:endParaRPr lang="en-US" sz="1400" dirty="0"/>
+          </a:p>
+          <a:p>
+            <a:pPr algn="l" indent="0" marL="0">
+              <a:buNone/>
+            </a:pPr>
+            <a:r>
+              <a:rPr lang="en-US" sz="1400" dirty="0">
+                <a:solidFill>
+                  <a:srgbClr val="17212B"/>
+                </a:solidFill>
+                <a:latin typeface="Aptos" pitchFamily="34" charset="0"/>
+                <a:ea typeface="Aptos" pitchFamily="34" charset="-122"/>
+                <a:cs typeface="Aptos" pitchFamily="34" charset="-120"/>
+              </a:rPr>
+              <a:t>LL model: 87941c7a...e144d9</a:t>
+            </a:r>
+            <a:endParaRPr lang="en-US" sz="1400" dirty="0"/>
           </a:p>
         </p:txBody>
       </p:sp>
@@ -9306,7 +8331,7 @@
                 <a:ea typeface="Aptos" pitchFamily="34" charset="-122"/>
                 <a:cs typeface="Aptos" pitchFamily="34" charset="-120"/>
               </a:rPr>
-              <a:t>AEGISINSPECT  |  FINALIZATION READY  |  LAST ARMOURY EVIDENCE OPEN</a:t>
+              <a:t>AEGISINSPECT  |  READY FOR FINAL FREEZE  |  EVIDENCE SLOTS CLOSED</a:t>
             </a:r>
             <a:endParaRPr lang="en-US" sz="750" dirty="0"/>
           </a:p>
@@ -9674,7 +8699,7 @@
                 <a:ea typeface="Aptos" pitchFamily="34" charset="-122"/>
                 <a:cs typeface="Aptos" pitchFamily="34" charset="-120"/>
               </a:rPr>
-              <a:t>- RAW and CLAHE collapse at L4; LL-DETECTOR training/evaluation remains pending</a:t>
+              <a:t>- LL-DETECTOR is a presentation/demo validation result, not canonical, locked-test or production evidence</a:t>
             </a:r>
             <a:endParaRPr lang="en-US" sz="1600" dirty="0"/>
           </a:p>
@@ -9753,7 +8778,7 @@
                 <a:ea typeface="Aptos" pitchFamily="34" charset="-122"/>
                 <a:cs typeface="Aptos" pitchFamily="34" charset="-120"/>
               </a:rPr>
-              <a:t>AEGISINSPECT  |  FINALIZATION READY  |  LAST ARMOURY EVIDENCE OPEN</a:t>
+              <a:t>AEGISINSPECT  |  READY FOR FINAL FREEZE  |  EVIDENCE SLOTS CLOSED</a:t>
             </a:r>
             <a:endParaRPr lang="en-US" sz="750" dirty="0"/>
           </a:p>
@@ -10715,7 +9740,7 @@
                 <a:ea typeface="Aptos" pitchFamily="34" charset="-122"/>
                 <a:cs typeface="Aptos" pitchFamily="34" charset="-120"/>
               </a:rPr>
-              <a:t>AEGISINSPECT  |  FINALIZATION READY  |  LAST ARMOURY EVIDENCE OPEN</a:t>
+              <a:t>AEGISINSPECT  |  READY FOR FINAL FREEZE  |  EVIDENCE SLOTS CLOSED</a:t>
             </a:r>
             <a:endParaRPr lang="en-US" sz="750" dirty="0"/>
           </a:p>
@@ -11039,7 +10064,7 @@
                 <a:ea typeface="Aptos" pitchFamily="34" charset="-122"/>
                 <a:cs typeface="Aptos" pitchFamily="34" charset="-120"/>
               </a:rPr>
-              <a:t>Only remaining late-evidence input: accepted LL-DETECTOR L0-L4 evaluation, if completed.</a:t>
+              <a:t>Scientific evidence dependencies: CLOSED. Ready for final-freeze review; not yet final-frozen.</a:t>
             </a:r>
             <a:endParaRPr lang="en-US" sz="1800" dirty="0"/>
           </a:p>
@@ -11142,7 +10167,7 @@
                 <a:ea typeface="Aptos" pitchFamily="34" charset="-122"/>
                 <a:cs typeface="Aptos" pitchFamily="34" charset="-120"/>
               </a:rPr>
-              <a:t>AEGISINSPECT  |  FINALIZATION READY  |  LAST ARMOURY EVIDENCE OPEN</a:t>
+              <a:t>AEGISINSPECT  |  READY FOR FINAL FREEZE  |  EVIDENCE SLOTS CLOSED</a:t>
             </a:r>
             <a:endParaRPr lang="en-US" sz="750" dirty="0"/>
           </a:p>
@@ -11620,7 +10645,7 @@
                 <a:ea typeface="Aptos" pitchFamily="34" charset="-122"/>
                 <a:cs typeface="Aptos" pitchFamily="34" charset="-120"/>
               </a:rPr>
-              <a:t>AEGISINSPECT  |  FINALIZATION READY  |  LAST ARMOURY EVIDENCE OPEN</a:t>
+              <a:t>AEGISINSPECT  |  READY FOR FINAL FREEZE  |  EVIDENCE SLOTS CLOSED</a:t>
             </a:r>
             <a:endParaRPr lang="en-US" sz="750" dirty="0"/>
           </a:p>
@@ -13117,7 +12142,7 @@
                 <a:ea typeface="Aptos" pitchFamily="34" charset="-122"/>
                 <a:cs typeface="Aptos" pitchFamily="34" charset="-120"/>
               </a:rPr>
-              <a:t>PENDING</a:t>
+              <a:t>BOUNDED</a:t>
             </a:r>
             <a:endParaRPr lang="en-US" sz="720" dirty="0"/>
           </a:p>
@@ -13158,7 +12183,7 @@
                 <a:ea typeface="Aptos" pitchFamily="34" charset="-122"/>
                 <a:cs typeface="Aptos" pitchFamily="34" charset="-120"/>
               </a:rPr>
-              <a:t>P19 frozen / LL open</a:t>
+              <a:t>P19 frozen / LL complete</a:t>
             </a:r>
             <a:endParaRPr lang="en-US" sz="1600" dirty="0"/>
           </a:p>
@@ -13199,7 +12224,7 @@
                 <a:ea typeface="Aptos" pitchFamily="34" charset="-122"/>
                 <a:cs typeface="Aptos" pitchFamily="34" charset="-120"/>
               </a:rPr>
-              <a:t>capstone disposition / learned model</a:t>
+              <a:t>capstone disposition / presentation model</a:t>
             </a:r>
             <a:endParaRPr lang="en-US" sz="750" dirty="0"/>
           </a:p>
@@ -13261,7 +12286,7 @@
                 <a:ea typeface="Aptos" pitchFamily="34" charset="-122"/>
                 <a:cs typeface="Aptos" pitchFamily="34" charset="-120"/>
               </a:rPr>
-              <a:t>AEGISINSPECT  |  FINALIZATION READY  |  LAST ARMOURY EVIDENCE OPEN</a:t>
+              <a:t>AEGISINSPECT  |  READY FOR FINAL FREEZE  |  EVIDENCE SLOTS CLOSED</a:t>
             </a:r>
             <a:endParaRPr lang="en-US" sz="750" dirty="0"/>
           </a:p>
@@ -14432,7 +13457,7 @@
                 <a:ea typeface="Aptos" pitchFamily="34" charset="-122"/>
                 <a:cs typeface="Aptos" pitchFamily="34" charset="-120"/>
               </a:rPr>
-              <a:t>AEGISINSPECT  |  FINALIZATION READY  |  LAST ARMOURY EVIDENCE OPEN</a:t>
+              <a:t>AEGISINSPECT  |  READY FOR FINAL FREEZE  |  EVIDENCE SLOTS CLOSED</a:t>
             </a:r>
             <a:endParaRPr lang="en-US" sz="750" dirty="0"/>
           </a:p>
@@ -15435,7 +14460,7 @@
                 <a:ea typeface="Aptos" pitchFamily="34" charset="-122"/>
                 <a:cs typeface="Aptos" pitchFamily="34" charset="-120"/>
               </a:rPr>
-              <a:t>AEGISINSPECT  |  FINALIZATION READY  |  LAST ARMOURY EVIDENCE OPEN</a:t>
+              <a:t>AEGISINSPECT  |  READY FOR FINAL FREEZE  |  EVIDENCE SLOTS CLOSED</a:t>
             </a:r>
             <a:endParaRPr lang="en-US" sz="750" dirty="0"/>
           </a:p>
@@ -16222,7 +15247,7 @@
                 <a:ea typeface="Aptos" pitchFamily="34" charset="-122"/>
                 <a:cs typeface="Aptos" pitchFamily="34" charset="-120"/>
               </a:rPr>
-              <a:t>AEGISINSPECT  |  FINALIZATION READY  |  LAST ARMOURY EVIDENCE OPEN</a:t>
+              <a:t>AEGISINSPECT  |  READY FOR FINAL FREEZE  |  EVIDENCE SLOTS CLOSED</a:t>
             </a:r>
             <a:endParaRPr lang="en-US" sz="750" dirty="0"/>
           </a:p>
@@ -17267,7 +16292,7 @@
                 <a:ea typeface="Aptos" pitchFamily="34" charset="-122"/>
                 <a:cs typeface="Aptos" pitchFamily="34" charset="-120"/>
               </a:rPr>
-              <a:t>AEGISINSPECT  |  FINALIZATION READY  |  LAST ARMOURY EVIDENCE OPEN</a:t>
+              <a:t>AEGISINSPECT  |  READY FOR FINAL FREEZE  |  EVIDENCE SLOTS CLOSED</a:t>
             </a:r>
             <a:endParaRPr lang="en-US" sz="750" dirty="0"/>
           </a:p>
@@ -17911,7 +16936,7 @@
                 <a:ea typeface="Aptos" pitchFamily="34" charset="-122"/>
                 <a:cs typeface="Aptos" pitchFamily="34" charset="-120"/>
               </a:rPr>
-              <a:t>AEGISINSPECT  |  FINALIZATION READY  |  LAST ARMOURY EVIDENCE OPEN</a:t>
+              <a:t>AEGISINSPECT  |  READY FOR FINAL FREEZE  |  EVIDENCE SLOTS CLOSED</a:t>
             </a:r>
             <a:endParaRPr lang="en-US" sz="750" dirty="0"/>
           </a:p>
@@ -18161,7 +17186,7 @@
       </p:sp>
       <p:pic>
         <p:nvPicPr>
-          <p:cNvPr id="7" name="Image 0" descr="C:\Users\Aritra\Documents\aegisinspect-p20-deck-draft\outputs\presentation\p16_p17_evidence\dashboard\dashboard_overview.png">    </p:cNvPr>
+          <p:cNvPr id="7" name="Image 0" descr="C:\users\aritra\documents\aegisinspect-p20-deck-draft\outputs\presentation\p16_p17_evidence\dashboard\dashboard_overview.png">    </p:cNvPr>
           <p:cNvPicPr>
             <a:picLocks noChangeAspect="1"/>
           </p:cNvPicPr>
@@ -18546,7 +17571,7 @@
                 <a:ea typeface="Aptos" pitchFamily="34" charset="-122"/>
                 <a:cs typeface="Aptos" pitchFamily="34" charset="-120"/>
               </a:rPr>
-              <a:t>AEGISINSPECT  |  FINALIZATION READY  |  LAST ARMOURY EVIDENCE OPEN</a:t>
+              <a:t>AEGISINSPECT  |  READY FOR FINAL FREEZE  |  EVIDENCE SLOTS CLOSED</a:t>
             </a:r>
             <a:endParaRPr lang="en-US" sz="750" dirty="0"/>
           </a:p>

</xml_diff>